<commit_message>
vault backup: 2025-12-08 01:00:21
</commit_message>
<xml_diff>
--- a/知识荟萃/Resume/个人简历 -3.0.pptx
+++ b/知识荟萃/Resume/个人简历 -3.0.pptx
@@ -121,22 +121,22 @@
     </p:ext>
     <p:ext uri="{EFAFB233-063F-42B5-8137-9DF3F51BA10A}">
       <p15:sldGuideLst xmlns:p15="http://schemas.microsoft.com/office/powerpoint/2012/main">
-        <p15:guide id="1" orient="horz" pos="3091" userDrawn="1">
+        <p15:guide id="1" orient="horz" pos="3045" userDrawn="1">
           <p15:clr>
             <a:srgbClr val="A4A3A4"/>
           </p15:clr>
         </p15:guide>
-        <p15:guide id="2" pos="2110" userDrawn="1">
+        <p15:guide id="2" pos="2114" userDrawn="1">
           <p15:clr>
             <a:srgbClr val="A4A3A4"/>
           </p15:clr>
         </p15:guide>
-        <p15:guide id="3" pos="4203" userDrawn="1">
+        <p15:guide id="3" pos="4170" userDrawn="1">
           <p15:clr>
             <a:srgbClr val="A4A3A4"/>
           </p15:clr>
         </p15:guide>
-        <p15:guide id="4" pos="130" userDrawn="1">
+        <p15:guide id="4" pos="118" userDrawn="1">
           <p15:clr>
             <a:srgbClr val="A4A3A4"/>
           </p15:clr>
@@ -3230,10 +3230,10 @@
         </p:nvGrpSpPr>
         <p:grpSpPr>
           <a:xfrm>
-            <a:off x="90696" y="1188303"/>
-            <a:ext cx="6471811" cy="282499"/>
+            <a:off x="90805" y="1188085"/>
+            <a:ext cx="6468745" cy="294518"/>
             <a:chOff x="142771" y="2118888"/>
-            <a:chExt cx="6454581" cy="253916"/>
+            <a:chExt cx="6454581" cy="241824"/>
           </a:xfrm>
         </p:grpSpPr>
         <p:sp>
@@ -3245,7 +3245,7 @@
           <p:spPr>
             <a:xfrm>
               <a:off x="142771" y="2118888"/>
-              <a:ext cx="1160060" cy="253916"/>
+              <a:ext cx="1160060" cy="207512"/>
             </a:xfrm>
             <a:prstGeom prst="rect">
               <a:avLst/>
@@ -3855,48 +3855,48 @@
             </a:pPr>
             <a:r>
               <a:rPr lang="zh-CN" altLang="en-US" sz="800" dirty="0">
-                <a:latin typeface="阿里巴巴普惠体 R" panose="00020600040101010101" pitchFamily="18" charset="-122"/>
-                <a:ea typeface="阿里巴巴普惠体 R" panose="00020600040101010101" pitchFamily="18" charset="-122"/>
-                <a:cs typeface="阿里巴巴普惠体 R" panose="00020600040101010101" pitchFamily="18" charset="-122"/>
+                <a:latin typeface="宋体" panose="02010600030101010101" pitchFamily="2" charset="-122"/>
+                <a:ea typeface="宋体" panose="02010600030101010101" pitchFamily="2" charset="-122"/>
+                <a:cs typeface="宋体" panose="02010600030101010101" pitchFamily="2" charset="-122"/>
               </a:rPr>
               <a:t>专业成绩</a:t>
             </a:r>
             <a:r>
               <a:rPr lang="en-US" altLang="zh-CN" sz="800" dirty="0">
-                <a:latin typeface="阿里巴巴普惠体 R" panose="00020600040101010101" pitchFamily="18" charset="-122"/>
-                <a:ea typeface="阿里巴巴普惠体 R" panose="00020600040101010101" pitchFamily="18" charset="-122"/>
-                <a:cs typeface="阿里巴巴普惠体 R" panose="00020600040101010101" pitchFamily="18" charset="-122"/>
+                <a:latin typeface="宋体" panose="02010600030101010101" pitchFamily="2" charset="-122"/>
+                <a:ea typeface="宋体" panose="02010600030101010101" pitchFamily="2" charset="-122"/>
+                <a:cs typeface="宋体" panose="02010600030101010101" pitchFamily="2" charset="-122"/>
               </a:rPr>
               <a:t>: </a:t>
             </a:r>
             <a:r>
               <a:rPr lang="en-US" altLang="zh-CN" sz="800" b="1" dirty="0">
-                <a:latin typeface="阿里巴巴普惠体 R" panose="00020600040101010101" pitchFamily="18" charset="-122"/>
-                <a:ea typeface="阿里巴巴普惠体 R" panose="00020600040101010101" pitchFamily="18" charset="-122"/>
-                <a:cs typeface="阿里巴巴普惠体 R" panose="00020600040101010101" pitchFamily="18" charset="-122"/>
+                <a:latin typeface="宋体" panose="02010600030101010101" pitchFamily="2" charset="-122"/>
+                <a:ea typeface="宋体" panose="02010600030101010101" pitchFamily="2" charset="-122"/>
+                <a:cs typeface="宋体" panose="02010600030101010101" pitchFamily="2" charset="-122"/>
               </a:rPr>
               <a:t>GPA:3.4/4.0(</a:t>
             </a:r>
             <a:r>
               <a:rPr lang="zh-CN" altLang="en-US" sz="800" b="1" dirty="0">
-                <a:latin typeface="阿里巴巴普惠体 R" panose="00020600040101010101" pitchFamily="18" charset="-122"/>
-                <a:ea typeface="阿里巴巴普惠体 R" panose="00020600040101010101" pitchFamily="18" charset="-122"/>
-                <a:cs typeface="阿里巴巴普惠体 R" panose="00020600040101010101" pitchFamily="18" charset="-122"/>
+                <a:latin typeface="宋体" panose="02010600030101010101" pitchFamily="2" charset="-122"/>
+                <a:ea typeface="宋体" panose="02010600030101010101" pitchFamily="2" charset="-122"/>
+                <a:cs typeface="宋体" panose="02010600030101010101" pitchFamily="2" charset="-122"/>
               </a:rPr>
               <a:t>专业前</a:t>
             </a:r>
             <a:r>
               <a:rPr lang="en-US" altLang="zh-CN" sz="800" b="1" dirty="0">
-                <a:latin typeface="阿里巴巴普惠体 R" panose="00020600040101010101" pitchFamily="18" charset="-122"/>
-                <a:ea typeface="阿里巴巴普惠体 R" panose="00020600040101010101" pitchFamily="18" charset="-122"/>
-                <a:cs typeface="阿里巴巴普惠体 R" panose="00020600040101010101" pitchFamily="18" charset="-122"/>
+                <a:latin typeface="宋体" panose="02010600030101010101" pitchFamily="2" charset="-122"/>
+                <a:ea typeface="宋体" panose="02010600030101010101" pitchFamily="2" charset="-122"/>
+                <a:cs typeface="宋体" panose="02010600030101010101" pitchFamily="2" charset="-122"/>
               </a:rPr>
               <a:t>10%)</a:t>
             </a:r>
             <a:endParaRPr lang="en-US" altLang="zh-CN" sz="800" b="1" dirty="0">
-              <a:latin typeface="阿里巴巴普惠体 R" panose="00020600040101010101" pitchFamily="18" charset="-122"/>
-              <a:ea typeface="阿里巴巴普惠体 R" panose="00020600040101010101" pitchFamily="18" charset="-122"/>
-              <a:cs typeface="阿里巴巴普惠体 R" panose="00020600040101010101" pitchFamily="18" charset="-122"/>
+              <a:latin typeface="宋体" panose="02010600030101010101" pitchFamily="2" charset="-122"/>
+              <a:ea typeface="宋体" panose="02010600030101010101" pitchFamily="2" charset="-122"/>
+              <a:cs typeface="宋体" panose="02010600030101010101" pitchFamily="2" charset="-122"/>
             </a:endParaRPr>
           </a:p>
           <a:p>
@@ -3907,48 +3907,48 @@
             </a:pPr>
             <a:r>
               <a:rPr lang="zh-CN" altLang="en-US" sz="800" dirty="0">
-                <a:latin typeface="阿里巴巴普惠体 R" panose="00020600040101010101" pitchFamily="18" charset="-122"/>
-                <a:ea typeface="阿里巴巴普惠体 R" panose="00020600040101010101" pitchFamily="18" charset="-122"/>
-                <a:cs typeface="阿里巴巴普惠体 R" panose="00020600040101010101" pitchFamily="18" charset="-122"/>
+                <a:latin typeface="宋体" panose="02010600030101010101" pitchFamily="2" charset="-122"/>
+                <a:ea typeface="宋体" panose="02010600030101010101" pitchFamily="2" charset="-122"/>
+                <a:cs typeface="宋体" panose="02010600030101010101" pitchFamily="2" charset="-122"/>
               </a:rPr>
               <a:t>主修课程</a:t>
             </a:r>
             <a:r>
               <a:rPr lang="en-US" altLang="zh-CN" sz="800" dirty="0">
-                <a:latin typeface="阿里巴巴普惠体 R" panose="00020600040101010101" pitchFamily="18" charset="-122"/>
-                <a:ea typeface="阿里巴巴普惠体 R" panose="00020600040101010101" pitchFamily="18" charset="-122"/>
-                <a:cs typeface="阿里巴巴普惠体 R" panose="00020600040101010101" pitchFamily="18" charset="-122"/>
+                <a:latin typeface="宋体" panose="02010600030101010101" pitchFamily="2" charset="-122"/>
+                <a:ea typeface="宋体" panose="02010600030101010101" pitchFamily="2" charset="-122"/>
+                <a:cs typeface="宋体" panose="02010600030101010101" pitchFamily="2" charset="-122"/>
               </a:rPr>
               <a:t>: </a:t>
             </a:r>
             <a:r>
               <a:rPr lang="zh-CN" altLang="en-US" sz="800" dirty="0">
-                <a:latin typeface="阿里巴巴普惠体 R" panose="00020600040101010101" pitchFamily="18" charset="-122"/>
-                <a:ea typeface="阿里巴巴普惠体 R" panose="00020600040101010101" pitchFamily="18" charset="-122"/>
-                <a:cs typeface="阿里巴巴普惠体 R" panose="00020600040101010101" pitchFamily="18" charset="-122"/>
+                <a:latin typeface="宋体" panose="02010600030101010101" pitchFamily="2" charset="-122"/>
+                <a:ea typeface="宋体" panose="02010600030101010101" pitchFamily="2" charset="-122"/>
+                <a:cs typeface="宋体" panose="02010600030101010101" pitchFamily="2" charset="-122"/>
               </a:rPr>
               <a:t>数据结构、软件项目管理、操作系统、计算机网络、</a:t>
             </a:r>
             <a:r>
               <a:rPr lang="en-US" altLang="zh-CN" sz="800" dirty="0" err="1">
-                <a:latin typeface="阿里巴巴普惠体 R" panose="00020600040101010101" pitchFamily="18" charset="-122"/>
-                <a:ea typeface="阿里巴巴普惠体 R" panose="00020600040101010101" pitchFamily="18" charset="-122"/>
-                <a:cs typeface="阿里巴巴普惠体 R" panose="00020600040101010101" pitchFamily="18" charset="-122"/>
+                <a:latin typeface="宋体" panose="02010600030101010101" pitchFamily="2" charset="-122"/>
+                <a:ea typeface="宋体" panose="02010600030101010101" pitchFamily="2" charset="-122"/>
+                <a:cs typeface="宋体" panose="02010600030101010101" pitchFamily="2" charset="-122"/>
               </a:rPr>
               <a:t>JavaWeb</a:t>
             </a:r>
             <a:r>
               <a:rPr lang="zh-CN" altLang="en-US" sz="800" dirty="0">
-                <a:latin typeface="阿里巴巴普惠体 R" panose="00020600040101010101" pitchFamily="18" charset="-122"/>
-                <a:ea typeface="阿里巴巴普惠体 R" panose="00020600040101010101" pitchFamily="18" charset="-122"/>
-                <a:cs typeface="阿里巴巴普惠体 R" panose="00020600040101010101" pitchFamily="18" charset="-122"/>
+                <a:latin typeface="宋体" panose="02010600030101010101" pitchFamily="2" charset="-122"/>
+                <a:ea typeface="宋体" panose="02010600030101010101" pitchFamily="2" charset="-122"/>
+                <a:cs typeface="宋体" panose="02010600030101010101" pitchFamily="2" charset="-122"/>
               </a:rPr>
               <a:t>应用开发、数据库系统概论、软件工程导论、企业级框架开发</a:t>
             </a:r>
             <a:endParaRPr lang="en-US" altLang="zh-CN" sz="800" dirty="0">
-              <a:latin typeface="阿里巴巴普惠体 R" panose="00020600040101010101" pitchFamily="18" charset="-122"/>
-              <a:ea typeface="阿里巴巴普惠体 R" panose="00020600040101010101" pitchFamily="18" charset="-122"/>
-              <a:cs typeface="阿里巴巴普惠体 R" panose="00020600040101010101" pitchFamily="18" charset="-122"/>
+              <a:latin typeface="宋体" panose="02010600030101010101" pitchFamily="2" charset="-122"/>
+              <a:ea typeface="宋体" panose="02010600030101010101" pitchFamily="2" charset="-122"/>
+              <a:cs typeface="宋体" panose="02010600030101010101" pitchFamily="2" charset="-122"/>
             </a:endParaRPr>
           </a:p>
           <a:p>
@@ -3959,96 +3959,88 @@
             </a:pPr>
             <a:r>
               <a:rPr lang="zh-CN" altLang="en-US" sz="800" dirty="0">
-                <a:latin typeface="阿里巴巴普惠体 R" panose="00020600040101010101" pitchFamily="18" charset="-122"/>
-                <a:ea typeface="阿里巴巴普惠体 R" panose="00020600040101010101" pitchFamily="18" charset="-122"/>
-                <a:cs typeface="阿里巴巴普惠体 R" panose="00020600040101010101" pitchFamily="18" charset="-122"/>
+                <a:latin typeface="宋体" panose="02010600030101010101" pitchFamily="2" charset="-122"/>
+                <a:ea typeface="宋体" panose="02010600030101010101" pitchFamily="2" charset="-122"/>
+                <a:cs typeface="宋体" panose="02010600030101010101" pitchFamily="2" charset="-122"/>
               </a:rPr>
               <a:t>个人荣誉：英语四级</a:t>
             </a:r>
             <a:r>
               <a:rPr lang="zh-CN" altLang="en-US" sz="800" b="1" dirty="0">
-                <a:latin typeface="阿里巴巴普惠体 R" panose="00020600040101010101" pitchFamily="18" charset="-122"/>
-                <a:ea typeface="阿里巴巴普惠体 R" panose="00020600040101010101" pitchFamily="18" charset="-122"/>
-                <a:cs typeface="阿里巴巴普惠体 R" panose="00020600040101010101" pitchFamily="18" charset="-122"/>
+                <a:latin typeface="宋体" panose="02010600030101010101" pitchFamily="2" charset="-122"/>
+                <a:ea typeface="宋体" panose="02010600030101010101" pitchFamily="2" charset="-122"/>
+                <a:cs typeface="宋体" panose="02010600030101010101" pitchFamily="2" charset="-122"/>
               </a:rPr>
               <a:t>（</a:t>
             </a:r>
             <a:r>
               <a:rPr lang="en-US" altLang="zh-CN" sz="800" b="1" dirty="0">
-                <a:latin typeface="阿里巴巴普惠体 R" panose="00020600040101010101" pitchFamily="18" charset="-122"/>
-                <a:ea typeface="阿里巴巴普惠体 R" panose="00020600040101010101" pitchFamily="18" charset="-122"/>
-                <a:cs typeface="阿里巴巴普惠体 R" panose="00020600040101010101" pitchFamily="18" charset="-122"/>
+                <a:latin typeface="宋体" panose="02010600030101010101" pitchFamily="2" charset="-122"/>
+                <a:ea typeface="宋体" panose="02010600030101010101" pitchFamily="2" charset="-122"/>
+                <a:cs typeface="宋体" panose="02010600030101010101" pitchFamily="2" charset="-122"/>
               </a:rPr>
               <a:t>536</a:t>
             </a:r>
             <a:r>
               <a:rPr lang="zh-CN" altLang="en-US" sz="800" b="1" dirty="0">
-                <a:latin typeface="阿里巴巴普惠体 R" panose="00020600040101010101" pitchFamily="18" charset="-122"/>
-                <a:ea typeface="阿里巴巴普惠体 R" panose="00020600040101010101" pitchFamily="18" charset="-122"/>
-                <a:cs typeface="阿里巴巴普惠体 R" panose="00020600040101010101" pitchFamily="18" charset="-122"/>
+                <a:latin typeface="宋体" panose="02010600030101010101" pitchFamily="2" charset="-122"/>
+                <a:ea typeface="宋体" panose="02010600030101010101" pitchFamily="2" charset="-122"/>
+                <a:cs typeface="宋体" panose="02010600030101010101" pitchFamily="2" charset="-122"/>
               </a:rPr>
               <a:t>分）</a:t>
             </a:r>
             <a:r>
               <a:rPr lang="zh-CN" altLang="en-US" sz="800" dirty="0">
-                <a:latin typeface="阿里巴巴普惠体 R" panose="00020600040101010101" pitchFamily="18" charset="-122"/>
-                <a:ea typeface="阿里巴巴普惠体 R" panose="00020600040101010101" pitchFamily="18" charset="-122"/>
-                <a:cs typeface="阿里巴巴普惠体 R" panose="00020600040101010101" pitchFamily="18" charset="-122"/>
+                <a:latin typeface="宋体" panose="02010600030101010101" pitchFamily="2" charset="-122"/>
+                <a:ea typeface="宋体" panose="02010600030101010101" pitchFamily="2" charset="-122"/>
+                <a:cs typeface="宋体" panose="02010600030101010101" pitchFamily="2" charset="-122"/>
               </a:rPr>
               <a:t>、</a:t>
             </a:r>
             <a:r>
               <a:rPr lang="zh-CN" altLang="en-US" sz="800" b="1" dirty="0">
-                <a:latin typeface="阿里巴巴普惠体 R" panose="00020600040101010101" pitchFamily="18" charset="-122"/>
-                <a:ea typeface="阿里巴巴普惠体 R" panose="00020600040101010101" pitchFamily="18" charset="-122"/>
-                <a:cs typeface="阿里巴巴普惠体 R" panose="00020600040101010101" pitchFamily="18" charset="-122"/>
+                <a:latin typeface="宋体" panose="02010600030101010101" pitchFamily="2" charset="-122"/>
+                <a:ea typeface="宋体" panose="02010600030101010101" pitchFamily="2" charset="-122"/>
+                <a:cs typeface="宋体" panose="02010600030101010101" pitchFamily="2" charset="-122"/>
               </a:rPr>
               <a:t>六级证书（</a:t>
             </a:r>
             <a:r>
               <a:rPr lang="en-US" altLang="zh-CN" sz="800" b="1" dirty="0">
-                <a:latin typeface="阿里巴巴普惠体 R" panose="00020600040101010101" pitchFamily="18" charset="-122"/>
-                <a:ea typeface="阿里巴巴普惠体 R" panose="00020600040101010101" pitchFamily="18" charset="-122"/>
-                <a:cs typeface="阿里巴巴普惠体 R" panose="00020600040101010101" pitchFamily="18" charset="-122"/>
+                <a:latin typeface="宋体" panose="02010600030101010101" pitchFamily="2" charset="-122"/>
+                <a:ea typeface="宋体" panose="02010600030101010101" pitchFamily="2" charset="-122"/>
+                <a:cs typeface="宋体" panose="02010600030101010101" pitchFamily="2" charset="-122"/>
               </a:rPr>
               <a:t>494</a:t>
             </a:r>
             <a:r>
               <a:rPr lang="zh-CN" altLang="en-US" sz="800" b="1" dirty="0">
-                <a:latin typeface="阿里巴巴普惠体 R" panose="00020600040101010101" pitchFamily="18" charset="-122"/>
-                <a:ea typeface="阿里巴巴普惠体 R" panose="00020600040101010101" pitchFamily="18" charset="-122"/>
-                <a:cs typeface="阿里巴巴普惠体 R" panose="00020600040101010101" pitchFamily="18" charset="-122"/>
+                <a:latin typeface="宋体" panose="02010600030101010101" pitchFamily="2" charset="-122"/>
+                <a:ea typeface="宋体" panose="02010600030101010101" pitchFamily="2" charset="-122"/>
+                <a:cs typeface="宋体" panose="02010600030101010101" pitchFamily="2" charset="-122"/>
               </a:rPr>
               <a:t>分）、</a:t>
             </a:r>
             <a:r>
               <a:rPr lang="zh-CN" altLang="en-US" sz="800" dirty="0">
-                <a:latin typeface="阿里巴巴普惠体 R" panose="00020600040101010101" pitchFamily="18" charset="-122"/>
-                <a:ea typeface="阿里巴巴普惠体 R" panose="00020600040101010101" pitchFamily="18" charset="-122"/>
-                <a:cs typeface="阿里巴巴普惠体 R" panose="00020600040101010101" pitchFamily="18" charset="-122"/>
+                <a:latin typeface="宋体" panose="02010600030101010101" pitchFamily="2" charset="-122"/>
+                <a:ea typeface="宋体" panose="02010600030101010101" pitchFamily="2" charset="-122"/>
+                <a:cs typeface="宋体" panose="02010600030101010101" pitchFamily="2" charset="-122"/>
               </a:rPr>
               <a:t>蓝桥杯</a:t>
             </a:r>
             <a:r>
               <a:rPr lang="zh-CN" altLang="en-US" sz="800" b="1" dirty="0">
-                <a:latin typeface="阿里巴巴普惠体 R" panose="00020600040101010101" pitchFamily="18" charset="-122"/>
-                <a:ea typeface="阿里巴巴普惠体 R" panose="00020600040101010101" pitchFamily="18" charset="-122"/>
-                <a:cs typeface="阿里巴巴普惠体 R" panose="00020600040101010101" pitchFamily="18" charset="-122"/>
-              </a:rPr>
-              <a:t>省</a:t>
-            </a:r>
-            <a:r>
-              <a:rPr lang="zh-CN" altLang="en-US" sz="800" b="1" dirty="0">
-                <a:latin typeface="阿里巴巴普惠体 R" panose="00020600040101010101" pitchFamily="18" charset="-122"/>
-                <a:ea typeface="阿里巴巴普惠体 R" panose="00020600040101010101" pitchFamily="18" charset="-122"/>
-                <a:cs typeface="阿里巴巴普惠体 R" panose="00020600040101010101" pitchFamily="18" charset="-122"/>
-              </a:rPr>
-              <a:t>二等奖</a:t>
+                <a:latin typeface="宋体" panose="02010600030101010101" pitchFamily="2" charset="-122"/>
+                <a:ea typeface="宋体" panose="02010600030101010101" pitchFamily="2" charset="-122"/>
+                <a:cs typeface="宋体" panose="02010600030101010101" pitchFamily="2" charset="-122"/>
+              </a:rPr>
+              <a:t>省二等奖</a:t>
             </a:r>
             <a:endParaRPr lang="en-US" altLang="zh-CN" sz="800" b="1" dirty="0">
-              <a:latin typeface="阿里巴巴普惠体 R" panose="00020600040101010101" pitchFamily="18" charset="-122"/>
-              <a:ea typeface="阿里巴巴普惠体 R" panose="00020600040101010101" pitchFamily="18" charset="-122"/>
-              <a:cs typeface="阿里巴巴普惠体 R" panose="00020600040101010101" pitchFamily="18" charset="-122"/>
+              <a:latin typeface="宋体" panose="02010600030101010101" pitchFamily="2" charset="-122"/>
+              <a:ea typeface="宋体" panose="02010600030101010101" pitchFamily="2" charset="-122"/>
+              <a:cs typeface="宋体" panose="02010600030101010101" pitchFamily="2" charset="-122"/>
             </a:endParaRPr>
           </a:p>
         </p:txBody>
@@ -4092,9 +4084,9 @@
         <p:grpSpPr>
           <a:xfrm>
             <a:off x="90805" y="2287905"/>
-            <a:ext cx="6407785" cy="275590"/>
+            <a:ext cx="6428105" cy="282004"/>
             <a:chOff x="172266" y="5624643"/>
-            <a:chExt cx="6425086" cy="273929"/>
+            <a:chExt cx="6425086" cy="264461"/>
           </a:xfrm>
         </p:grpSpPr>
         <p:sp>
@@ -4106,7 +4098,7 @@
           <p:spPr>
             <a:xfrm>
               <a:off x="172266" y="5624643"/>
-              <a:ext cx="1160060" cy="273929"/>
+              <a:ext cx="1160060" cy="258446"/>
             </a:xfrm>
             <a:prstGeom prst="rect">
               <a:avLst/>
@@ -4251,7 +4243,7 @@
         </p:nvGrpSpPr>
         <p:grpSpPr>
           <a:xfrm>
-            <a:off x="47516" y="4233145"/>
+            <a:off x="82441" y="6230220"/>
             <a:ext cx="6437151" cy="275590"/>
             <a:chOff x="160201" y="5643058"/>
             <a:chExt cx="6437151" cy="275590"/>
@@ -4404,7 +4396,7 @@
         </p:nvSpPr>
         <p:spPr>
           <a:xfrm>
-            <a:off x="4610626" y="6404610"/>
+            <a:off x="4645551" y="8401685"/>
             <a:ext cx="2072702" cy="307777"/>
           </a:xfrm>
           <a:prstGeom prst="rect">
@@ -4435,7 +4427,7 @@
         </p:nvSpPr>
         <p:spPr>
           <a:xfrm>
-            <a:off x="-201237" y="6404610"/>
+            <a:off x="-166312" y="8401685"/>
             <a:ext cx="1646697" cy="307777"/>
           </a:xfrm>
           <a:prstGeom prst="rect">
@@ -4460,14 +4452,14 @@
       </p:sp>
       <p:sp>
         <p:nvSpPr>
-          <p:cNvPr id="106" name="文本框 105"/>
+          <p:cNvPr id="107" name="文本框 106"/>
           <p:cNvSpPr txBox="1"/>
           <p:nvPr/>
         </p:nvSpPr>
         <p:spPr>
           <a:xfrm>
-            <a:off x="79375" y="7617460"/>
-            <a:ext cx="6591300" cy="2040255"/>
+            <a:off x="116840" y="6393180"/>
+            <a:ext cx="6628130" cy="2924175"/>
           </a:xfrm>
           <a:prstGeom prst="rect">
             <a:avLst/>
@@ -4476,396 +4468,17 @@
         </p:spPr>
         <p:txBody>
           <a:bodyPr wrap="square" rtlCol="0">
-            <a:spAutoFit/>
+            <a:noAutofit/>
           </a:bodyPr>
           <a:lstStyle/>
           <a:p>
-            <a:pPr algn="l">
+            <a:pPr indent="0" fontAlgn="auto">
               <a:lnSpc>
-                <a:spcPts val="1520"/>
+                <a:spcPct val="200000"/>
               </a:lnSpc>
             </a:pPr>
             <a:r>
-              <a:rPr lang="en-US" altLang="zh-CN" sz="800" dirty="0">
-                <a:latin typeface="阿里巴巴普惠体 R" panose="00020600040101010101" pitchFamily="18" charset="-122"/>
-                <a:ea typeface="阿里巴巴普惠体 R" panose="00020600040101010101" pitchFamily="18" charset="-122"/>
-                <a:cs typeface="阿里巴巴普惠体 R" panose="00020600040101010101" pitchFamily="18" charset="-122"/>
-              </a:rPr>
-              <a:t>2024/9 – 2025/1</a:t>
-            </a:r>
-            <a:endParaRPr lang="en-US" altLang="zh-CN" sz="800" dirty="0">
-              <a:latin typeface="阿里巴巴普惠体 R" panose="00020600040101010101" pitchFamily="18" charset="-122"/>
-              <a:ea typeface="阿里巴巴普惠体 R" panose="00020600040101010101" pitchFamily="18" charset="-122"/>
-              <a:cs typeface="阿里巴巴普惠体 R" panose="00020600040101010101" pitchFamily="18" charset="-122"/>
-            </a:endParaRPr>
-          </a:p>
-          <a:p>
-            <a:pPr>
-              <a:lnSpc>
-                <a:spcPts val="1520"/>
-              </a:lnSpc>
-            </a:pPr>
-            <a:r>
-              <a:rPr lang="en-US" altLang="zh-CN" sz="800" b="1" dirty="0" err="1">
-                <a:ea typeface="阿里巴巴普惠体 M" panose="00020600040101010101"/>
-              </a:rPr>
-              <a:t>ArcLearn</a:t>
-            </a:r>
-            <a:r>
               <a:rPr lang="en-US" altLang="zh-CN" sz="800" b="1" dirty="0">
-                <a:ea typeface="阿里巴巴普惠体 M" panose="00020600040101010101"/>
-              </a:rPr>
-              <a:t> </a:t>
-            </a:r>
-            <a:r>
-              <a:rPr lang="zh-CN" altLang="en-US" sz="800" b="1" dirty="0">
-                <a:ea typeface="阿里巴巴普惠体 M" panose="00020600040101010101"/>
-              </a:rPr>
-              <a:t>社区</a:t>
-            </a:r>
-            <a:r>
-              <a:rPr lang="en-US" altLang="zh-CN" sz="800" b="1" dirty="0">
-                <a:ea typeface="阿里巴巴普惠体 M" panose="00020600040101010101"/>
-              </a:rPr>
-              <a:t>—</a:t>
-            </a:r>
-            <a:r>
-              <a:rPr lang="zh-CN" altLang="en-US" sz="800" b="1" dirty="0">
-                <a:ea typeface="阿里巴巴普惠体 M" panose="00020600040101010101"/>
-              </a:rPr>
-              <a:t>后端开发</a:t>
-            </a:r>
-            <a:endParaRPr lang="en-US" altLang="zh-CN" sz="800" b="1" dirty="0">
-              <a:ea typeface="阿里巴巴普惠体 M" panose="00020600040101010101"/>
-            </a:endParaRPr>
-          </a:p>
-          <a:p>
-            <a:pPr algn="l">
-              <a:lnSpc>
-                <a:spcPts val="1520"/>
-              </a:lnSpc>
-              <a:buClrTx/>
-              <a:buSzTx/>
-              <a:buNone/>
-            </a:pPr>
-            <a:r>
-              <a:rPr lang="zh-CN" altLang="en-US" sz="800" b="1" dirty="0">
-                <a:latin typeface="宋体" panose="02010600030101010101" pitchFamily="2" charset="-122"/>
-                <a:ea typeface="宋体" panose="02010600030101010101" pitchFamily="2" charset="-122"/>
-                <a:cs typeface="宋体" panose="02010600030101010101" pitchFamily="2" charset="-122"/>
-              </a:rPr>
-              <a:t>项目描述:</a:t>
-            </a:r>
-            <a:r>
-              <a:rPr lang="zh-CN" altLang="en-US" sz="800" dirty="0">
-                <a:latin typeface="宋体" panose="02010600030101010101" pitchFamily="2" charset="-122"/>
-                <a:ea typeface="宋体" panose="02010600030101010101" pitchFamily="2" charset="-122"/>
-                <a:cs typeface="宋体" panose="02010600030101010101" pitchFamily="2" charset="-122"/>
-              </a:rPr>
-              <a:t> 一款面向开发者的技术交流平台，支持Markdown 富文本文章的发布、评论互动、用户签到、行为统计等功能，</a:t>
-            </a:r>
-            <a:endParaRPr lang="zh-CN" altLang="en-US" sz="800" dirty="0">
-              <a:latin typeface="宋体" panose="02010600030101010101" pitchFamily="2" charset="-122"/>
-              <a:ea typeface="宋体" panose="02010600030101010101" pitchFamily="2" charset="-122"/>
-              <a:cs typeface="宋体" panose="02010600030101010101" pitchFamily="2" charset="-122"/>
-            </a:endParaRPr>
-          </a:p>
-          <a:p>
-            <a:pPr algn="l">
-              <a:lnSpc>
-                <a:spcPts val="1520"/>
-              </a:lnSpc>
-              <a:buClrTx/>
-              <a:buSzTx/>
-              <a:buNone/>
-            </a:pPr>
-            <a:r>
-              <a:rPr lang="zh-CN" altLang="en-US" sz="800" b="1" dirty="0">
-                <a:latin typeface="宋体" panose="02010600030101010101" pitchFamily="2" charset="-122"/>
-                <a:ea typeface="宋体" panose="02010600030101010101" pitchFamily="2" charset="-122"/>
-                <a:cs typeface="宋体" panose="02010600030101010101" pitchFamily="2" charset="-122"/>
-              </a:rPr>
-              <a:t>核心技术:</a:t>
-            </a:r>
-            <a:r>
-              <a:rPr lang="zh-CN" altLang="en-US" sz="800" dirty="0">
-                <a:latin typeface="宋体" panose="02010600030101010101" pitchFamily="2" charset="-122"/>
-                <a:ea typeface="宋体" panose="02010600030101010101" pitchFamily="2" charset="-122"/>
-                <a:cs typeface="宋体" panose="02010600030101010101" pitchFamily="2" charset="-122"/>
-              </a:rPr>
-              <a:t> SpringBoot , MyBatis , Redis, RabbitMQ, JWT, Nginx,阿里云Oss, Vue3,ElementUl Plus</a:t>
-            </a:r>
-            <a:endParaRPr lang="zh-CN" altLang="en-US" sz="800" dirty="0">
-              <a:latin typeface="宋体" panose="02010600030101010101" pitchFamily="2" charset="-122"/>
-              <a:ea typeface="宋体" panose="02010600030101010101" pitchFamily="2" charset="-122"/>
-              <a:cs typeface="宋体" panose="02010600030101010101" pitchFamily="2" charset="-122"/>
-            </a:endParaRPr>
-          </a:p>
-          <a:p>
-            <a:pPr algn="l">
-              <a:lnSpc>
-                <a:spcPts val="1520"/>
-              </a:lnSpc>
-              <a:buClrTx/>
-              <a:buSzTx/>
-              <a:buNone/>
-            </a:pPr>
-            <a:r>
-              <a:rPr lang="zh-CN" altLang="en-US" sz="800" b="1" dirty="0">
-                <a:latin typeface="宋体" panose="02010600030101010101" pitchFamily="2" charset="-122"/>
-                <a:ea typeface="宋体" panose="02010600030101010101" pitchFamily="2" charset="-122"/>
-                <a:cs typeface="宋体" panose="02010600030101010101" pitchFamily="2" charset="-122"/>
-              </a:rPr>
-              <a:t>核心职责:</a:t>
-            </a:r>
-            <a:endParaRPr lang="zh-CN" altLang="en-US" sz="800" b="1" dirty="0">
-              <a:latin typeface="宋体" panose="02010600030101010101" pitchFamily="2" charset="-122"/>
-              <a:ea typeface="宋体" panose="02010600030101010101" pitchFamily="2" charset="-122"/>
-              <a:cs typeface="宋体" panose="02010600030101010101" pitchFamily="2" charset="-122"/>
-            </a:endParaRPr>
-          </a:p>
-          <a:p>
-            <a:pPr lvl="1" algn="l">
-              <a:lnSpc>
-                <a:spcPts val="1520"/>
-              </a:lnSpc>
-              <a:buClrTx/>
-              <a:buSzTx/>
-              <a:buNone/>
-            </a:pPr>
-            <a:r>
-              <a:rPr lang="zh-CN" altLang="en-US" sz="800" dirty="0">
-                <a:latin typeface="宋体" panose="02010600030101010101" pitchFamily="2" charset="-122"/>
-                <a:ea typeface="宋体" panose="02010600030101010101" pitchFamily="2" charset="-122"/>
-                <a:cs typeface="宋体" panose="02010600030101010101" pitchFamily="2" charset="-122"/>
-              </a:rPr>
-              <a:t> </a:t>
-            </a:r>
-            <a:r>
-              <a:rPr lang="zh-CN" altLang="en-US" sz="800" b="1" dirty="0">
-                <a:latin typeface="宋体" panose="02010600030101010101" pitchFamily="2" charset="-122"/>
-                <a:ea typeface="宋体" panose="02010600030101010101" pitchFamily="2" charset="-122"/>
-                <a:cs typeface="宋体" panose="02010600030101010101" pitchFamily="2" charset="-122"/>
-              </a:rPr>
-              <a:t>异步解耦：</a:t>
-            </a:r>
-            <a:r>
-              <a:rPr lang="zh-CN" altLang="en-US" sz="800" dirty="0">
-                <a:latin typeface="宋体" panose="02010600030101010101" pitchFamily="2" charset="-122"/>
-                <a:ea typeface="宋体" panose="02010600030101010101" pitchFamily="2" charset="-122"/>
-                <a:cs typeface="宋体" panose="02010600030101010101" pitchFamily="2" charset="-122"/>
-              </a:rPr>
-              <a:t>构建基于</a:t>
-            </a:r>
-            <a:r>
-              <a:rPr lang="zh-CN" altLang="en-US" sz="800" b="1" dirty="0">
-                <a:latin typeface="宋体" panose="02010600030101010101" pitchFamily="2" charset="-122"/>
-                <a:ea typeface="宋体" panose="02010600030101010101" pitchFamily="2" charset="-122"/>
-                <a:cs typeface="宋体" panose="02010600030101010101" pitchFamily="2" charset="-122"/>
-              </a:rPr>
-              <a:t> RabbitMQ 的事件驱动架构</a:t>
-            </a:r>
-            <a:r>
-              <a:rPr lang="zh-CN" altLang="en-US" sz="800" dirty="0">
-                <a:latin typeface="宋体" panose="02010600030101010101" pitchFamily="2" charset="-122"/>
-                <a:ea typeface="宋体" panose="02010600030101010101" pitchFamily="2" charset="-122"/>
-                <a:cs typeface="宋体" panose="02010600030101010101" pitchFamily="2" charset="-122"/>
-              </a:rPr>
-              <a:t>，将文章发布、评论提醒、系统通知等任务异步化，提高系统响应速度与可扩展性。</a:t>
-            </a:r>
-            <a:endParaRPr lang="zh-CN" altLang="en-US" sz="800" dirty="0">
-              <a:latin typeface="宋体" panose="02010600030101010101" pitchFamily="2" charset="-122"/>
-              <a:ea typeface="宋体" panose="02010600030101010101" pitchFamily="2" charset="-122"/>
-              <a:cs typeface="宋体" panose="02010600030101010101" pitchFamily="2" charset="-122"/>
-            </a:endParaRPr>
-          </a:p>
-          <a:p>
-            <a:pPr lvl="1" algn="l">
-              <a:lnSpc>
-                <a:spcPts val="1520"/>
-              </a:lnSpc>
-              <a:buClrTx/>
-              <a:buSzTx/>
-              <a:buNone/>
-            </a:pPr>
-            <a:r>
-              <a:rPr lang="zh-CN" altLang="en-US" sz="800" dirty="0">
-                <a:latin typeface="宋体" panose="02010600030101010101" pitchFamily="2" charset="-122"/>
-                <a:ea typeface="宋体" panose="02010600030101010101" pitchFamily="2" charset="-122"/>
-                <a:cs typeface="宋体" panose="02010600030101010101" pitchFamily="2" charset="-122"/>
-              </a:rPr>
-              <a:t> </a:t>
-            </a:r>
-            <a:r>
-              <a:rPr lang="zh-CN" altLang="en-US" sz="800" b="1" dirty="0">
-                <a:latin typeface="宋体" panose="02010600030101010101" pitchFamily="2" charset="-122"/>
-                <a:ea typeface="宋体" panose="02010600030101010101" pitchFamily="2" charset="-122"/>
-                <a:cs typeface="宋体" panose="02010600030101010101" pitchFamily="2" charset="-122"/>
-              </a:rPr>
-              <a:t>缓存优化：</a:t>
-            </a:r>
-            <a:r>
-              <a:rPr lang="zh-CN" altLang="en-US" sz="800" dirty="0">
-                <a:latin typeface="宋体" panose="02010600030101010101" pitchFamily="2" charset="-122"/>
-                <a:ea typeface="宋体" panose="02010600030101010101" pitchFamily="2" charset="-122"/>
-                <a:cs typeface="宋体" panose="02010600030101010101" pitchFamily="2" charset="-122"/>
-              </a:rPr>
-              <a:t>使用 Redis 缓存热点数据，结合布隆过滤器与互斥锁，有效防止缓存击穿/穿透问题</a:t>
-            </a:r>
-            <a:endParaRPr lang="zh-CN" altLang="en-US" sz="800" dirty="0">
-              <a:latin typeface="宋体" panose="02010600030101010101" pitchFamily="2" charset="-122"/>
-              <a:ea typeface="宋体" panose="02010600030101010101" pitchFamily="2" charset="-122"/>
-              <a:cs typeface="宋体" panose="02010600030101010101" pitchFamily="2" charset="-122"/>
-            </a:endParaRPr>
-          </a:p>
-          <a:p>
-            <a:pPr lvl="1" algn="l">
-              <a:lnSpc>
-                <a:spcPts val="1520"/>
-              </a:lnSpc>
-              <a:buClrTx/>
-              <a:buSzTx/>
-              <a:buNone/>
-            </a:pPr>
-            <a:r>
-              <a:rPr lang="zh-CN" altLang="en-US" sz="800" dirty="0">
-                <a:latin typeface="宋体" panose="02010600030101010101" pitchFamily="2" charset="-122"/>
-                <a:ea typeface="宋体" panose="02010600030101010101" pitchFamily="2" charset="-122"/>
-                <a:cs typeface="宋体" panose="02010600030101010101" pitchFamily="2" charset="-122"/>
-              </a:rPr>
-              <a:t> </a:t>
-            </a:r>
-            <a:r>
-              <a:rPr lang="zh-CN" altLang="en-US" sz="800" b="1" dirty="0">
-                <a:latin typeface="宋体" panose="02010600030101010101" pitchFamily="2" charset="-122"/>
-                <a:ea typeface="宋体" panose="02010600030101010101" pitchFamily="2" charset="-122"/>
-                <a:cs typeface="宋体" panose="02010600030101010101" pitchFamily="2" charset="-122"/>
-              </a:rPr>
-              <a:t>架构设计：</a:t>
-            </a:r>
-            <a:r>
-              <a:rPr lang="zh-CN" altLang="en-US" sz="800" dirty="0">
-                <a:latin typeface="宋体" panose="02010600030101010101" pitchFamily="2" charset="-122"/>
-                <a:ea typeface="宋体" panose="02010600030101010101" pitchFamily="2" charset="-122"/>
-                <a:cs typeface="宋体" panose="02010600030101010101" pitchFamily="2" charset="-122"/>
-              </a:rPr>
-              <a:t>基于SpringBoot+MyBatis实现高效数据持久化，利用AOP 切面编程统一日志采集</a:t>
-            </a:r>
-            <a:endParaRPr lang="zh-CN" altLang="en-US" sz="800" dirty="0">
-              <a:latin typeface="宋体" panose="02010600030101010101" pitchFamily="2" charset="-122"/>
-              <a:ea typeface="宋体" panose="02010600030101010101" pitchFamily="2" charset="-122"/>
-              <a:cs typeface="宋体" panose="02010600030101010101" pitchFamily="2" charset="-122"/>
-            </a:endParaRPr>
-          </a:p>
-          <a:p>
-            <a:pPr lvl="1" algn="l">
-              <a:lnSpc>
-                <a:spcPts val="1520"/>
-              </a:lnSpc>
-              <a:buClrTx/>
-              <a:buSzTx/>
-              <a:buNone/>
-            </a:pPr>
-            <a:r>
-              <a:rPr lang="zh-CN" altLang="en-US" sz="800" dirty="0">
-                <a:latin typeface="宋体" panose="02010600030101010101" pitchFamily="2" charset="-122"/>
-                <a:ea typeface="宋体" panose="02010600030101010101" pitchFamily="2" charset="-122"/>
-                <a:cs typeface="宋体" panose="02010600030101010101" pitchFamily="2" charset="-122"/>
-              </a:rPr>
-              <a:t> </a:t>
-            </a:r>
-            <a:r>
-              <a:rPr lang="zh-CN" altLang="en-US" sz="800" b="1" dirty="0">
-                <a:latin typeface="宋体" panose="02010600030101010101" pitchFamily="2" charset="-122"/>
-                <a:ea typeface="宋体" panose="02010600030101010101" pitchFamily="2" charset="-122"/>
-                <a:cs typeface="宋体" panose="02010600030101010101" pitchFamily="2" charset="-122"/>
-              </a:rPr>
-              <a:t>安全认证:</a:t>
-            </a:r>
-            <a:r>
-              <a:rPr lang="en-US" altLang="zh-CN" sz="800" b="1" dirty="0">
-                <a:latin typeface="宋体" panose="02010600030101010101" pitchFamily="2" charset="-122"/>
-                <a:ea typeface="宋体" panose="02010600030101010101" pitchFamily="2" charset="-122"/>
-                <a:cs typeface="宋体" panose="02010600030101010101" pitchFamily="2" charset="-122"/>
-              </a:rPr>
-              <a:t> </a:t>
-            </a:r>
-            <a:r>
-              <a:rPr lang="zh-CN" altLang="en-US" sz="800" dirty="0">
-                <a:latin typeface="宋体" panose="02010600030101010101" pitchFamily="2" charset="-122"/>
-                <a:ea typeface="宋体" panose="02010600030101010101" pitchFamily="2" charset="-122"/>
-                <a:cs typeface="宋体" panose="02010600030101010101" pitchFamily="2" charset="-122"/>
-              </a:rPr>
-              <a:t>JWT无状态令牌实现鉴权,优化用户体验并保障接口安全。</a:t>
-            </a:r>
-            <a:endParaRPr lang="zh-CN" altLang="en-US" sz="800" dirty="0">
-              <a:latin typeface="宋体" panose="02010600030101010101" pitchFamily="2" charset="-122"/>
-              <a:ea typeface="宋体" panose="02010600030101010101" pitchFamily="2" charset="-122"/>
-              <a:cs typeface="宋体" panose="02010600030101010101" pitchFamily="2" charset="-122"/>
-            </a:endParaRPr>
-          </a:p>
-          <a:p>
-            <a:pPr lvl="1" algn="l">
-              <a:lnSpc>
-                <a:spcPts val="1520"/>
-              </a:lnSpc>
-              <a:buClrTx/>
-              <a:buSzTx/>
-              <a:buNone/>
-            </a:pPr>
-            <a:r>
-              <a:rPr lang="zh-CN" altLang="en-US" sz="800" b="1" dirty="0">
-                <a:latin typeface="宋体" panose="02010600030101010101" pitchFamily="2" charset="-122"/>
-                <a:ea typeface="宋体" panose="02010600030101010101" pitchFamily="2" charset="-122"/>
-                <a:cs typeface="宋体" panose="02010600030101010101" pitchFamily="2" charset="-122"/>
-              </a:rPr>
-              <a:t> 用户统计：</a:t>
-            </a:r>
-            <a:r>
-              <a:rPr lang="zh-CN" altLang="en-US" sz="800" dirty="0">
-                <a:latin typeface="宋体" panose="02010600030101010101" pitchFamily="2" charset="-122"/>
-                <a:ea typeface="宋体" panose="02010600030101010101" pitchFamily="2" charset="-122"/>
-                <a:cs typeface="宋体" panose="02010600030101010101" pitchFamily="2" charset="-122"/>
-              </a:rPr>
-              <a:t>利用 HyperLogLog 统计独立访客（UV），结合Bitmap 记录用户签到行为，实现社区活跃度分析与数据可视化。</a:t>
-            </a:r>
-            <a:endParaRPr lang="zh-CN" altLang="en-US" sz="800" dirty="0">
-              <a:latin typeface="宋体" panose="02010600030101010101" pitchFamily="2" charset="-122"/>
-              <a:ea typeface="宋体" panose="02010600030101010101" pitchFamily="2" charset="-122"/>
-              <a:cs typeface="宋体" panose="02010600030101010101" pitchFamily="2" charset="-122"/>
-            </a:endParaRPr>
-          </a:p>
-        </p:txBody>
-      </p:sp>
-      <p:sp>
-        <p:nvSpPr>
-          <p:cNvPr id="107" name="文本框 106"/>
-          <p:cNvSpPr txBox="1"/>
-          <p:nvPr/>
-        </p:nvSpPr>
-        <p:spPr>
-          <a:xfrm>
-            <a:off x="44450" y="4395950"/>
-            <a:ext cx="6627945" cy="3014980"/>
-          </a:xfrm>
-          <a:prstGeom prst="rect">
-            <a:avLst/>
-          </a:prstGeom>
-          <a:noFill/>
-        </p:spPr>
-        <p:txBody>
-          <a:bodyPr wrap="square" rtlCol="0">
-            <a:spAutoFit/>
-          </a:bodyPr>
-          <a:lstStyle/>
-          <a:p>
-            <a:pPr>
-              <a:lnSpc>
-                <a:spcPts val="1520"/>
-              </a:lnSpc>
-            </a:pPr>
-            <a:r>
-              <a:rPr lang="en-US" altLang="zh-CN" sz="800" dirty="0">
                 <a:latin typeface="阿里巴巴普惠体 R" panose="00020600040101010101" pitchFamily="18" charset="-122"/>
                 <a:ea typeface="阿里巴巴普惠体 R" panose="00020600040101010101" pitchFamily="18" charset="-122"/>
                 <a:cs typeface="阿里巴巴普惠体 R" panose="00020600040101010101" pitchFamily="18" charset="-122"/>
@@ -4889,9 +4502,9 @@
             </a:endParaRPr>
           </a:p>
           <a:p>
-            <a:pPr>
+            <a:pPr indent="0" fontAlgn="auto">
               <a:lnSpc>
-                <a:spcPts val="1520"/>
+                <a:spcPct val="200000"/>
               </a:lnSpc>
             </a:pPr>
             <a:r>
@@ -4901,7 +4514,7 @@
                 <a:cs typeface="阿里巴巴普惠体 R" panose="00020600040101010101" pitchFamily="18" charset="-122"/>
                 <a:sym typeface="+mn-ea"/>
               </a:rPr>
-              <a:t>     </a:t>
+              <a:t>    </a:t>
             </a:r>
             <a:endParaRPr lang="en-US" altLang="zh-CN" sz="800" b="1" dirty="0">
               <a:latin typeface="阿里巴巴普惠体 R" panose="00020600040101010101" pitchFamily="18" charset="-122"/>
@@ -4911,11 +4524,319 @@
             </a:endParaRPr>
           </a:p>
           <a:p>
+            <a:pPr indent="0" fontAlgn="auto">
+              <a:lnSpc>
+                <a:spcPct val="200000"/>
+              </a:lnSpc>
+            </a:pPr>
+            <a:r>
+              <a:rPr lang="en-US" altLang="zh-CN" sz="800" b="1" dirty="0">
+                <a:latin typeface="宋体" panose="02010600030101010101" pitchFamily="2" charset="-122"/>
+                <a:ea typeface="宋体" panose="02010600030101010101" pitchFamily="2" charset="-122"/>
+                <a:cs typeface="宋体" panose="02010600030101010101" pitchFamily="2" charset="-122"/>
+              </a:rPr>
+              <a:t>ArcHat </a:t>
+            </a:r>
+            <a:r>
+              <a:rPr lang="zh-CN" altLang="en-US" sz="800" b="1" dirty="0">
+                <a:latin typeface="宋体" panose="02010600030101010101" pitchFamily="2" charset="-122"/>
+                <a:ea typeface="宋体" panose="02010600030101010101" pitchFamily="2" charset="-122"/>
+                <a:cs typeface="宋体" panose="02010600030101010101" pitchFamily="2" charset="-122"/>
+              </a:rPr>
+              <a:t>通讯协作平台</a:t>
+            </a:r>
+            <a:r>
+              <a:rPr lang="en-US" altLang="zh-CN" sz="800" b="1" dirty="0">
+                <a:latin typeface="宋体" panose="02010600030101010101" pitchFamily="2" charset="-122"/>
+                <a:ea typeface="宋体" panose="02010600030101010101" pitchFamily="2" charset="-122"/>
+                <a:cs typeface="宋体" panose="02010600030101010101" pitchFamily="2" charset="-122"/>
+              </a:rPr>
+              <a:t> --</a:t>
+            </a:r>
+            <a:r>
+              <a:rPr lang="zh-CN" altLang="en-US" sz="800" b="1" dirty="0">
+                <a:latin typeface="宋体" panose="02010600030101010101" pitchFamily="2" charset="-122"/>
+                <a:ea typeface="宋体" panose="02010600030101010101" pitchFamily="2" charset="-122"/>
+                <a:cs typeface="宋体" panose="02010600030101010101" pitchFamily="2" charset="-122"/>
+              </a:rPr>
+              <a:t>前后端开发</a:t>
+            </a:r>
+            <a:r>
+              <a:rPr lang="en-US" altLang="zh-CN" sz="800" b="1" dirty="0">
+                <a:latin typeface="宋体" panose="02010600030101010101" pitchFamily="2" charset="-122"/>
+                <a:ea typeface="宋体" panose="02010600030101010101" pitchFamily="2" charset="-122"/>
+                <a:cs typeface="宋体" panose="02010600030101010101" pitchFamily="2" charset="-122"/>
+              </a:rPr>
+              <a:t>							</a:t>
+            </a:r>
+            <a:endParaRPr lang="en-US" altLang="zh-CN" sz="800" b="1" dirty="0">
+              <a:latin typeface="宋体" panose="02010600030101010101" pitchFamily="2" charset="-122"/>
+              <a:ea typeface="宋体" panose="02010600030101010101" pitchFamily="2" charset="-122"/>
+              <a:cs typeface="宋体" panose="02010600030101010101" pitchFamily="2" charset="-122"/>
+            </a:endParaRPr>
+          </a:p>
+          <a:p>
             <a:pPr>
               <a:lnSpc>
                 <a:spcPts val="1520"/>
               </a:lnSpc>
             </a:pPr>
+            <a:r>
+              <a:rPr lang="zh-CN" altLang="en-US" sz="800" b="1" dirty="0">
+                <a:latin typeface="宋体" panose="02010600030101010101" pitchFamily="2" charset="-122"/>
+                <a:ea typeface="宋体" panose="02010600030101010101" pitchFamily="2" charset="-122"/>
+                <a:cs typeface="宋体" panose="02010600030101010101" pitchFamily="2" charset="-122"/>
+              </a:rPr>
+              <a:t>项目描述</a:t>
+            </a:r>
+            <a:r>
+              <a:rPr lang="en-US" altLang="zh-CN" sz="800" b="1" dirty="0">
+                <a:latin typeface="宋体" panose="02010600030101010101" pitchFamily="2" charset="-122"/>
+                <a:ea typeface="宋体" panose="02010600030101010101" pitchFamily="2" charset="-122"/>
+                <a:cs typeface="宋体" panose="02010600030101010101" pitchFamily="2" charset="-122"/>
+              </a:rPr>
+              <a:t>: </a:t>
+            </a:r>
+            <a:r>
+              <a:rPr lang="zh-CN" altLang="en-US" sz="800" dirty="0">
+                <a:latin typeface="宋体" panose="02010600030101010101" pitchFamily="2" charset="-122"/>
+                <a:ea typeface="宋体" panose="02010600030101010101" pitchFamily="2" charset="-122"/>
+                <a:cs typeface="宋体" panose="02010600030101010101" pitchFamily="2" charset="-122"/>
+              </a:rPr>
+              <a:t>一款仿飞书的企业级通讯与协作平台，集私聊、群聊与安全权限管理于一体，支持接口</a:t>
+            </a:r>
+            <a:r>
+              <a:rPr lang="zh-CN" altLang="en-US" sz="800" dirty="0">
+                <a:latin typeface="宋体" panose="02010600030101010101" pitchFamily="2" charset="-122"/>
+                <a:ea typeface="宋体" panose="02010600030101010101" pitchFamily="2" charset="-122"/>
+                <a:cs typeface="宋体" panose="02010600030101010101" pitchFamily="2" charset="-122"/>
+              </a:rPr>
+              <a:t>多维限流、敏感词过滤、会话管理、消息实时推送、语音通话、以及智能 </a:t>
+            </a:r>
+            <a:r>
+              <a:rPr lang="en-US" altLang="zh-CN" sz="800" dirty="0">
+                <a:latin typeface="宋体" panose="02010600030101010101" pitchFamily="2" charset="-122"/>
+                <a:ea typeface="宋体" panose="02010600030101010101" pitchFamily="2" charset="-122"/>
+                <a:cs typeface="宋体" panose="02010600030101010101" pitchFamily="2" charset="-122"/>
+              </a:rPr>
+              <a:t>AI </a:t>
+            </a:r>
+            <a:r>
+              <a:rPr lang="zh-CN" altLang="en-US" sz="800" dirty="0">
+                <a:latin typeface="宋体" panose="02010600030101010101" pitchFamily="2" charset="-122"/>
+                <a:ea typeface="宋体" panose="02010600030101010101" pitchFamily="2" charset="-122"/>
+                <a:cs typeface="宋体" panose="02010600030101010101" pitchFamily="2" charset="-122"/>
+              </a:rPr>
+              <a:t>助手，旨在提升团队沟通效率与协作体验。</a:t>
+            </a:r>
+            <a:endParaRPr lang="en-US" altLang="zh-CN" sz="800" dirty="0">
+              <a:latin typeface="宋体" panose="02010600030101010101" pitchFamily="2" charset="-122"/>
+              <a:ea typeface="宋体" panose="02010600030101010101" pitchFamily="2" charset="-122"/>
+              <a:cs typeface="宋体" panose="02010600030101010101" pitchFamily="2" charset="-122"/>
+            </a:endParaRPr>
+          </a:p>
+          <a:p>
+            <a:pPr>
+              <a:lnSpc>
+                <a:spcPts val="1520"/>
+              </a:lnSpc>
+            </a:pPr>
+            <a:r>
+              <a:rPr lang="zh-CN" altLang="en-US" sz="800" b="1" dirty="0">
+                <a:latin typeface="宋体" panose="02010600030101010101" pitchFamily="2" charset="-122"/>
+                <a:ea typeface="宋体" panose="02010600030101010101" pitchFamily="2" charset="-122"/>
+                <a:cs typeface="宋体" panose="02010600030101010101" pitchFamily="2" charset="-122"/>
+              </a:rPr>
+              <a:t>核心技术</a:t>
+            </a:r>
+            <a:r>
+              <a:rPr lang="en-US" altLang="zh-CN" sz="800" b="1" dirty="0">
+                <a:latin typeface="宋体" panose="02010600030101010101" pitchFamily="2" charset="-122"/>
+                <a:ea typeface="宋体" panose="02010600030101010101" pitchFamily="2" charset="-122"/>
+                <a:cs typeface="宋体" panose="02010600030101010101" pitchFamily="2" charset="-122"/>
+              </a:rPr>
+              <a:t>: </a:t>
+            </a:r>
+            <a:r>
+              <a:rPr lang="en-US" altLang="zh-CN" sz="800" dirty="0">
+                <a:latin typeface="宋体" panose="02010600030101010101" pitchFamily="2" charset="-122"/>
+                <a:ea typeface="宋体" panose="02010600030101010101" pitchFamily="2" charset="-122"/>
+                <a:cs typeface="宋体" panose="02010600030101010101" pitchFamily="2" charset="-122"/>
+              </a:rPr>
+              <a:t>SpringBoot3, </a:t>
+            </a:r>
+            <a:r>
+              <a:rPr lang="en-US" altLang="zh-CN" sz="800" dirty="0" err="1">
+                <a:latin typeface="宋体" panose="02010600030101010101" pitchFamily="2" charset="-122"/>
+                <a:ea typeface="宋体" panose="02010600030101010101" pitchFamily="2" charset="-122"/>
+                <a:cs typeface="宋体" panose="02010600030101010101" pitchFamily="2" charset="-122"/>
+              </a:rPr>
+              <a:t>MyBatis</a:t>
+            </a:r>
+            <a:r>
+              <a:rPr lang="en-US" altLang="zh-CN" sz="800" dirty="0">
+                <a:latin typeface="宋体" panose="02010600030101010101" pitchFamily="2" charset="-122"/>
+                <a:ea typeface="宋体" panose="02010600030101010101" pitchFamily="2" charset="-122"/>
+                <a:cs typeface="宋体" panose="02010600030101010101" pitchFamily="2" charset="-122"/>
+              </a:rPr>
+              <a:t> Plus</a:t>
+            </a:r>
+            <a:r>
+              <a:rPr lang="zh-CN" altLang="en-US" sz="800" dirty="0">
+                <a:latin typeface="宋体" panose="02010600030101010101" pitchFamily="2" charset="-122"/>
+                <a:ea typeface="宋体" panose="02010600030101010101" pitchFamily="2" charset="-122"/>
+                <a:cs typeface="宋体" panose="02010600030101010101" pitchFamily="2" charset="-122"/>
+              </a:rPr>
+              <a:t>，</a:t>
+            </a:r>
+            <a:r>
+              <a:rPr lang="en-US" altLang="zh-CN" sz="800" dirty="0">
+                <a:latin typeface="宋体" panose="02010600030101010101" pitchFamily="2" charset="-122"/>
+                <a:ea typeface="宋体" panose="02010600030101010101" pitchFamily="2" charset="-122"/>
+                <a:cs typeface="宋体" panose="02010600030101010101" pitchFamily="2" charset="-122"/>
+              </a:rPr>
+              <a:t>Netty</a:t>
+            </a:r>
+            <a:r>
+              <a:rPr lang="zh-CN" altLang="en-US" sz="800" dirty="0">
+                <a:latin typeface="宋体" panose="02010600030101010101" pitchFamily="2" charset="-122"/>
+                <a:ea typeface="宋体" panose="02010600030101010101" pitchFamily="2" charset="-122"/>
+                <a:cs typeface="宋体" panose="02010600030101010101" pitchFamily="2" charset="-122"/>
+              </a:rPr>
+              <a:t>，</a:t>
+            </a:r>
+            <a:r>
+              <a:rPr lang="en-US" altLang="zh-CN" sz="800" dirty="0">
+                <a:latin typeface="宋体" panose="02010600030101010101" pitchFamily="2" charset="-122"/>
+                <a:ea typeface="宋体" panose="02010600030101010101" pitchFamily="2" charset="-122"/>
+                <a:cs typeface="宋体" panose="02010600030101010101" pitchFamily="2" charset="-122"/>
+              </a:rPr>
+              <a:t>WebRTC</a:t>
+            </a:r>
+            <a:r>
+              <a:rPr lang="zh-CN" altLang="en-US" sz="800" dirty="0">
+                <a:latin typeface="宋体" panose="02010600030101010101" pitchFamily="2" charset="-122"/>
+                <a:ea typeface="宋体" panose="02010600030101010101" pitchFamily="2" charset="-122"/>
+                <a:cs typeface="宋体" panose="02010600030101010101" pitchFamily="2" charset="-122"/>
+              </a:rPr>
+              <a:t>、</a:t>
+            </a:r>
+            <a:r>
+              <a:rPr lang="en-US" altLang="zh-CN" sz="800" dirty="0">
+                <a:latin typeface="宋体" panose="02010600030101010101" pitchFamily="2" charset="-122"/>
+                <a:ea typeface="宋体" panose="02010600030101010101" pitchFamily="2" charset="-122"/>
+                <a:cs typeface="宋体" panose="02010600030101010101" pitchFamily="2" charset="-122"/>
+              </a:rPr>
+              <a:t>RabbitMQ</a:t>
+            </a:r>
+            <a:r>
+              <a:rPr lang="zh-CN" altLang="en-US" sz="800" dirty="0">
+                <a:latin typeface="宋体" panose="02010600030101010101" pitchFamily="2" charset="-122"/>
+                <a:ea typeface="宋体" panose="02010600030101010101" pitchFamily="2" charset="-122"/>
+                <a:cs typeface="宋体" panose="02010600030101010101" pitchFamily="2" charset="-122"/>
+              </a:rPr>
+              <a:t>，</a:t>
+            </a:r>
+            <a:r>
+              <a:rPr lang="en-US" altLang="zh-CN" sz="800" dirty="0">
+                <a:latin typeface="宋体" panose="02010600030101010101" pitchFamily="2" charset="-122"/>
+                <a:ea typeface="宋体" panose="02010600030101010101" pitchFamily="2" charset="-122"/>
+                <a:cs typeface="宋体" panose="02010600030101010101" pitchFamily="2" charset="-122"/>
+              </a:rPr>
+              <a:t>Docker</a:t>
+            </a:r>
+            <a:r>
+              <a:rPr lang="zh-CN" altLang="en-US" sz="800" dirty="0">
+                <a:latin typeface="宋体" panose="02010600030101010101" pitchFamily="2" charset="-122"/>
+                <a:ea typeface="宋体" panose="02010600030101010101" pitchFamily="2" charset="-122"/>
+                <a:cs typeface="宋体" panose="02010600030101010101" pitchFamily="2" charset="-122"/>
+              </a:rPr>
+              <a:t>，</a:t>
+            </a:r>
+            <a:r>
+              <a:rPr lang="en-US" altLang="zh-CN" sz="800" dirty="0">
+                <a:latin typeface="宋体" panose="02010600030101010101" pitchFamily="2" charset="-122"/>
+                <a:ea typeface="宋体" panose="02010600030101010101" pitchFamily="2" charset="-122"/>
+                <a:cs typeface="宋体" panose="02010600030101010101" pitchFamily="2" charset="-122"/>
+              </a:rPr>
+              <a:t>Nginx</a:t>
+            </a:r>
+            <a:r>
+              <a:rPr lang="zh-CN" altLang="en-US" sz="800" dirty="0">
+                <a:latin typeface="宋体" panose="02010600030101010101" pitchFamily="2" charset="-122"/>
+                <a:ea typeface="宋体" panose="02010600030101010101" pitchFamily="2" charset="-122"/>
+                <a:cs typeface="宋体" panose="02010600030101010101" pitchFamily="2" charset="-122"/>
+              </a:rPr>
+              <a:t>，</a:t>
+            </a:r>
+            <a:r>
+              <a:rPr lang="en-US" altLang="zh-CN" sz="800" dirty="0">
+                <a:latin typeface="宋体" panose="02010600030101010101" pitchFamily="2" charset="-122"/>
+                <a:ea typeface="宋体" panose="02010600030101010101" pitchFamily="2" charset="-122"/>
+                <a:cs typeface="宋体" panose="02010600030101010101" pitchFamily="2" charset="-122"/>
+              </a:rPr>
+              <a:t>Redis</a:t>
+            </a:r>
+            <a:r>
+              <a:rPr lang="zh-CN" altLang="en-US" sz="800" dirty="0">
+                <a:latin typeface="宋体" panose="02010600030101010101" pitchFamily="2" charset="-122"/>
+                <a:ea typeface="宋体" panose="02010600030101010101" pitchFamily="2" charset="-122"/>
+                <a:cs typeface="宋体" panose="02010600030101010101" pitchFamily="2" charset="-122"/>
+              </a:rPr>
+              <a:t>，</a:t>
+            </a:r>
+            <a:r>
+              <a:rPr lang="en-US" altLang="zh-CN" sz="800" dirty="0">
+                <a:latin typeface="宋体" panose="02010600030101010101" pitchFamily="2" charset="-122"/>
+                <a:ea typeface="宋体" panose="02010600030101010101" pitchFamily="2" charset="-122"/>
+                <a:cs typeface="宋体" panose="02010600030101010101" pitchFamily="2" charset="-122"/>
+              </a:rPr>
+              <a:t>JWT</a:t>
+            </a:r>
+            <a:r>
+              <a:rPr lang="zh-CN" altLang="en-US" sz="800" dirty="0">
+                <a:latin typeface="宋体" panose="02010600030101010101" pitchFamily="2" charset="-122"/>
+                <a:ea typeface="宋体" panose="02010600030101010101" pitchFamily="2" charset="-122"/>
+                <a:cs typeface="宋体" panose="02010600030101010101" pitchFamily="2" charset="-122"/>
+              </a:rPr>
+              <a:t>，</a:t>
+            </a:r>
+            <a:r>
+              <a:rPr lang="en-US" altLang="zh-CN" sz="800" dirty="0">
+                <a:latin typeface="宋体" panose="02010600030101010101" pitchFamily="2" charset="-122"/>
+                <a:ea typeface="宋体" panose="02010600030101010101" pitchFamily="2" charset="-122"/>
+                <a:cs typeface="宋体" panose="02010600030101010101" pitchFamily="2" charset="-122"/>
+              </a:rPr>
+              <a:t>langchain4j</a:t>
+            </a:r>
+            <a:endParaRPr lang="en-US" altLang="zh-CN" sz="800" dirty="0">
+              <a:latin typeface="宋体" panose="02010600030101010101" pitchFamily="2" charset="-122"/>
+              <a:ea typeface="宋体" panose="02010600030101010101" pitchFamily="2" charset="-122"/>
+              <a:cs typeface="宋体" panose="02010600030101010101" pitchFamily="2" charset="-122"/>
+            </a:endParaRPr>
+          </a:p>
+          <a:p>
+            <a:pPr>
+              <a:lnSpc>
+                <a:spcPts val="1520"/>
+              </a:lnSpc>
+            </a:pPr>
+            <a:r>
+              <a:rPr lang="zh-CN" altLang="en-US" sz="800" b="1" dirty="0">
+                <a:latin typeface="宋体" panose="02010600030101010101" pitchFamily="2" charset="-122"/>
+                <a:ea typeface="宋体" panose="02010600030101010101" pitchFamily="2" charset="-122"/>
+                <a:cs typeface="宋体" panose="02010600030101010101" pitchFamily="2" charset="-122"/>
+              </a:rPr>
+              <a:t>核心职责</a:t>
+            </a:r>
+            <a:r>
+              <a:rPr lang="en-US" altLang="zh-CN" sz="800" b="1" dirty="0">
+                <a:latin typeface="宋体" panose="02010600030101010101" pitchFamily="2" charset="-122"/>
+                <a:ea typeface="宋体" panose="02010600030101010101" pitchFamily="2" charset="-122"/>
+                <a:cs typeface="宋体" panose="02010600030101010101" pitchFamily="2" charset="-122"/>
+              </a:rPr>
+              <a:t>:</a:t>
+            </a:r>
             <a:endParaRPr lang="en-US" altLang="zh-CN" sz="800" b="1" dirty="0">
               <a:latin typeface="宋体" panose="02010600030101010101" pitchFamily="2" charset="-122"/>
               <a:ea typeface="宋体" panose="02010600030101010101" pitchFamily="2" charset="-122"/>
@@ -4934,7 +4855,7 @@
                 <a:ea typeface="宋体" panose="02010600030101010101" pitchFamily="2" charset="-122"/>
                 <a:cs typeface="宋体" panose="02010600030101010101" pitchFamily="2" charset="-122"/>
               </a:rPr>
-              <a:t>ArcHat </a:t>
+              <a:t>	</a:t>
             </a:r>
             <a:r>
               <a:rPr lang="zh-CN" altLang="en-US" sz="800" b="1" dirty="0">
@@ -4942,7 +4863,7 @@
                 <a:ea typeface="宋体" panose="02010600030101010101" pitchFamily="2" charset="-122"/>
                 <a:cs typeface="宋体" panose="02010600030101010101" pitchFamily="2" charset="-122"/>
               </a:rPr>
-              <a:t>通讯协作平台</a:t>
+              <a:t>消息推送</a:t>
             </a:r>
             <a:r>
               <a:rPr lang="en-US" altLang="zh-CN" sz="800" b="1" dirty="0">
@@ -4950,7 +4871,7 @@
                 <a:ea typeface="宋体" panose="02010600030101010101" pitchFamily="2" charset="-122"/>
                 <a:cs typeface="宋体" panose="02010600030101010101" pitchFamily="2" charset="-122"/>
               </a:rPr>
-              <a:t> --</a:t>
+              <a:t>/</a:t>
             </a:r>
             <a:r>
               <a:rPr lang="zh-CN" altLang="en-US" sz="800" b="1" dirty="0">
@@ -4958,7 +4879,91 @@
                 <a:ea typeface="宋体" panose="02010600030101010101" pitchFamily="2" charset="-122"/>
                 <a:cs typeface="宋体" panose="02010600030101010101" pitchFamily="2" charset="-122"/>
               </a:rPr>
-              <a:t>前后端开发</a:t>
+              <a:t>处理：</a:t>
+            </a:r>
+            <a:r>
+              <a:rPr lang="zh-CN" altLang="en-US" sz="800" dirty="0">
+                <a:latin typeface="宋体" panose="02010600030101010101" pitchFamily="2" charset="-122"/>
+                <a:ea typeface="宋体" panose="02010600030101010101" pitchFamily="2" charset="-122"/>
+                <a:cs typeface="宋体" panose="02010600030101010101" pitchFamily="2" charset="-122"/>
+              </a:rPr>
+              <a:t>基于</a:t>
+            </a:r>
+            <a:r>
+              <a:rPr lang="en-US" altLang="zh-CN" sz="800" dirty="0">
+                <a:latin typeface="宋体" panose="02010600030101010101" pitchFamily="2" charset="-122"/>
+                <a:ea typeface="宋体" panose="02010600030101010101" pitchFamily="2" charset="-122"/>
+                <a:cs typeface="宋体" panose="02010600030101010101" pitchFamily="2" charset="-122"/>
+              </a:rPr>
+              <a:t>Netty</a:t>
+            </a:r>
+            <a:r>
+              <a:rPr lang="zh-CN" altLang="en-US" sz="800" dirty="0">
+                <a:latin typeface="宋体" panose="02010600030101010101" pitchFamily="2" charset="-122"/>
+                <a:ea typeface="宋体" panose="02010600030101010101" pitchFamily="2" charset="-122"/>
+                <a:cs typeface="宋体" panose="02010600030101010101" pitchFamily="2" charset="-122"/>
+              </a:rPr>
+              <a:t>构建长连接服务，支持私聊</a:t>
+            </a:r>
+            <a:r>
+              <a:rPr lang="en-US" altLang="zh-CN" sz="800" dirty="0">
+                <a:latin typeface="宋体" panose="02010600030101010101" pitchFamily="2" charset="-122"/>
+                <a:ea typeface="宋体" panose="02010600030101010101" pitchFamily="2" charset="-122"/>
+                <a:cs typeface="宋体" panose="02010600030101010101" pitchFamily="2" charset="-122"/>
+              </a:rPr>
+              <a:t>/</a:t>
+            </a:r>
+            <a:r>
+              <a:rPr lang="zh-CN" altLang="en-US" sz="800" dirty="0">
+                <a:latin typeface="宋体" panose="02010600030101010101" pitchFamily="2" charset="-122"/>
+                <a:ea typeface="宋体" panose="02010600030101010101" pitchFamily="2" charset="-122"/>
+                <a:cs typeface="宋体" panose="02010600030101010101" pitchFamily="2" charset="-122"/>
+              </a:rPr>
+              <a:t>群聊消息的实时分发</a:t>
+            </a:r>
+            <a:r>
+              <a:rPr lang="zh-CN" altLang="en-US" sz="800" b="1" dirty="0">
+                <a:latin typeface="宋体" panose="02010600030101010101" pitchFamily="2" charset="-122"/>
+                <a:ea typeface="宋体" panose="02010600030101010101" pitchFamily="2" charset="-122"/>
+                <a:cs typeface="宋体" panose="02010600030101010101" pitchFamily="2" charset="-122"/>
+              </a:rPr>
+              <a:t>。抽象消息处理器</a:t>
+            </a:r>
+            <a:r>
+              <a:rPr lang="zh-CN" altLang="en-US" sz="800" dirty="0">
+                <a:latin typeface="宋体" panose="02010600030101010101" pitchFamily="2" charset="-122"/>
+                <a:ea typeface="宋体" panose="02010600030101010101" pitchFamily="2" charset="-122"/>
+                <a:cs typeface="宋体" panose="02010600030101010101" pitchFamily="2" charset="-122"/>
+              </a:rPr>
+              <a:t>基类，</a:t>
+            </a:r>
+            <a:endParaRPr lang="en-US" altLang="zh-CN" sz="800" dirty="0">
+              <a:latin typeface="宋体" panose="02010600030101010101" pitchFamily="2" charset="-122"/>
+              <a:ea typeface="宋体" panose="02010600030101010101" pitchFamily="2" charset="-122"/>
+              <a:cs typeface="宋体" panose="02010600030101010101" pitchFamily="2" charset="-122"/>
+            </a:endParaRPr>
+          </a:p>
+          <a:p>
+            <a:pPr>
+              <a:lnSpc>
+                <a:spcPts val="1520"/>
+              </a:lnSpc>
+            </a:pPr>
+            <a:r>
+              <a:rPr lang="en-US" altLang="zh-CN" sz="800" dirty="0">
+                <a:latin typeface="宋体" panose="02010600030101010101" pitchFamily="2" charset="-122"/>
+                <a:ea typeface="宋体" panose="02010600030101010101" pitchFamily="2" charset="-122"/>
+                <a:cs typeface="宋体" panose="02010600030101010101" pitchFamily="2" charset="-122"/>
+              </a:rPr>
+              <a:t>	</a:t>
+            </a:r>
+            <a:r>
+              <a:rPr lang="zh-CN" altLang="en-US" sz="800" dirty="0">
+                <a:latin typeface="宋体" panose="02010600030101010101" pitchFamily="2" charset="-122"/>
+                <a:ea typeface="宋体" panose="02010600030101010101" pitchFamily="2" charset="-122"/>
+                <a:cs typeface="宋体" panose="02010600030101010101" pitchFamily="2" charset="-122"/>
+              </a:rPr>
+              <a:t>结合 </a:t>
             </a:r>
             <a:r>
               <a:rPr lang="en-US" altLang="zh-CN" sz="800" b="1" dirty="0">
@@ -4966,7 +4971,395 @@
                 <a:ea typeface="宋体" panose="02010600030101010101" pitchFamily="2" charset="-122"/>
                 <a:cs typeface="宋体" panose="02010600030101010101" pitchFamily="2" charset="-122"/>
               </a:rPr>
-              <a:t>							</a:t>
+              <a:t>Spring </a:t>
+            </a:r>
+            <a:r>
+              <a:rPr lang="zh-CN" altLang="en-US" sz="800" b="1" dirty="0">
+                <a:latin typeface="宋体" panose="02010600030101010101" pitchFamily="2" charset="-122"/>
+                <a:ea typeface="宋体" panose="02010600030101010101" pitchFamily="2" charset="-122"/>
+                <a:cs typeface="宋体" panose="02010600030101010101" pitchFamily="2" charset="-122"/>
+              </a:rPr>
+              <a:t>容器注册机制</a:t>
+            </a:r>
+            <a:r>
+              <a:rPr lang="zh-CN" altLang="en-US" sz="800" dirty="0">
+                <a:latin typeface="宋体" panose="02010600030101010101" pitchFamily="2" charset="-122"/>
+                <a:ea typeface="宋体" panose="02010600030101010101" pitchFamily="2" charset="-122"/>
+                <a:cs typeface="宋体" panose="02010600030101010101" pitchFamily="2" charset="-122"/>
+              </a:rPr>
+              <a:t>，支持</a:t>
+            </a:r>
+            <a:r>
+              <a:rPr lang="zh-CN" altLang="en-US" sz="800" b="1" dirty="0">
+                <a:latin typeface="宋体" panose="02010600030101010101" pitchFamily="2" charset="-122"/>
+                <a:ea typeface="宋体" panose="02010600030101010101" pitchFamily="2" charset="-122"/>
+                <a:cs typeface="宋体" panose="02010600030101010101" pitchFamily="2" charset="-122"/>
+              </a:rPr>
+              <a:t>多种消息类型</a:t>
+            </a:r>
+            <a:r>
+              <a:rPr lang="zh-CN" altLang="en-US" sz="800" dirty="0">
+                <a:latin typeface="宋体" panose="02010600030101010101" pitchFamily="2" charset="-122"/>
+                <a:ea typeface="宋体" panose="02010600030101010101" pitchFamily="2" charset="-122"/>
+                <a:cs typeface="宋体" panose="02010600030101010101" pitchFamily="2" charset="-122"/>
+              </a:rPr>
+              <a:t>（文本、图片、文件）动态分发与处理，利用</a:t>
+            </a:r>
+            <a:r>
+              <a:rPr lang="zh-CN" altLang="en-US" sz="800" b="1" dirty="0">
+                <a:latin typeface="宋体" panose="02010600030101010101" pitchFamily="2" charset="-122"/>
+                <a:ea typeface="宋体" panose="02010600030101010101" pitchFamily="2" charset="-122"/>
+                <a:cs typeface="宋体" panose="02010600030101010101" pitchFamily="2" charset="-122"/>
+              </a:rPr>
+              <a:t>策略模式</a:t>
+            </a:r>
+            <a:r>
+              <a:rPr lang="zh-CN" altLang="en-US" sz="800" dirty="0">
+                <a:latin typeface="宋体" panose="02010600030101010101" pitchFamily="2" charset="-122"/>
+                <a:ea typeface="宋体" panose="02010600030101010101" pitchFamily="2" charset="-122"/>
+                <a:cs typeface="宋体" panose="02010600030101010101" pitchFamily="2" charset="-122"/>
+              </a:rPr>
+              <a:t>实现</a:t>
+            </a:r>
+            <a:r>
+              <a:rPr lang="zh-CN" altLang="en-US" sz="800" b="1" dirty="0">
+                <a:latin typeface="宋体" panose="02010600030101010101" pitchFamily="2" charset="-122"/>
+                <a:ea typeface="宋体" panose="02010600030101010101" pitchFamily="2" charset="-122"/>
+                <a:cs typeface="宋体" panose="02010600030101010101" pitchFamily="2" charset="-122"/>
+              </a:rPr>
+              <a:t>高可扩展性。</a:t>
+            </a:r>
+            <a:r>
+              <a:rPr lang="en-US" altLang="zh-CN" sz="800" dirty="0">
+                <a:latin typeface="宋体" panose="02010600030101010101" pitchFamily="2" charset="-122"/>
+                <a:ea typeface="宋体" panose="02010600030101010101" pitchFamily="2" charset="-122"/>
+                <a:cs typeface="宋体" panose="02010600030101010101" pitchFamily="2" charset="-122"/>
+              </a:rPr>
+              <a:t>	</a:t>
+            </a:r>
+            <a:endParaRPr lang="en-US" altLang="zh-CN" sz="800" dirty="0">
+              <a:latin typeface="宋体" panose="02010600030101010101" pitchFamily="2" charset="-122"/>
+              <a:ea typeface="宋体" panose="02010600030101010101" pitchFamily="2" charset="-122"/>
+              <a:cs typeface="宋体" panose="02010600030101010101" pitchFamily="2" charset="-122"/>
+            </a:endParaRPr>
+          </a:p>
+          <a:p>
+            <a:pPr>
+              <a:lnSpc>
+                <a:spcPts val="1520"/>
+              </a:lnSpc>
+            </a:pPr>
+            <a:r>
+              <a:rPr lang="en-US" altLang="zh-CN" sz="800" dirty="0">
+                <a:latin typeface="宋体" panose="02010600030101010101" pitchFamily="2" charset="-122"/>
+                <a:ea typeface="宋体" panose="02010600030101010101" pitchFamily="2" charset="-122"/>
+                <a:cs typeface="宋体" panose="02010600030101010101" pitchFamily="2" charset="-122"/>
+              </a:rPr>
+              <a:t>	</a:t>
+            </a:r>
+            <a:r>
+              <a:rPr lang="en-US" altLang="zh-CN" sz="800" b="1" dirty="0">
+                <a:latin typeface="宋体" panose="02010600030101010101" pitchFamily="2" charset="-122"/>
+                <a:ea typeface="宋体" panose="02010600030101010101" pitchFamily="2" charset="-122"/>
+                <a:cs typeface="宋体" panose="02010600030101010101" pitchFamily="2" charset="-122"/>
+              </a:rPr>
+              <a:t>AI Chat</a:t>
+            </a:r>
+            <a:r>
+              <a:rPr lang="zh-CN" altLang="en-US" sz="800" b="1" dirty="0">
+                <a:latin typeface="宋体" panose="02010600030101010101" pitchFamily="2" charset="-122"/>
+                <a:ea typeface="宋体" panose="02010600030101010101" pitchFamily="2" charset="-122"/>
+                <a:cs typeface="宋体" panose="02010600030101010101" pitchFamily="2" charset="-122"/>
+              </a:rPr>
+              <a:t>集成：</a:t>
+            </a:r>
+            <a:r>
+              <a:rPr lang="zh-CN" altLang="en-US" sz="800" dirty="0">
+                <a:latin typeface="宋体" panose="02010600030101010101" pitchFamily="2" charset="-122"/>
+                <a:ea typeface="宋体" panose="02010600030101010101" pitchFamily="2" charset="-122"/>
+                <a:cs typeface="宋体" panose="02010600030101010101" pitchFamily="2" charset="-122"/>
+              </a:rPr>
+              <a:t>使用 </a:t>
+            </a:r>
+            <a:r>
+              <a:rPr lang="en-US" altLang="zh-CN" sz="800" b="1" dirty="0">
+                <a:latin typeface="宋体" panose="02010600030101010101" pitchFamily="2" charset="-122"/>
+                <a:ea typeface="宋体" panose="02010600030101010101" pitchFamily="2" charset="-122"/>
+                <a:cs typeface="宋体" panose="02010600030101010101" pitchFamily="2" charset="-122"/>
+              </a:rPr>
+              <a:t>Langchain4j </a:t>
+            </a:r>
+            <a:r>
+              <a:rPr lang="zh-CN" altLang="en-US" sz="800" dirty="0">
+                <a:latin typeface="宋体" panose="02010600030101010101" pitchFamily="2" charset="-122"/>
+                <a:ea typeface="宋体" panose="02010600030101010101" pitchFamily="2" charset="-122"/>
+                <a:cs typeface="宋体" panose="02010600030101010101" pitchFamily="2" charset="-122"/>
+              </a:rPr>
+              <a:t>，集成到项目中开发</a:t>
+            </a:r>
+            <a:r>
+              <a:rPr lang="en-US" altLang="zh-CN" sz="800" dirty="0">
+                <a:latin typeface="宋体" panose="02010600030101010101" pitchFamily="2" charset="-122"/>
+                <a:ea typeface="宋体" panose="02010600030101010101" pitchFamily="2" charset="-122"/>
+                <a:cs typeface="宋体" panose="02010600030101010101" pitchFamily="2" charset="-122"/>
+              </a:rPr>
+              <a:t>AI</a:t>
+            </a:r>
+            <a:r>
+              <a:rPr lang="zh-CN" altLang="en-US" sz="800" dirty="0">
+                <a:latin typeface="宋体" panose="02010600030101010101" pitchFamily="2" charset="-122"/>
+                <a:ea typeface="宋体" panose="02010600030101010101" pitchFamily="2" charset="-122"/>
+                <a:cs typeface="宋体" panose="02010600030101010101" pitchFamily="2" charset="-122"/>
+              </a:rPr>
+              <a:t>助手，实现多轮对话，记忆持久化</a:t>
+            </a:r>
+            <a:r>
+              <a:rPr lang="en-US" altLang="zh-CN" sz="800" dirty="0">
+                <a:latin typeface="宋体" panose="02010600030101010101" pitchFamily="2" charset="-122"/>
+                <a:ea typeface="宋体" panose="02010600030101010101" pitchFamily="2" charset="-122"/>
+                <a:cs typeface="宋体" panose="02010600030101010101" pitchFamily="2" charset="-122"/>
+              </a:rPr>
+              <a:t>, </a:t>
+            </a:r>
+            <a:r>
+              <a:rPr lang="zh-CN" altLang="en-US" sz="800" dirty="0">
+                <a:latin typeface="宋体" panose="02010600030101010101" pitchFamily="2" charset="-122"/>
+                <a:ea typeface="宋体" panose="02010600030101010101" pitchFamily="2" charset="-122"/>
+                <a:cs typeface="宋体" panose="02010600030101010101" pitchFamily="2" charset="-122"/>
+              </a:rPr>
+              <a:t>会话隔离，</a:t>
+            </a:r>
+            <a:r>
+              <a:rPr lang="en-US" altLang="zh-CN" sz="800" dirty="0">
+                <a:latin typeface="宋体" panose="02010600030101010101" pitchFamily="2" charset="-122"/>
+                <a:ea typeface="宋体" panose="02010600030101010101" pitchFamily="2" charset="-122"/>
+                <a:cs typeface="宋体" panose="02010600030101010101" pitchFamily="2" charset="-122"/>
+              </a:rPr>
+              <a:t> RAG</a:t>
+            </a:r>
+            <a:r>
+              <a:rPr lang="zh-CN" altLang="en-US" sz="800" dirty="0">
+                <a:latin typeface="宋体" panose="02010600030101010101" pitchFamily="2" charset="-122"/>
+                <a:ea typeface="宋体" panose="02010600030101010101" pitchFamily="2" charset="-122"/>
+                <a:cs typeface="宋体" panose="02010600030101010101" pitchFamily="2" charset="-122"/>
+              </a:rPr>
+              <a:t>知识库导入。</a:t>
+            </a:r>
+            <a:r>
+              <a:rPr lang="en-US" altLang="zh-CN" sz="800" dirty="0">
+                <a:latin typeface="宋体" panose="02010600030101010101" pitchFamily="2" charset="-122"/>
+                <a:ea typeface="宋体" panose="02010600030101010101" pitchFamily="2" charset="-122"/>
+                <a:cs typeface="宋体" panose="02010600030101010101" pitchFamily="2" charset="-122"/>
+              </a:rPr>
+              <a:t>	</a:t>
+            </a:r>
+            <a:endParaRPr lang="en-US" altLang="zh-CN" sz="800" dirty="0">
+              <a:latin typeface="宋体" panose="02010600030101010101" pitchFamily="2" charset="-122"/>
+              <a:ea typeface="宋体" panose="02010600030101010101" pitchFamily="2" charset="-122"/>
+              <a:cs typeface="宋体" panose="02010600030101010101" pitchFamily="2" charset="-122"/>
+            </a:endParaRPr>
+          </a:p>
+          <a:p>
+            <a:pPr>
+              <a:lnSpc>
+                <a:spcPts val="1520"/>
+              </a:lnSpc>
+            </a:pPr>
+            <a:r>
+              <a:rPr lang="en-US" altLang="zh-CN" sz="800" dirty="0">
+                <a:latin typeface="宋体" panose="02010600030101010101" pitchFamily="2" charset="-122"/>
+                <a:ea typeface="宋体" panose="02010600030101010101" pitchFamily="2" charset="-122"/>
+                <a:cs typeface="宋体" panose="02010600030101010101" pitchFamily="2" charset="-122"/>
+              </a:rPr>
+              <a:t>	</a:t>
+            </a:r>
+            <a:r>
+              <a:rPr lang="zh-CN" altLang="en-US" sz="800" b="1" dirty="0">
+                <a:latin typeface="宋体" panose="02010600030101010101" pitchFamily="2" charset="-122"/>
+                <a:ea typeface="宋体" panose="02010600030101010101" pitchFamily="2" charset="-122"/>
+                <a:cs typeface="宋体" panose="02010600030101010101" pitchFamily="2" charset="-122"/>
+              </a:rPr>
+              <a:t>性能</a:t>
+            </a:r>
+            <a:r>
+              <a:rPr lang="en-US" altLang="zh-CN" sz="800" b="1" dirty="0">
+                <a:latin typeface="宋体" panose="02010600030101010101" pitchFamily="2" charset="-122"/>
+                <a:ea typeface="宋体" panose="02010600030101010101" pitchFamily="2" charset="-122"/>
+                <a:cs typeface="宋体" panose="02010600030101010101" pitchFamily="2" charset="-122"/>
+              </a:rPr>
+              <a:t>/</a:t>
+            </a:r>
+            <a:r>
+              <a:rPr lang="zh-CN" altLang="en-US" sz="800" b="1" dirty="0">
+                <a:latin typeface="宋体" panose="02010600030101010101" pitchFamily="2" charset="-122"/>
+                <a:ea typeface="宋体" panose="02010600030101010101" pitchFamily="2" charset="-122"/>
+                <a:cs typeface="宋体" panose="02010600030101010101" pitchFamily="2" charset="-122"/>
+              </a:rPr>
+              <a:t>安全：</a:t>
+            </a:r>
+            <a:r>
+              <a:rPr lang="zh-CN" altLang="en-US" sz="800" dirty="0">
+                <a:latin typeface="宋体" panose="02010600030101010101" pitchFamily="2" charset="-122"/>
+                <a:ea typeface="宋体" panose="02010600030101010101" pitchFamily="2" charset="-122"/>
+                <a:cs typeface="宋体" panose="02010600030101010101" pitchFamily="2" charset="-122"/>
+              </a:rPr>
+              <a:t>基于</a:t>
+            </a:r>
+            <a:r>
+              <a:rPr lang="zh-CN" altLang="en-US" sz="800" b="1" dirty="0">
+                <a:latin typeface="宋体" panose="02010600030101010101" pitchFamily="2" charset="-122"/>
+                <a:ea typeface="宋体" panose="02010600030101010101" pitchFamily="2" charset="-122"/>
+                <a:cs typeface="宋体" panose="02010600030101010101" pitchFamily="2" charset="-122"/>
+              </a:rPr>
+              <a:t>事件驱动</a:t>
+            </a:r>
+            <a:r>
+              <a:rPr lang="zh-CN" altLang="en-US" sz="800" dirty="0">
+                <a:latin typeface="宋体" panose="02010600030101010101" pitchFamily="2" charset="-122"/>
+                <a:ea typeface="宋体" panose="02010600030101010101" pitchFamily="2" charset="-122"/>
+                <a:cs typeface="宋体" panose="02010600030101010101" pitchFamily="2" charset="-122"/>
+              </a:rPr>
+              <a:t>与</a:t>
+            </a:r>
+            <a:r>
+              <a:rPr lang="zh-CN" altLang="en-US" sz="800" b="1" dirty="0">
+                <a:latin typeface="宋体" panose="02010600030101010101" pitchFamily="2" charset="-122"/>
+                <a:ea typeface="宋体" panose="02010600030101010101" pitchFamily="2" charset="-122"/>
+                <a:cs typeface="宋体" panose="02010600030101010101" pitchFamily="2" charset="-122"/>
+              </a:rPr>
+              <a:t>敏感词过滤机制</a:t>
+            </a:r>
+            <a:r>
+              <a:rPr lang="zh-CN" altLang="en-US" sz="800" dirty="0">
+                <a:latin typeface="宋体" panose="02010600030101010101" pitchFamily="2" charset="-122"/>
+                <a:ea typeface="宋体" panose="02010600030101010101" pitchFamily="2" charset="-122"/>
+                <a:cs typeface="宋体" panose="02010600030101010101" pitchFamily="2" charset="-122"/>
+              </a:rPr>
+              <a:t>，实现群聊消息的</a:t>
+            </a:r>
+            <a:r>
+              <a:rPr lang="zh-CN" altLang="en-US" sz="800" b="1" dirty="0">
+                <a:latin typeface="宋体" panose="02010600030101010101" pitchFamily="2" charset="-122"/>
+                <a:ea typeface="宋体" panose="02010600030101010101" pitchFamily="2" charset="-122"/>
+                <a:cs typeface="宋体" panose="02010600030101010101" pitchFamily="2" charset="-122"/>
+              </a:rPr>
+              <a:t>异步入库与推送</a:t>
+            </a:r>
+            <a:r>
+              <a:rPr lang="zh-CN" altLang="en-US" sz="800" dirty="0">
+                <a:latin typeface="宋体" panose="02010600030101010101" pitchFamily="2" charset="-122"/>
+                <a:ea typeface="宋体" panose="02010600030101010101" pitchFamily="2" charset="-122"/>
+                <a:cs typeface="宋体" panose="02010600030101010101" pitchFamily="2" charset="-122"/>
+              </a:rPr>
+              <a:t>，确保内容合规同时显著提升接口性能。 </a:t>
+            </a:r>
+            <a:r>
+              <a:rPr lang="en-US" altLang="zh-CN" sz="800" dirty="0">
+                <a:latin typeface="宋体" panose="02010600030101010101" pitchFamily="2" charset="-122"/>
+                <a:ea typeface="宋体" panose="02010600030101010101" pitchFamily="2" charset="-122"/>
+                <a:cs typeface="宋体" panose="02010600030101010101" pitchFamily="2" charset="-122"/>
+              </a:rPr>
+              <a:t>	</a:t>
+            </a:r>
+            <a:endParaRPr lang="en-US" altLang="zh-CN" sz="800" dirty="0">
+              <a:latin typeface="宋体" panose="02010600030101010101" pitchFamily="2" charset="-122"/>
+              <a:ea typeface="宋体" panose="02010600030101010101" pitchFamily="2" charset="-122"/>
+              <a:cs typeface="宋体" panose="02010600030101010101" pitchFamily="2" charset="-122"/>
+            </a:endParaRPr>
+          </a:p>
+          <a:p>
+            <a:pPr>
+              <a:lnSpc>
+                <a:spcPts val="1520"/>
+              </a:lnSpc>
+            </a:pPr>
+            <a:r>
+              <a:rPr lang="en-US" altLang="zh-CN" sz="800" b="1" dirty="0">
+                <a:latin typeface="宋体" panose="02010600030101010101" pitchFamily="2" charset="-122"/>
+                <a:ea typeface="宋体" panose="02010600030101010101" pitchFamily="2" charset="-122"/>
+                <a:cs typeface="宋体" panose="02010600030101010101" pitchFamily="2" charset="-122"/>
+              </a:rPr>
+              <a:t>	</a:t>
+            </a:r>
+            <a:r>
+              <a:rPr lang="zh-CN" altLang="en-US" sz="800" b="1" dirty="0">
+                <a:latin typeface="宋体" panose="02010600030101010101" pitchFamily="2" charset="-122"/>
+                <a:ea typeface="宋体" panose="02010600030101010101" pitchFamily="2" charset="-122"/>
+                <a:cs typeface="宋体" panose="02010600030101010101" pitchFamily="2" charset="-122"/>
+              </a:rPr>
+              <a:t>限流控制：</a:t>
+            </a:r>
+            <a:r>
+              <a:rPr lang="zh-CN" altLang="en-US" sz="800" dirty="0">
+                <a:latin typeface="宋体" panose="02010600030101010101" pitchFamily="2" charset="-122"/>
+                <a:ea typeface="宋体" panose="02010600030101010101" pitchFamily="2" charset="-122"/>
+                <a:cs typeface="宋体" panose="02010600030101010101" pitchFamily="2" charset="-122"/>
+              </a:rPr>
+              <a:t>自定义注解实现高复用，结合 </a:t>
+            </a:r>
+            <a:r>
+              <a:rPr lang="en-US" altLang="zh-CN" sz="800" b="1" dirty="0">
+                <a:latin typeface="宋体" panose="02010600030101010101" pitchFamily="2" charset="-122"/>
+                <a:ea typeface="宋体" panose="02010600030101010101" pitchFamily="2" charset="-122"/>
+                <a:cs typeface="宋体" panose="02010600030101010101" pitchFamily="2" charset="-122"/>
+              </a:rPr>
+              <a:t>AOP + </a:t>
+            </a:r>
+            <a:r>
+              <a:rPr lang="en-US" altLang="zh-CN" sz="800" b="1" dirty="0" err="1">
+                <a:latin typeface="宋体" panose="02010600030101010101" pitchFamily="2" charset="-122"/>
+                <a:ea typeface="宋体" panose="02010600030101010101" pitchFamily="2" charset="-122"/>
+                <a:cs typeface="宋体" panose="02010600030101010101" pitchFamily="2" charset="-122"/>
+              </a:rPr>
+              <a:t>SpEL</a:t>
+            </a:r>
+            <a:r>
+              <a:rPr lang="en-US" altLang="zh-CN" sz="800" b="1" dirty="0">
+                <a:latin typeface="宋体" panose="02010600030101010101" pitchFamily="2" charset="-122"/>
+                <a:ea typeface="宋体" panose="02010600030101010101" pitchFamily="2" charset="-122"/>
+                <a:cs typeface="宋体" panose="02010600030101010101" pitchFamily="2" charset="-122"/>
+              </a:rPr>
+              <a:t> </a:t>
+            </a:r>
+            <a:r>
+              <a:rPr lang="zh-CN" altLang="en-US" sz="800" b="1" dirty="0">
+                <a:latin typeface="宋体" panose="02010600030101010101" pitchFamily="2" charset="-122"/>
+                <a:ea typeface="宋体" panose="02010600030101010101" pitchFamily="2" charset="-122"/>
+                <a:cs typeface="宋体" panose="02010600030101010101" pitchFamily="2" charset="-122"/>
+              </a:rPr>
+              <a:t>表达式</a:t>
+            </a:r>
+            <a:r>
+              <a:rPr lang="zh-CN" altLang="en-US" sz="800" dirty="0">
+                <a:latin typeface="宋体" panose="02010600030101010101" pitchFamily="2" charset="-122"/>
+                <a:ea typeface="宋体" panose="02010600030101010101" pitchFamily="2" charset="-122"/>
+                <a:cs typeface="宋体" panose="02010600030101010101" pitchFamily="2" charset="-122"/>
+              </a:rPr>
+              <a:t>，实现接口级限流防刷功能，支持用户、</a:t>
+            </a:r>
+            <a:r>
+              <a:rPr lang="en-US" altLang="zh-CN" sz="800" dirty="0">
+                <a:latin typeface="宋体" panose="02010600030101010101" pitchFamily="2" charset="-122"/>
+                <a:ea typeface="宋体" panose="02010600030101010101" pitchFamily="2" charset="-122"/>
+                <a:cs typeface="宋体" panose="02010600030101010101" pitchFamily="2" charset="-122"/>
+              </a:rPr>
+              <a:t>IP</a:t>
+            </a:r>
+            <a:r>
+              <a:rPr lang="zh-CN" altLang="en-US" sz="800" dirty="0">
+                <a:latin typeface="宋体" panose="02010600030101010101" pitchFamily="2" charset="-122"/>
+                <a:ea typeface="宋体" panose="02010600030101010101" pitchFamily="2" charset="-122"/>
+                <a:cs typeface="宋体" panose="02010600030101010101" pitchFamily="2" charset="-122"/>
+              </a:rPr>
+              <a:t>、接口维度灵活限流</a:t>
+            </a:r>
+            <a:r>
+              <a:rPr lang="zh-CN" altLang="en-US" sz="800" b="1" dirty="0">
+                <a:latin typeface="宋体" panose="02010600030101010101" pitchFamily="2" charset="-122"/>
+                <a:ea typeface="宋体" panose="02010600030101010101" pitchFamily="2" charset="-122"/>
+                <a:cs typeface="宋体" panose="02010600030101010101" pitchFamily="2" charset="-122"/>
+              </a:rPr>
+              <a:t>。</a:t>
             </a:r>
             <a:endParaRPr lang="en-US" altLang="zh-CN" sz="800" b="1" dirty="0">
               <a:latin typeface="宋体" panose="02010600030101010101" pitchFamily="2" charset="-122"/>
@@ -4981,12 +5374,28 @@
               </a:lnSpc>
             </a:pPr>
             <a:r>
+              <a:rPr lang="en-US" altLang="zh-CN" sz="800" b="1" dirty="0">
+                <a:latin typeface="宋体" panose="02010600030101010101" pitchFamily="2" charset="-122"/>
+                <a:ea typeface="宋体" panose="02010600030101010101" pitchFamily="2" charset="-122"/>
+                <a:cs typeface="宋体" panose="02010600030101010101" pitchFamily="2" charset="-122"/>
+              </a:rPr>
+              <a:t>	</a:t>
+            </a:r>
+            <a:r>
               <a:rPr lang="zh-CN" altLang="en-US" sz="800" b="1" dirty="0">
                 <a:latin typeface="宋体" panose="02010600030101010101" pitchFamily="2" charset="-122"/>
                 <a:ea typeface="宋体" panose="02010600030101010101" pitchFamily="2" charset="-122"/>
                 <a:cs typeface="宋体" panose="02010600030101010101" pitchFamily="2" charset="-122"/>
               </a:rPr>
-              <a:t>项目描述</a:t>
+              <a:t>日志记录：</a:t>
+            </a:r>
+            <a:r>
+              <a:rPr lang="zh-CN" altLang="en-US" sz="800" dirty="0">
+                <a:latin typeface="宋体" panose="02010600030101010101" pitchFamily="2" charset="-122"/>
+                <a:ea typeface="宋体" panose="02010600030101010101" pitchFamily="2" charset="-122"/>
+                <a:cs typeface="宋体" panose="02010600030101010101" pitchFamily="2" charset="-122"/>
+              </a:rPr>
+              <a:t>使用 </a:t>
             </a:r>
             <a:r>
               <a:rPr lang="en-US" altLang="zh-CN" sz="800" b="1" dirty="0">
@@ -4994,23 +5403,15 @@
                 <a:ea typeface="宋体" panose="02010600030101010101" pitchFamily="2" charset="-122"/>
                 <a:cs typeface="宋体" panose="02010600030101010101" pitchFamily="2" charset="-122"/>
               </a:rPr>
-              <a:t>: </a:t>
-            </a:r>
-            <a:r>
-              <a:rPr lang="zh-CN" altLang="en-US" sz="800" dirty="0">
-                <a:latin typeface="宋体" panose="02010600030101010101" pitchFamily="2" charset="-122"/>
-                <a:ea typeface="宋体" panose="02010600030101010101" pitchFamily="2" charset="-122"/>
-                <a:cs typeface="宋体" panose="02010600030101010101" pitchFamily="2" charset="-122"/>
-              </a:rPr>
-              <a:t>一款仿飞书的企业级通讯与协作平台，集私聊、群聊与安全权限管理于一体，支持接口</a:t>
-            </a:r>
-            <a:r>
-              <a:rPr lang="zh-CN" altLang="en-US" sz="800" dirty="0">
-                <a:latin typeface="宋体" panose="02010600030101010101" pitchFamily="2" charset="-122"/>
-                <a:ea typeface="宋体" panose="02010600030101010101" pitchFamily="2" charset="-122"/>
-                <a:cs typeface="宋体" panose="02010600030101010101" pitchFamily="2" charset="-122"/>
-              </a:rPr>
-              <a:t>多维限流、敏感词过滤、会话管理、消息实时推送、语音通话、以及智能 </a:t>
+              <a:t>MDC </a:t>
+            </a:r>
+            <a:r>
+              <a:rPr lang="zh-CN" altLang="en-US" sz="800" dirty="0">
+                <a:latin typeface="宋体" panose="02010600030101010101" pitchFamily="2" charset="-122"/>
+                <a:ea typeface="宋体" panose="02010600030101010101" pitchFamily="2" charset="-122"/>
+                <a:cs typeface="宋体" panose="02010600030101010101" pitchFamily="2" charset="-122"/>
+              </a:rPr>
+              <a:t>日志上下文机制，通过</a:t>
             </a:r>
             <a:r>
               <a:rPr lang="en-US" altLang="zh-CN" sz="800" dirty="0">
@@ -5018,15 +5419,63 @@
                 <a:ea typeface="宋体" panose="02010600030101010101" pitchFamily="2" charset="-122"/>
                 <a:cs typeface="宋体" panose="02010600030101010101" pitchFamily="2" charset="-122"/>
               </a:rPr>
-              <a:t>AI </a:t>
-            </a:r>
-            <a:r>
-              <a:rPr lang="zh-CN" altLang="en-US" sz="800" dirty="0">
-                <a:latin typeface="宋体" panose="02010600030101010101" pitchFamily="2" charset="-122"/>
-                <a:ea typeface="宋体" panose="02010600030101010101" pitchFamily="2" charset="-122"/>
-                <a:cs typeface="宋体" panose="02010600030101010101" pitchFamily="2" charset="-122"/>
-              </a:rPr>
-              <a:t>助手，旨在提升团队沟通效率与协作体验。</a:t>
+              <a:t>Filter </a:t>
+            </a:r>
+            <a:r>
+              <a:rPr lang="zh-CN" altLang="en-US" sz="800" dirty="0">
+                <a:latin typeface="宋体" panose="02010600030101010101" pitchFamily="2" charset="-122"/>
+                <a:ea typeface="宋体" panose="02010600030101010101" pitchFamily="2" charset="-122"/>
+                <a:cs typeface="宋体" panose="02010600030101010101" pitchFamily="2" charset="-122"/>
+              </a:rPr>
+              <a:t>统一生成 </a:t>
+            </a:r>
+            <a:r>
+              <a:rPr lang="en-US" altLang="zh-CN" sz="800" dirty="0" err="1">
+                <a:latin typeface="宋体" panose="02010600030101010101" pitchFamily="2" charset="-122"/>
+                <a:ea typeface="宋体" panose="02010600030101010101" pitchFamily="2" charset="-122"/>
+                <a:cs typeface="宋体" panose="02010600030101010101" pitchFamily="2" charset="-122"/>
+              </a:rPr>
+              <a:t>traceId</a:t>
+            </a:r>
+            <a:r>
+              <a:rPr lang="zh-CN" altLang="en-US" sz="800" dirty="0">
+                <a:latin typeface="宋体" panose="02010600030101010101" pitchFamily="2" charset="-122"/>
+                <a:ea typeface="宋体" panose="02010600030101010101" pitchFamily="2" charset="-122"/>
+                <a:cs typeface="宋体" panose="02010600030101010101" pitchFamily="2" charset="-122"/>
+              </a:rPr>
+              <a:t>，并结合 </a:t>
+            </a:r>
+            <a:r>
+              <a:rPr lang="en-US" altLang="zh-CN" sz="800" dirty="0" err="1">
+                <a:latin typeface="宋体" panose="02010600030101010101" pitchFamily="2" charset="-122"/>
+                <a:ea typeface="宋体" panose="02010600030101010101" pitchFamily="2" charset="-122"/>
+                <a:cs typeface="宋体" panose="02010600030101010101" pitchFamily="2" charset="-122"/>
+              </a:rPr>
+              <a:t>ThreadLocal</a:t>
+            </a:r>
+            <a:r>
+              <a:rPr lang="zh-CN" altLang="en-US" sz="800" dirty="0">
+                <a:latin typeface="宋体" panose="02010600030101010101" pitchFamily="2" charset="-122"/>
+                <a:ea typeface="宋体" panose="02010600030101010101" pitchFamily="2" charset="-122"/>
+                <a:cs typeface="宋体" panose="02010600030101010101" pitchFamily="2" charset="-122"/>
+              </a:rPr>
+              <a:t>、</a:t>
+            </a:r>
+            <a:r>
+              <a:rPr lang="en-US" altLang="zh-CN" sz="800" dirty="0">
+                <a:latin typeface="宋体" panose="02010600030101010101" pitchFamily="2" charset="-122"/>
+                <a:ea typeface="宋体" panose="02010600030101010101" pitchFamily="2" charset="-122"/>
+                <a:cs typeface="宋体" panose="02010600030101010101" pitchFamily="2" charset="-122"/>
+              </a:rPr>
+              <a:t>MDC</a:t>
+            </a:r>
+            <a:r>
+              <a:rPr lang="zh-CN" altLang="en-US" sz="800" dirty="0">
+                <a:latin typeface="宋体" panose="02010600030101010101" pitchFamily="2" charset="-122"/>
+                <a:ea typeface="宋体" panose="02010600030101010101" pitchFamily="2" charset="-122"/>
+                <a:cs typeface="宋体" panose="02010600030101010101" pitchFamily="2" charset="-122"/>
+              </a:rPr>
+              <a:t>注入线程上下文，</a:t>
             </a:r>
             <a:endParaRPr lang="en-US" altLang="zh-CN" sz="800" dirty="0">
               <a:latin typeface="宋体" panose="02010600030101010101" pitchFamily="2" charset="-122"/>
@@ -5041,854 +5490,6 @@
               </a:lnSpc>
             </a:pPr>
             <a:r>
-              <a:rPr lang="zh-CN" altLang="en-US" sz="800" b="1" dirty="0">
-                <a:latin typeface="宋体" panose="02010600030101010101" pitchFamily="2" charset="-122"/>
-                <a:ea typeface="宋体" panose="02010600030101010101" pitchFamily="2" charset="-122"/>
-                <a:cs typeface="宋体" panose="02010600030101010101" pitchFamily="2" charset="-122"/>
-              </a:rPr>
-              <a:t>核心技术</a:t>
-            </a:r>
-            <a:r>
-              <a:rPr lang="en-US" altLang="zh-CN" sz="800" b="1" dirty="0">
-                <a:latin typeface="宋体" panose="02010600030101010101" pitchFamily="2" charset="-122"/>
-                <a:ea typeface="宋体" panose="02010600030101010101" pitchFamily="2" charset="-122"/>
-                <a:cs typeface="宋体" panose="02010600030101010101" pitchFamily="2" charset="-122"/>
-              </a:rPr>
-              <a:t>: </a:t>
-            </a:r>
-            <a:r>
-              <a:rPr lang="en-US" altLang="zh-CN" sz="800" dirty="0">
-                <a:latin typeface="宋体" panose="02010600030101010101" pitchFamily="2" charset="-122"/>
-                <a:ea typeface="宋体" panose="02010600030101010101" pitchFamily="2" charset="-122"/>
-                <a:cs typeface="宋体" panose="02010600030101010101" pitchFamily="2" charset="-122"/>
-              </a:rPr>
-              <a:t>SpringBoot3, </a:t>
-            </a:r>
-            <a:r>
-              <a:rPr lang="en-US" altLang="zh-CN" sz="800" dirty="0" err="1">
-                <a:latin typeface="宋体" panose="02010600030101010101" pitchFamily="2" charset="-122"/>
-                <a:ea typeface="宋体" panose="02010600030101010101" pitchFamily="2" charset="-122"/>
-                <a:cs typeface="宋体" panose="02010600030101010101" pitchFamily="2" charset="-122"/>
-              </a:rPr>
-              <a:t>MyBatis</a:t>
-            </a:r>
-            <a:r>
-              <a:rPr lang="en-US" altLang="zh-CN" sz="800" dirty="0">
-                <a:latin typeface="宋体" panose="02010600030101010101" pitchFamily="2" charset="-122"/>
-                <a:ea typeface="宋体" panose="02010600030101010101" pitchFamily="2" charset="-122"/>
-                <a:cs typeface="宋体" panose="02010600030101010101" pitchFamily="2" charset="-122"/>
-              </a:rPr>
-              <a:t> Plus</a:t>
-            </a:r>
-            <a:r>
-              <a:rPr lang="zh-CN" altLang="en-US" sz="800" dirty="0">
-                <a:latin typeface="宋体" panose="02010600030101010101" pitchFamily="2" charset="-122"/>
-                <a:ea typeface="宋体" panose="02010600030101010101" pitchFamily="2" charset="-122"/>
-                <a:cs typeface="宋体" panose="02010600030101010101" pitchFamily="2" charset="-122"/>
-              </a:rPr>
-              <a:t>，</a:t>
-            </a:r>
-            <a:r>
-              <a:rPr lang="en-US" altLang="zh-CN" sz="800" dirty="0">
-                <a:latin typeface="宋体" panose="02010600030101010101" pitchFamily="2" charset="-122"/>
-                <a:ea typeface="宋体" panose="02010600030101010101" pitchFamily="2" charset="-122"/>
-                <a:cs typeface="宋体" panose="02010600030101010101" pitchFamily="2" charset="-122"/>
-              </a:rPr>
-              <a:t>Netty</a:t>
-            </a:r>
-            <a:r>
-              <a:rPr lang="zh-CN" altLang="en-US" sz="800" dirty="0">
-                <a:latin typeface="宋体" panose="02010600030101010101" pitchFamily="2" charset="-122"/>
-                <a:ea typeface="宋体" panose="02010600030101010101" pitchFamily="2" charset="-122"/>
-                <a:cs typeface="宋体" panose="02010600030101010101" pitchFamily="2" charset="-122"/>
-              </a:rPr>
-              <a:t>，</a:t>
-            </a:r>
-            <a:r>
-              <a:rPr lang="en-US" altLang="zh-CN" sz="800" dirty="0">
-                <a:latin typeface="宋体" panose="02010600030101010101" pitchFamily="2" charset="-122"/>
-                <a:ea typeface="宋体" panose="02010600030101010101" pitchFamily="2" charset="-122"/>
-                <a:cs typeface="宋体" panose="02010600030101010101" pitchFamily="2" charset="-122"/>
-              </a:rPr>
-              <a:t>WebRTC</a:t>
-            </a:r>
-            <a:r>
-              <a:rPr lang="zh-CN" altLang="en-US" sz="800" dirty="0">
-                <a:latin typeface="宋体" panose="02010600030101010101" pitchFamily="2" charset="-122"/>
-                <a:ea typeface="宋体" panose="02010600030101010101" pitchFamily="2" charset="-122"/>
-                <a:cs typeface="宋体" panose="02010600030101010101" pitchFamily="2" charset="-122"/>
-              </a:rPr>
-              <a:t>、</a:t>
-            </a:r>
-            <a:r>
-              <a:rPr lang="en-US" altLang="zh-CN" sz="800" dirty="0">
-                <a:latin typeface="宋体" panose="02010600030101010101" pitchFamily="2" charset="-122"/>
-                <a:ea typeface="宋体" panose="02010600030101010101" pitchFamily="2" charset="-122"/>
-                <a:cs typeface="宋体" panose="02010600030101010101" pitchFamily="2" charset="-122"/>
-              </a:rPr>
-              <a:t>RabbitMQ</a:t>
-            </a:r>
-            <a:r>
-              <a:rPr lang="zh-CN" altLang="en-US" sz="800" dirty="0">
-                <a:latin typeface="宋体" panose="02010600030101010101" pitchFamily="2" charset="-122"/>
-                <a:ea typeface="宋体" panose="02010600030101010101" pitchFamily="2" charset="-122"/>
-                <a:cs typeface="宋体" panose="02010600030101010101" pitchFamily="2" charset="-122"/>
-              </a:rPr>
-              <a:t>，</a:t>
-            </a:r>
-            <a:r>
-              <a:rPr lang="en-US" altLang="zh-CN" sz="800" dirty="0">
-                <a:latin typeface="宋体" panose="02010600030101010101" pitchFamily="2" charset="-122"/>
-                <a:ea typeface="宋体" panose="02010600030101010101" pitchFamily="2" charset="-122"/>
-                <a:cs typeface="宋体" panose="02010600030101010101" pitchFamily="2" charset="-122"/>
-              </a:rPr>
-              <a:t>Docker</a:t>
-            </a:r>
-            <a:r>
-              <a:rPr lang="zh-CN" altLang="en-US" sz="800" dirty="0">
-                <a:latin typeface="宋体" panose="02010600030101010101" pitchFamily="2" charset="-122"/>
-                <a:ea typeface="宋体" panose="02010600030101010101" pitchFamily="2" charset="-122"/>
-                <a:cs typeface="宋体" panose="02010600030101010101" pitchFamily="2" charset="-122"/>
-              </a:rPr>
-              <a:t>，</a:t>
-            </a:r>
-            <a:r>
-              <a:rPr lang="en-US" altLang="zh-CN" sz="800" dirty="0">
-                <a:latin typeface="宋体" panose="02010600030101010101" pitchFamily="2" charset="-122"/>
-                <a:ea typeface="宋体" panose="02010600030101010101" pitchFamily="2" charset="-122"/>
-                <a:cs typeface="宋体" panose="02010600030101010101" pitchFamily="2" charset="-122"/>
-              </a:rPr>
-              <a:t>Nginx</a:t>
-            </a:r>
-            <a:r>
-              <a:rPr lang="zh-CN" altLang="en-US" sz="800" dirty="0">
-                <a:latin typeface="宋体" panose="02010600030101010101" pitchFamily="2" charset="-122"/>
-                <a:ea typeface="宋体" panose="02010600030101010101" pitchFamily="2" charset="-122"/>
-                <a:cs typeface="宋体" panose="02010600030101010101" pitchFamily="2" charset="-122"/>
-              </a:rPr>
-              <a:t>，</a:t>
-            </a:r>
-            <a:r>
-              <a:rPr lang="en-US" altLang="zh-CN" sz="800" dirty="0">
-                <a:latin typeface="宋体" panose="02010600030101010101" pitchFamily="2" charset="-122"/>
-                <a:ea typeface="宋体" panose="02010600030101010101" pitchFamily="2" charset="-122"/>
-                <a:cs typeface="宋体" panose="02010600030101010101" pitchFamily="2" charset="-122"/>
-              </a:rPr>
-              <a:t>Redis</a:t>
-            </a:r>
-            <a:r>
-              <a:rPr lang="zh-CN" altLang="en-US" sz="800" dirty="0">
-                <a:latin typeface="宋体" panose="02010600030101010101" pitchFamily="2" charset="-122"/>
-                <a:ea typeface="宋体" panose="02010600030101010101" pitchFamily="2" charset="-122"/>
-                <a:cs typeface="宋体" panose="02010600030101010101" pitchFamily="2" charset="-122"/>
-              </a:rPr>
-              <a:t>，</a:t>
-            </a:r>
-            <a:r>
-              <a:rPr lang="en-US" altLang="zh-CN" sz="800" dirty="0">
-                <a:latin typeface="宋体" panose="02010600030101010101" pitchFamily="2" charset="-122"/>
-                <a:ea typeface="宋体" panose="02010600030101010101" pitchFamily="2" charset="-122"/>
-                <a:cs typeface="宋体" panose="02010600030101010101" pitchFamily="2" charset="-122"/>
-              </a:rPr>
-              <a:t>JWT</a:t>
-            </a:r>
-            <a:r>
-              <a:rPr lang="zh-CN" altLang="en-US" sz="800" dirty="0">
-                <a:latin typeface="宋体" panose="02010600030101010101" pitchFamily="2" charset="-122"/>
-                <a:ea typeface="宋体" panose="02010600030101010101" pitchFamily="2" charset="-122"/>
-                <a:cs typeface="宋体" panose="02010600030101010101" pitchFamily="2" charset="-122"/>
-              </a:rPr>
-              <a:t>，</a:t>
-            </a:r>
-            <a:r>
-              <a:rPr lang="en-US" altLang="zh-CN" sz="800" dirty="0">
-                <a:latin typeface="宋体" panose="02010600030101010101" pitchFamily="2" charset="-122"/>
-                <a:ea typeface="宋体" panose="02010600030101010101" pitchFamily="2" charset="-122"/>
-                <a:cs typeface="宋体" panose="02010600030101010101" pitchFamily="2" charset="-122"/>
-              </a:rPr>
-              <a:t>langchain4j</a:t>
-            </a:r>
-            <a:endParaRPr lang="en-US" altLang="zh-CN" sz="800" dirty="0">
-              <a:latin typeface="宋体" panose="02010600030101010101" pitchFamily="2" charset="-122"/>
-              <a:ea typeface="宋体" panose="02010600030101010101" pitchFamily="2" charset="-122"/>
-              <a:cs typeface="宋体" panose="02010600030101010101" pitchFamily="2" charset="-122"/>
-            </a:endParaRPr>
-          </a:p>
-          <a:p>
-            <a:pPr>
-              <a:lnSpc>
-                <a:spcPts val="1520"/>
-              </a:lnSpc>
-            </a:pPr>
-            <a:r>
-              <a:rPr lang="zh-CN" altLang="en-US" sz="800" b="1" dirty="0">
-                <a:latin typeface="宋体" panose="02010600030101010101" pitchFamily="2" charset="-122"/>
-                <a:ea typeface="宋体" panose="02010600030101010101" pitchFamily="2" charset="-122"/>
-                <a:cs typeface="宋体" panose="02010600030101010101" pitchFamily="2" charset="-122"/>
-              </a:rPr>
-              <a:t>核心职责</a:t>
-            </a:r>
-            <a:r>
-              <a:rPr lang="en-US" altLang="zh-CN" sz="800" b="1" dirty="0">
-                <a:latin typeface="宋体" panose="02010600030101010101" pitchFamily="2" charset="-122"/>
-                <a:ea typeface="宋体" panose="02010600030101010101" pitchFamily="2" charset="-122"/>
-                <a:cs typeface="宋体" panose="02010600030101010101" pitchFamily="2" charset="-122"/>
-              </a:rPr>
-              <a:t>:</a:t>
-            </a:r>
-            <a:endParaRPr lang="en-US" altLang="zh-CN" sz="800" b="1" dirty="0">
-              <a:latin typeface="宋体" panose="02010600030101010101" pitchFamily="2" charset="-122"/>
-              <a:ea typeface="宋体" panose="02010600030101010101" pitchFamily="2" charset="-122"/>
-              <a:cs typeface="宋体" panose="02010600030101010101" pitchFamily="2" charset="-122"/>
-            </a:endParaRPr>
-          </a:p>
-          <a:p>
-            <a:pPr>
-              <a:lnSpc>
-                <a:spcPts val="1520"/>
-              </a:lnSpc>
-            </a:pPr>
-            <a:r>
-              <a:rPr lang="en-US" altLang="zh-CN" sz="800" b="1" dirty="0">
-                <a:latin typeface="宋体" panose="02010600030101010101" pitchFamily="2" charset="-122"/>
-                <a:ea typeface="宋体" panose="02010600030101010101" pitchFamily="2" charset="-122"/>
-                <a:cs typeface="宋体" panose="02010600030101010101" pitchFamily="2" charset="-122"/>
-              </a:rPr>
-              <a:t>	</a:t>
-            </a:r>
-            <a:r>
-              <a:rPr lang="zh-CN" altLang="en-US" sz="800" b="1" dirty="0">
-                <a:latin typeface="宋体" panose="02010600030101010101" pitchFamily="2" charset="-122"/>
-                <a:ea typeface="宋体" panose="02010600030101010101" pitchFamily="2" charset="-122"/>
-                <a:cs typeface="宋体" panose="02010600030101010101" pitchFamily="2" charset="-122"/>
-              </a:rPr>
-              <a:t>消息推送</a:t>
-            </a:r>
-            <a:r>
-              <a:rPr lang="en-US" altLang="zh-CN" sz="800" b="1" dirty="0">
-                <a:latin typeface="宋体" panose="02010600030101010101" pitchFamily="2" charset="-122"/>
-                <a:ea typeface="宋体" panose="02010600030101010101" pitchFamily="2" charset="-122"/>
-                <a:cs typeface="宋体" panose="02010600030101010101" pitchFamily="2" charset="-122"/>
-              </a:rPr>
-              <a:t>/</a:t>
-            </a:r>
-            <a:r>
-              <a:rPr lang="zh-CN" altLang="en-US" sz="800" b="1" dirty="0">
-                <a:latin typeface="宋体" panose="02010600030101010101" pitchFamily="2" charset="-122"/>
-                <a:ea typeface="宋体" panose="02010600030101010101" pitchFamily="2" charset="-122"/>
-                <a:cs typeface="宋体" panose="02010600030101010101" pitchFamily="2" charset="-122"/>
-              </a:rPr>
-              <a:t>处理：</a:t>
-            </a:r>
-            <a:r>
-              <a:rPr lang="zh-CN" altLang="en-US" sz="800" dirty="0">
-                <a:latin typeface="宋体" panose="02010600030101010101" pitchFamily="2" charset="-122"/>
-                <a:ea typeface="宋体" panose="02010600030101010101" pitchFamily="2" charset="-122"/>
-                <a:cs typeface="宋体" panose="02010600030101010101" pitchFamily="2" charset="-122"/>
-              </a:rPr>
-              <a:t>基于</a:t>
-            </a:r>
-            <a:r>
-              <a:rPr lang="en-US" altLang="zh-CN" sz="800" dirty="0">
-                <a:latin typeface="宋体" panose="02010600030101010101" pitchFamily="2" charset="-122"/>
-                <a:ea typeface="宋体" panose="02010600030101010101" pitchFamily="2" charset="-122"/>
-                <a:cs typeface="宋体" panose="02010600030101010101" pitchFamily="2" charset="-122"/>
-              </a:rPr>
-              <a:t>Netty</a:t>
-            </a:r>
-            <a:r>
-              <a:rPr lang="zh-CN" altLang="en-US" sz="800" dirty="0">
-                <a:latin typeface="宋体" panose="02010600030101010101" pitchFamily="2" charset="-122"/>
-                <a:ea typeface="宋体" panose="02010600030101010101" pitchFamily="2" charset="-122"/>
-                <a:cs typeface="宋体" panose="02010600030101010101" pitchFamily="2" charset="-122"/>
-              </a:rPr>
-              <a:t>构建长连接服务，支持私聊</a:t>
-            </a:r>
-            <a:r>
-              <a:rPr lang="en-US" altLang="zh-CN" sz="800" dirty="0">
-                <a:latin typeface="宋体" panose="02010600030101010101" pitchFamily="2" charset="-122"/>
-                <a:ea typeface="宋体" panose="02010600030101010101" pitchFamily="2" charset="-122"/>
-                <a:cs typeface="宋体" panose="02010600030101010101" pitchFamily="2" charset="-122"/>
-              </a:rPr>
-              <a:t>/</a:t>
-            </a:r>
-            <a:r>
-              <a:rPr lang="zh-CN" altLang="en-US" sz="800" dirty="0">
-                <a:latin typeface="宋体" panose="02010600030101010101" pitchFamily="2" charset="-122"/>
-                <a:ea typeface="宋体" panose="02010600030101010101" pitchFamily="2" charset="-122"/>
-                <a:cs typeface="宋体" panose="02010600030101010101" pitchFamily="2" charset="-122"/>
-              </a:rPr>
-              <a:t>群聊消息的实时分发</a:t>
-            </a:r>
-            <a:r>
-              <a:rPr lang="zh-CN" altLang="en-US" sz="800" b="1" dirty="0">
-                <a:latin typeface="宋体" panose="02010600030101010101" pitchFamily="2" charset="-122"/>
-                <a:ea typeface="宋体" panose="02010600030101010101" pitchFamily="2" charset="-122"/>
-                <a:cs typeface="宋体" panose="02010600030101010101" pitchFamily="2" charset="-122"/>
-              </a:rPr>
-              <a:t>。抽象消息处理器</a:t>
-            </a:r>
-            <a:r>
-              <a:rPr lang="zh-CN" altLang="en-US" sz="800" dirty="0">
-                <a:latin typeface="宋体" panose="02010600030101010101" pitchFamily="2" charset="-122"/>
-                <a:ea typeface="宋体" panose="02010600030101010101" pitchFamily="2" charset="-122"/>
-                <a:cs typeface="宋体" panose="02010600030101010101" pitchFamily="2" charset="-122"/>
-              </a:rPr>
-              <a:t>基类，</a:t>
-            </a:r>
-            <a:endParaRPr lang="en-US" altLang="zh-CN" sz="800" dirty="0">
-              <a:latin typeface="宋体" panose="02010600030101010101" pitchFamily="2" charset="-122"/>
-              <a:ea typeface="宋体" panose="02010600030101010101" pitchFamily="2" charset="-122"/>
-              <a:cs typeface="宋体" panose="02010600030101010101" pitchFamily="2" charset="-122"/>
-            </a:endParaRPr>
-          </a:p>
-          <a:p>
-            <a:pPr>
-              <a:lnSpc>
-                <a:spcPts val="1520"/>
-              </a:lnSpc>
-            </a:pPr>
-            <a:r>
-              <a:rPr lang="en-US" altLang="zh-CN" sz="800" dirty="0">
-                <a:latin typeface="宋体" panose="02010600030101010101" pitchFamily="2" charset="-122"/>
-                <a:ea typeface="宋体" panose="02010600030101010101" pitchFamily="2" charset="-122"/>
-                <a:cs typeface="宋体" panose="02010600030101010101" pitchFamily="2" charset="-122"/>
-              </a:rPr>
-              <a:t>	</a:t>
-            </a:r>
-            <a:r>
-              <a:rPr lang="zh-CN" altLang="en-US" sz="800" dirty="0">
-                <a:latin typeface="宋体" panose="02010600030101010101" pitchFamily="2" charset="-122"/>
-                <a:ea typeface="宋体" panose="02010600030101010101" pitchFamily="2" charset="-122"/>
-                <a:cs typeface="宋体" panose="02010600030101010101" pitchFamily="2" charset="-122"/>
-              </a:rPr>
-              <a:t>结合 </a:t>
-            </a:r>
-            <a:r>
-              <a:rPr lang="en-US" altLang="zh-CN" sz="800" b="1" dirty="0">
-                <a:latin typeface="宋体" panose="02010600030101010101" pitchFamily="2" charset="-122"/>
-                <a:ea typeface="宋体" panose="02010600030101010101" pitchFamily="2" charset="-122"/>
-                <a:cs typeface="宋体" panose="02010600030101010101" pitchFamily="2" charset="-122"/>
-              </a:rPr>
-              <a:t>Spring </a:t>
-            </a:r>
-            <a:r>
-              <a:rPr lang="zh-CN" altLang="en-US" sz="800" b="1" dirty="0">
-                <a:latin typeface="宋体" panose="02010600030101010101" pitchFamily="2" charset="-122"/>
-                <a:ea typeface="宋体" panose="02010600030101010101" pitchFamily="2" charset="-122"/>
-                <a:cs typeface="宋体" panose="02010600030101010101" pitchFamily="2" charset="-122"/>
-              </a:rPr>
-              <a:t>容器注册机制</a:t>
-            </a:r>
-            <a:r>
-              <a:rPr lang="zh-CN" altLang="en-US" sz="800" dirty="0">
-                <a:latin typeface="宋体" panose="02010600030101010101" pitchFamily="2" charset="-122"/>
-                <a:ea typeface="宋体" panose="02010600030101010101" pitchFamily="2" charset="-122"/>
-                <a:cs typeface="宋体" panose="02010600030101010101" pitchFamily="2" charset="-122"/>
-              </a:rPr>
-              <a:t>，支持</a:t>
-            </a:r>
-            <a:r>
-              <a:rPr lang="zh-CN" altLang="en-US" sz="800" b="1" dirty="0">
-                <a:latin typeface="宋体" panose="02010600030101010101" pitchFamily="2" charset="-122"/>
-                <a:ea typeface="宋体" panose="02010600030101010101" pitchFamily="2" charset="-122"/>
-                <a:cs typeface="宋体" panose="02010600030101010101" pitchFamily="2" charset="-122"/>
-              </a:rPr>
-              <a:t>多种消息类型</a:t>
-            </a:r>
-            <a:r>
-              <a:rPr lang="zh-CN" altLang="en-US" sz="800" dirty="0">
-                <a:latin typeface="宋体" panose="02010600030101010101" pitchFamily="2" charset="-122"/>
-                <a:ea typeface="宋体" panose="02010600030101010101" pitchFamily="2" charset="-122"/>
-                <a:cs typeface="宋体" panose="02010600030101010101" pitchFamily="2" charset="-122"/>
-              </a:rPr>
-              <a:t>（文本、图片、文件）动态分发与处理，利用</a:t>
-            </a:r>
-            <a:r>
-              <a:rPr lang="zh-CN" altLang="en-US" sz="800" b="1" dirty="0">
-                <a:latin typeface="宋体" panose="02010600030101010101" pitchFamily="2" charset="-122"/>
-                <a:ea typeface="宋体" panose="02010600030101010101" pitchFamily="2" charset="-122"/>
-                <a:cs typeface="宋体" panose="02010600030101010101" pitchFamily="2" charset="-122"/>
-              </a:rPr>
-              <a:t>策略模式</a:t>
-            </a:r>
-            <a:r>
-              <a:rPr lang="zh-CN" altLang="en-US" sz="800" dirty="0">
-                <a:latin typeface="宋体" panose="02010600030101010101" pitchFamily="2" charset="-122"/>
-                <a:ea typeface="宋体" panose="02010600030101010101" pitchFamily="2" charset="-122"/>
-                <a:cs typeface="宋体" panose="02010600030101010101" pitchFamily="2" charset="-122"/>
-              </a:rPr>
-              <a:t>实现</a:t>
-            </a:r>
-            <a:r>
-              <a:rPr lang="zh-CN" altLang="en-US" sz="800" b="1" dirty="0">
-                <a:latin typeface="宋体" panose="02010600030101010101" pitchFamily="2" charset="-122"/>
-                <a:ea typeface="宋体" panose="02010600030101010101" pitchFamily="2" charset="-122"/>
-                <a:cs typeface="宋体" panose="02010600030101010101" pitchFamily="2" charset="-122"/>
-              </a:rPr>
-              <a:t>高可扩展性。</a:t>
-            </a:r>
-            <a:r>
-              <a:rPr lang="en-US" altLang="zh-CN" sz="800" dirty="0">
-                <a:latin typeface="宋体" panose="02010600030101010101" pitchFamily="2" charset="-122"/>
-                <a:ea typeface="宋体" panose="02010600030101010101" pitchFamily="2" charset="-122"/>
-                <a:cs typeface="宋体" panose="02010600030101010101" pitchFamily="2" charset="-122"/>
-              </a:rPr>
-              <a:t>	</a:t>
-            </a:r>
-            <a:endParaRPr lang="en-US" altLang="zh-CN" sz="800" dirty="0">
-              <a:latin typeface="宋体" panose="02010600030101010101" pitchFamily="2" charset="-122"/>
-              <a:ea typeface="宋体" panose="02010600030101010101" pitchFamily="2" charset="-122"/>
-              <a:cs typeface="宋体" panose="02010600030101010101" pitchFamily="2" charset="-122"/>
-            </a:endParaRPr>
-          </a:p>
-          <a:p>
-            <a:pPr>
-              <a:lnSpc>
-                <a:spcPts val="1520"/>
-              </a:lnSpc>
-            </a:pPr>
-            <a:r>
-              <a:rPr lang="en-US" altLang="zh-CN" sz="800" dirty="0">
-                <a:latin typeface="宋体" panose="02010600030101010101" pitchFamily="2" charset="-122"/>
-                <a:ea typeface="宋体" panose="02010600030101010101" pitchFamily="2" charset="-122"/>
-                <a:cs typeface="宋体" panose="02010600030101010101" pitchFamily="2" charset="-122"/>
-              </a:rPr>
-              <a:t>	</a:t>
-            </a:r>
-            <a:r>
-              <a:rPr lang="en-US" altLang="zh-CN" sz="800" b="1" dirty="0">
-                <a:latin typeface="宋体" panose="02010600030101010101" pitchFamily="2" charset="-122"/>
-                <a:ea typeface="宋体" panose="02010600030101010101" pitchFamily="2" charset="-122"/>
-                <a:cs typeface="宋体" panose="02010600030101010101" pitchFamily="2" charset="-122"/>
-              </a:rPr>
-              <a:t>AI Chat</a:t>
-            </a:r>
-            <a:r>
-              <a:rPr lang="zh-CN" altLang="en-US" sz="800" b="1" dirty="0">
-                <a:latin typeface="宋体" panose="02010600030101010101" pitchFamily="2" charset="-122"/>
-                <a:ea typeface="宋体" panose="02010600030101010101" pitchFamily="2" charset="-122"/>
-                <a:cs typeface="宋体" panose="02010600030101010101" pitchFamily="2" charset="-122"/>
-              </a:rPr>
-              <a:t>集成：</a:t>
-            </a:r>
-            <a:r>
-              <a:rPr lang="zh-CN" altLang="en-US" sz="800" dirty="0">
-                <a:latin typeface="宋体" panose="02010600030101010101" pitchFamily="2" charset="-122"/>
-                <a:ea typeface="宋体" panose="02010600030101010101" pitchFamily="2" charset="-122"/>
-                <a:cs typeface="宋体" panose="02010600030101010101" pitchFamily="2" charset="-122"/>
-              </a:rPr>
-              <a:t>使用 </a:t>
-            </a:r>
-            <a:r>
-              <a:rPr lang="en-US" altLang="zh-CN" sz="800" b="1" dirty="0">
-                <a:latin typeface="宋体" panose="02010600030101010101" pitchFamily="2" charset="-122"/>
-                <a:ea typeface="宋体" panose="02010600030101010101" pitchFamily="2" charset="-122"/>
-                <a:cs typeface="宋体" panose="02010600030101010101" pitchFamily="2" charset="-122"/>
-              </a:rPr>
-              <a:t>Langchain4j </a:t>
-            </a:r>
-            <a:r>
-              <a:rPr lang="zh-CN" altLang="en-US" sz="800" dirty="0">
-                <a:latin typeface="宋体" panose="02010600030101010101" pitchFamily="2" charset="-122"/>
-                <a:ea typeface="宋体" panose="02010600030101010101" pitchFamily="2" charset="-122"/>
-                <a:cs typeface="宋体" panose="02010600030101010101" pitchFamily="2" charset="-122"/>
-              </a:rPr>
-              <a:t>，集成到项目中开发</a:t>
-            </a:r>
-            <a:r>
-              <a:rPr lang="en-US" altLang="zh-CN" sz="800" dirty="0">
-                <a:latin typeface="宋体" panose="02010600030101010101" pitchFamily="2" charset="-122"/>
-                <a:ea typeface="宋体" panose="02010600030101010101" pitchFamily="2" charset="-122"/>
-                <a:cs typeface="宋体" panose="02010600030101010101" pitchFamily="2" charset="-122"/>
-              </a:rPr>
-              <a:t>AI</a:t>
-            </a:r>
-            <a:r>
-              <a:rPr lang="zh-CN" altLang="en-US" sz="800" dirty="0">
-                <a:latin typeface="宋体" panose="02010600030101010101" pitchFamily="2" charset="-122"/>
-                <a:ea typeface="宋体" panose="02010600030101010101" pitchFamily="2" charset="-122"/>
-                <a:cs typeface="宋体" panose="02010600030101010101" pitchFamily="2" charset="-122"/>
-              </a:rPr>
-              <a:t>助手，实现多轮对话，记忆持久化</a:t>
-            </a:r>
-            <a:r>
-              <a:rPr lang="en-US" altLang="zh-CN" sz="800" dirty="0">
-                <a:latin typeface="宋体" panose="02010600030101010101" pitchFamily="2" charset="-122"/>
-                <a:ea typeface="宋体" panose="02010600030101010101" pitchFamily="2" charset="-122"/>
-                <a:cs typeface="宋体" panose="02010600030101010101" pitchFamily="2" charset="-122"/>
-              </a:rPr>
-              <a:t>, </a:t>
-            </a:r>
-            <a:r>
-              <a:rPr lang="zh-CN" altLang="en-US" sz="800" dirty="0">
-                <a:latin typeface="宋体" panose="02010600030101010101" pitchFamily="2" charset="-122"/>
-                <a:ea typeface="宋体" panose="02010600030101010101" pitchFamily="2" charset="-122"/>
-                <a:cs typeface="宋体" panose="02010600030101010101" pitchFamily="2" charset="-122"/>
-              </a:rPr>
-              <a:t>会话隔离，</a:t>
-            </a:r>
-            <a:r>
-              <a:rPr lang="en-US" altLang="zh-CN" sz="800" dirty="0">
-                <a:latin typeface="宋体" panose="02010600030101010101" pitchFamily="2" charset="-122"/>
-                <a:ea typeface="宋体" panose="02010600030101010101" pitchFamily="2" charset="-122"/>
-                <a:cs typeface="宋体" panose="02010600030101010101" pitchFamily="2" charset="-122"/>
-              </a:rPr>
-              <a:t> RAG</a:t>
-            </a:r>
-            <a:r>
-              <a:rPr lang="zh-CN" altLang="en-US" sz="800" dirty="0">
-                <a:latin typeface="宋体" panose="02010600030101010101" pitchFamily="2" charset="-122"/>
-                <a:ea typeface="宋体" panose="02010600030101010101" pitchFamily="2" charset="-122"/>
-                <a:cs typeface="宋体" panose="02010600030101010101" pitchFamily="2" charset="-122"/>
-              </a:rPr>
-              <a:t>知识库导入。</a:t>
-            </a:r>
-            <a:r>
-              <a:rPr lang="en-US" altLang="zh-CN" sz="800" dirty="0">
-                <a:latin typeface="宋体" panose="02010600030101010101" pitchFamily="2" charset="-122"/>
-                <a:ea typeface="宋体" panose="02010600030101010101" pitchFamily="2" charset="-122"/>
-                <a:cs typeface="宋体" panose="02010600030101010101" pitchFamily="2" charset="-122"/>
-              </a:rPr>
-              <a:t>	</a:t>
-            </a:r>
-            <a:endParaRPr lang="en-US" altLang="zh-CN" sz="800" dirty="0">
-              <a:latin typeface="宋体" panose="02010600030101010101" pitchFamily="2" charset="-122"/>
-              <a:ea typeface="宋体" panose="02010600030101010101" pitchFamily="2" charset="-122"/>
-              <a:cs typeface="宋体" panose="02010600030101010101" pitchFamily="2" charset="-122"/>
-            </a:endParaRPr>
-          </a:p>
-          <a:p>
-            <a:pPr>
-              <a:lnSpc>
-                <a:spcPts val="1520"/>
-              </a:lnSpc>
-            </a:pPr>
-            <a:r>
-              <a:rPr lang="en-US" altLang="zh-CN" sz="800" dirty="0">
-                <a:latin typeface="宋体" panose="02010600030101010101" pitchFamily="2" charset="-122"/>
-                <a:ea typeface="宋体" panose="02010600030101010101" pitchFamily="2" charset="-122"/>
-                <a:cs typeface="宋体" panose="02010600030101010101" pitchFamily="2" charset="-122"/>
-              </a:rPr>
-              <a:t>	</a:t>
-            </a:r>
-            <a:r>
-              <a:rPr lang="zh-CN" altLang="en-US" sz="800" b="1" dirty="0">
-                <a:latin typeface="宋体" panose="02010600030101010101" pitchFamily="2" charset="-122"/>
-                <a:ea typeface="宋体" panose="02010600030101010101" pitchFamily="2" charset="-122"/>
-                <a:cs typeface="宋体" panose="02010600030101010101" pitchFamily="2" charset="-122"/>
-              </a:rPr>
-              <a:t>性能</a:t>
-            </a:r>
-            <a:r>
-              <a:rPr lang="en-US" altLang="zh-CN" sz="800" b="1" dirty="0">
-                <a:latin typeface="宋体" panose="02010600030101010101" pitchFamily="2" charset="-122"/>
-                <a:ea typeface="宋体" panose="02010600030101010101" pitchFamily="2" charset="-122"/>
-                <a:cs typeface="宋体" panose="02010600030101010101" pitchFamily="2" charset="-122"/>
-              </a:rPr>
-              <a:t>/</a:t>
-            </a:r>
-            <a:r>
-              <a:rPr lang="zh-CN" altLang="en-US" sz="800" b="1" dirty="0">
-                <a:latin typeface="宋体" panose="02010600030101010101" pitchFamily="2" charset="-122"/>
-                <a:ea typeface="宋体" panose="02010600030101010101" pitchFamily="2" charset="-122"/>
-                <a:cs typeface="宋体" panose="02010600030101010101" pitchFamily="2" charset="-122"/>
-              </a:rPr>
-              <a:t>安全：</a:t>
-            </a:r>
-            <a:r>
-              <a:rPr lang="zh-CN" altLang="en-US" sz="800" dirty="0">
-                <a:latin typeface="宋体" panose="02010600030101010101" pitchFamily="2" charset="-122"/>
-                <a:ea typeface="宋体" panose="02010600030101010101" pitchFamily="2" charset="-122"/>
-                <a:cs typeface="宋体" panose="02010600030101010101" pitchFamily="2" charset="-122"/>
-              </a:rPr>
-              <a:t>基于</a:t>
-            </a:r>
-            <a:r>
-              <a:rPr lang="zh-CN" altLang="en-US" sz="800" b="1" dirty="0">
-                <a:latin typeface="宋体" panose="02010600030101010101" pitchFamily="2" charset="-122"/>
-                <a:ea typeface="宋体" panose="02010600030101010101" pitchFamily="2" charset="-122"/>
-                <a:cs typeface="宋体" panose="02010600030101010101" pitchFamily="2" charset="-122"/>
-              </a:rPr>
-              <a:t>事件驱动</a:t>
-            </a:r>
-            <a:r>
-              <a:rPr lang="zh-CN" altLang="en-US" sz="800" dirty="0">
-                <a:latin typeface="宋体" panose="02010600030101010101" pitchFamily="2" charset="-122"/>
-                <a:ea typeface="宋体" panose="02010600030101010101" pitchFamily="2" charset="-122"/>
-                <a:cs typeface="宋体" panose="02010600030101010101" pitchFamily="2" charset="-122"/>
-              </a:rPr>
-              <a:t>与</a:t>
-            </a:r>
-            <a:r>
-              <a:rPr lang="zh-CN" altLang="en-US" sz="800" b="1" dirty="0">
-                <a:latin typeface="宋体" panose="02010600030101010101" pitchFamily="2" charset="-122"/>
-                <a:ea typeface="宋体" panose="02010600030101010101" pitchFamily="2" charset="-122"/>
-                <a:cs typeface="宋体" panose="02010600030101010101" pitchFamily="2" charset="-122"/>
-              </a:rPr>
-              <a:t>敏感词过滤机制</a:t>
-            </a:r>
-            <a:r>
-              <a:rPr lang="zh-CN" altLang="en-US" sz="800" dirty="0">
-                <a:latin typeface="宋体" panose="02010600030101010101" pitchFamily="2" charset="-122"/>
-                <a:ea typeface="宋体" panose="02010600030101010101" pitchFamily="2" charset="-122"/>
-                <a:cs typeface="宋体" panose="02010600030101010101" pitchFamily="2" charset="-122"/>
-              </a:rPr>
-              <a:t>，实现群聊消息的</a:t>
-            </a:r>
-            <a:r>
-              <a:rPr lang="zh-CN" altLang="en-US" sz="800" b="1" dirty="0">
-                <a:latin typeface="宋体" panose="02010600030101010101" pitchFamily="2" charset="-122"/>
-                <a:ea typeface="宋体" panose="02010600030101010101" pitchFamily="2" charset="-122"/>
-                <a:cs typeface="宋体" panose="02010600030101010101" pitchFamily="2" charset="-122"/>
-              </a:rPr>
-              <a:t>异步入库与推送</a:t>
-            </a:r>
-            <a:r>
-              <a:rPr lang="zh-CN" altLang="en-US" sz="800" dirty="0">
-                <a:latin typeface="宋体" panose="02010600030101010101" pitchFamily="2" charset="-122"/>
-                <a:ea typeface="宋体" panose="02010600030101010101" pitchFamily="2" charset="-122"/>
-                <a:cs typeface="宋体" panose="02010600030101010101" pitchFamily="2" charset="-122"/>
-              </a:rPr>
-              <a:t>，确保内容合规同时显著提升接口性能。 </a:t>
-            </a:r>
-            <a:r>
-              <a:rPr lang="en-US" altLang="zh-CN" sz="800" dirty="0">
-                <a:latin typeface="宋体" panose="02010600030101010101" pitchFamily="2" charset="-122"/>
-                <a:ea typeface="宋体" panose="02010600030101010101" pitchFamily="2" charset="-122"/>
-                <a:cs typeface="宋体" panose="02010600030101010101" pitchFamily="2" charset="-122"/>
-              </a:rPr>
-              <a:t>	</a:t>
-            </a:r>
-            <a:endParaRPr lang="en-US" altLang="zh-CN" sz="800" dirty="0">
-              <a:latin typeface="宋体" panose="02010600030101010101" pitchFamily="2" charset="-122"/>
-              <a:ea typeface="宋体" panose="02010600030101010101" pitchFamily="2" charset="-122"/>
-              <a:cs typeface="宋体" panose="02010600030101010101" pitchFamily="2" charset="-122"/>
-            </a:endParaRPr>
-          </a:p>
-          <a:p>
-            <a:pPr>
-              <a:lnSpc>
-                <a:spcPts val="1520"/>
-              </a:lnSpc>
-            </a:pPr>
-            <a:r>
-              <a:rPr lang="en-US" altLang="zh-CN" sz="800" b="1" dirty="0">
-                <a:latin typeface="宋体" panose="02010600030101010101" pitchFamily="2" charset="-122"/>
-                <a:ea typeface="宋体" panose="02010600030101010101" pitchFamily="2" charset="-122"/>
-                <a:cs typeface="宋体" panose="02010600030101010101" pitchFamily="2" charset="-122"/>
-              </a:rPr>
-              <a:t>	</a:t>
-            </a:r>
-            <a:r>
-              <a:rPr lang="zh-CN" altLang="en-US" sz="800" b="1" dirty="0">
-                <a:latin typeface="宋体" panose="02010600030101010101" pitchFamily="2" charset="-122"/>
-                <a:ea typeface="宋体" panose="02010600030101010101" pitchFamily="2" charset="-122"/>
-                <a:cs typeface="宋体" panose="02010600030101010101" pitchFamily="2" charset="-122"/>
-              </a:rPr>
-              <a:t>限流控制：</a:t>
-            </a:r>
-            <a:r>
-              <a:rPr lang="zh-CN" altLang="en-US" sz="800" dirty="0">
-                <a:latin typeface="宋体" panose="02010600030101010101" pitchFamily="2" charset="-122"/>
-                <a:ea typeface="宋体" panose="02010600030101010101" pitchFamily="2" charset="-122"/>
-                <a:cs typeface="宋体" panose="02010600030101010101" pitchFamily="2" charset="-122"/>
-              </a:rPr>
-              <a:t>自定义注解实现高复用，结合 </a:t>
-            </a:r>
-            <a:r>
-              <a:rPr lang="en-US" altLang="zh-CN" sz="800" b="1" dirty="0">
-                <a:latin typeface="宋体" panose="02010600030101010101" pitchFamily="2" charset="-122"/>
-                <a:ea typeface="宋体" panose="02010600030101010101" pitchFamily="2" charset="-122"/>
-                <a:cs typeface="宋体" panose="02010600030101010101" pitchFamily="2" charset="-122"/>
-              </a:rPr>
-              <a:t>AOP + </a:t>
-            </a:r>
-            <a:r>
-              <a:rPr lang="en-US" altLang="zh-CN" sz="800" b="1" dirty="0" err="1">
-                <a:latin typeface="宋体" panose="02010600030101010101" pitchFamily="2" charset="-122"/>
-                <a:ea typeface="宋体" panose="02010600030101010101" pitchFamily="2" charset="-122"/>
-                <a:cs typeface="宋体" panose="02010600030101010101" pitchFamily="2" charset="-122"/>
-              </a:rPr>
-              <a:t>SpEL</a:t>
-            </a:r>
-            <a:r>
-              <a:rPr lang="en-US" altLang="zh-CN" sz="800" b="1" dirty="0">
-                <a:latin typeface="宋体" panose="02010600030101010101" pitchFamily="2" charset="-122"/>
-                <a:ea typeface="宋体" panose="02010600030101010101" pitchFamily="2" charset="-122"/>
-                <a:cs typeface="宋体" panose="02010600030101010101" pitchFamily="2" charset="-122"/>
-              </a:rPr>
-              <a:t> </a:t>
-            </a:r>
-            <a:r>
-              <a:rPr lang="zh-CN" altLang="en-US" sz="800" b="1" dirty="0">
-                <a:latin typeface="宋体" panose="02010600030101010101" pitchFamily="2" charset="-122"/>
-                <a:ea typeface="宋体" panose="02010600030101010101" pitchFamily="2" charset="-122"/>
-                <a:cs typeface="宋体" panose="02010600030101010101" pitchFamily="2" charset="-122"/>
-              </a:rPr>
-              <a:t>表达式</a:t>
-            </a:r>
-            <a:r>
-              <a:rPr lang="zh-CN" altLang="en-US" sz="800" dirty="0">
-                <a:latin typeface="宋体" panose="02010600030101010101" pitchFamily="2" charset="-122"/>
-                <a:ea typeface="宋体" panose="02010600030101010101" pitchFamily="2" charset="-122"/>
-                <a:cs typeface="宋体" panose="02010600030101010101" pitchFamily="2" charset="-122"/>
-              </a:rPr>
-              <a:t>，实现接口级限流防刷功能，支持用户、</a:t>
-            </a:r>
-            <a:r>
-              <a:rPr lang="en-US" altLang="zh-CN" sz="800" dirty="0">
-                <a:latin typeface="宋体" panose="02010600030101010101" pitchFamily="2" charset="-122"/>
-                <a:ea typeface="宋体" panose="02010600030101010101" pitchFamily="2" charset="-122"/>
-                <a:cs typeface="宋体" panose="02010600030101010101" pitchFamily="2" charset="-122"/>
-              </a:rPr>
-              <a:t>IP</a:t>
-            </a:r>
-            <a:r>
-              <a:rPr lang="zh-CN" altLang="en-US" sz="800" dirty="0">
-                <a:latin typeface="宋体" panose="02010600030101010101" pitchFamily="2" charset="-122"/>
-                <a:ea typeface="宋体" panose="02010600030101010101" pitchFamily="2" charset="-122"/>
-                <a:cs typeface="宋体" panose="02010600030101010101" pitchFamily="2" charset="-122"/>
-              </a:rPr>
-              <a:t>、接口维度灵活限流</a:t>
-            </a:r>
-            <a:r>
-              <a:rPr lang="zh-CN" altLang="en-US" sz="800" b="1" dirty="0">
-                <a:latin typeface="宋体" panose="02010600030101010101" pitchFamily="2" charset="-122"/>
-                <a:ea typeface="宋体" panose="02010600030101010101" pitchFamily="2" charset="-122"/>
-                <a:cs typeface="宋体" panose="02010600030101010101" pitchFamily="2" charset="-122"/>
-              </a:rPr>
-              <a:t>。</a:t>
-            </a:r>
-            <a:endParaRPr lang="en-US" altLang="zh-CN" sz="800" b="1" dirty="0">
-              <a:latin typeface="宋体" panose="02010600030101010101" pitchFamily="2" charset="-122"/>
-              <a:ea typeface="宋体" panose="02010600030101010101" pitchFamily="2" charset="-122"/>
-              <a:cs typeface="宋体" panose="02010600030101010101" pitchFamily="2" charset="-122"/>
-            </a:endParaRPr>
-          </a:p>
-          <a:p>
-            <a:pPr>
-              <a:lnSpc>
-                <a:spcPts val="1520"/>
-              </a:lnSpc>
-            </a:pPr>
-            <a:r>
-              <a:rPr lang="en-US" altLang="zh-CN" sz="800" b="1" dirty="0">
-                <a:latin typeface="宋体" panose="02010600030101010101" pitchFamily="2" charset="-122"/>
-                <a:ea typeface="宋体" panose="02010600030101010101" pitchFamily="2" charset="-122"/>
-                <a:cs typeface="宋体" panose="02010600030101010101" pitchFamily="2" charset="-122"/>
-              </a:rPr>
-              <a:t>	</a:t>
-            </a:r>
-            <a:r>
-              <a:rPr lang="zh-CN" altLang="en-US" sz="800" b="1" dirty="0">
-                <a:latin typeface="宋体" panose="02010600030101010101" pitchFamily="2" charset="-122"/>
-                <a:ea typeface="宋体" panose="02010600030101010101" pitchFamily="2" charset="-122"/>
-                <a:cs typeface="宋体" panose="02010600030101010101" pitchFamily="2" charset="-122"/>
-              </a:rPr>
-              <a:t>日志记录：</a:t>
-            </a:r>
-            <a:r>
-              <a:rPr lang="zh-CN" altLang="en-US" sz="800" dirty="0">
-                <a:latin typeface="宋体" panose="02010600030101010101" pitchFamily="2" charset="-122"/>
-                <a:ea typeface="宋体" panose="02010600030101010101" pitchFamily="2" charset="-122"/>
-                <a:cs typeface="宋体" panose="02010600030101010101" pitchFamily="2" charset="-122"/>
-              </a:rPr>
-              <a:t>使用 </a:t>
-            </a:r>
-            <a:r>
-              <a:rPr lang="en-US" altLang="zh-CN" sz="800" b="1" dirty="0">
-                <a:latin typeface="宋体" panose="02010600030101010101" pitchFamily="2" charset="-122"/>
-                <a:ea typeface="宋体" panose="02010600030101010101" pitchFamily="2" charset="-122"/>
-                <a:cs typeface="宋体" panose="02010600030101010101" pitchFamily="2" charset="-122"/>
-              </a:rPr>
-              <a:t>MDC </a:t>
-            </a:r>
-            <a:r>
-              <a:rPr lang="zh-CN" altLang="en-US" sz="800" dirty="0">
-                <a:latin typeface="宋体" panose="02010600030101010101" pitchFamily="2" charset="-122"/>
-                <a:ea typeface="宋体" panose="02010600030101010101" pitchFamily="2" charset="-122"/>
-                <a:cs typeface="宋体" panose="02010600030101010101" pitchFamily="2" charset="-122"/>
-              </a:rPr>
-              <a:t>日志上下文机制，通过</a:t>
-            </a:r>
-            <a:r>
-              <a:rPr lang="en-US" altLang="zh-CN" sz="800" dirty="0">
-                <a:latin typeface="宋体" panose="02010600030101010101" pitchFamily="2" charset="-122"/>
-                <a:ea typeface="宋体" panose="02010600030101010101" pitchFamily="2" charset="-122"/>
-                <a:cs typeface="宋体" panose="02010600030101010101" pitchFamily="2" charset="-122"/>
-              </a:rPr>
-              <a:t>Filter </a:t>
-            </a:r>
-            <a:r>
-              <a:rPr lang="zh-CN" altLang="en-US" sz="800" dirty="0">
-                <a:latin typeface="宋体" panose="02010600030101010101" pitchFamily="2" charset="-122"/>
-                <a:ea typeface="宋体" panose="02010600030101010101" pitchFamily="2" charset="-122"/>
-                <a:cs typeface="宋体" panose="02010600030101010101" pitchFamily="2" charset="-122"/>
-              </a:rPr>
-              <a:t>统一生成 </a:t>
-            </a:r>
-            <a:r>
-              <a:rPr lang="en-US" altLang="zh-CN" sz="800" dirty="0" err="1">
-                <a:latin typeface="宋体" panose="02010600030101010101" pitchFamily="2" charset="-122"/>
-                <a:ea typeface="宋体" panose="02010600030101010101" pitchFamily="2" charset="-122"/>
-                <a:cs typeface="宋体" panose="02010600030101010101" pitchFamily="2" charset="-122"/>
-              </a:rPr>
-              <a:t>traceId</a:t>
-            </a:r>
-            <a:r>
-              <a:rPr lang="zh-CN" altLang="en-US" sz="800" dirty="0">
-                <a:latin typeface="宋体" panose="02010600030101010101" pitchFamily="2" charset="-122"/>
-                <a:ea typeface="宋体" panose="02010600030101010101" pitchFamily="2" charset="-122"/>
-                <a:cs typeface="宋体" panose="02010600030101010101" pitchFamily="2" charset="-122"/>
-              </a:rPr>
-              <a:t>，并结合 </a:t>
-            </a:r>
-            <a:r>
-              <a:rPr lang="en-US" altLang="zh-CN" sz="800" dirty="0" err="1">
-                <a:latin typeface="宋体" panose="02010600030101010101" pitchFamily="2" charset="-122"/>
-                <a:ea typeface="宋体" panose="02010600030101010101" pitchFamily="2" charset="-122"/>
-                <a:cs typeface="宋体" panose="02010600030101010101" pitchFamily="2" charset="-122"/>
-              </a:rPr>
-              <a:t>ThreadLocal</a:t>
-            </a:r>
-            <a:r>
-              <a:rPr lang="zh-CN" altLang="en-US" sz="800" dirty="0">
-                <a:latin typeface="宋体" panose="02010600030101010101" pitchFamily="2" charset="-122"/>
-                <a:ea typeface="宋体" panose="02010600030101010101" pitchFamily="2" charset="-122"/>
-                <a:cs typeface="宋体" panose="02010600030101010101" pitchFamily="2" charset="-122"/>
-              </a:rPr>
-              <a:t>、</a:t>
-            </a:r>
-            <a:r>
-              <a:rPr lang="en-US" altLang="zh-CN" sz="800" dirty="0">
-                <a:latin typeface="宋体" panose="02010600030101010101" pitchFamily="2" charset="-122"/>
-                <a:ea typeface="宋体" panose="02010600030101010101" pitchFamily="2" charset="-122"/>
-                <a:cs typeface="宋体" panose="02010600030101010101" pitchFamily="2" charset="-122"/>
-              </a:rPr>
-              <a:t>MDC</a:t>
-            </a:r>
-            <a:r>
-              <a:rPr lang="zh-CN" altLang="en-US" sz="800" dirty="0">
-                <a:latin typeface="宋体" panose="02010600030101010101" pitchFamily="2" charset="-122"/>
-                <a:ea typeface="宋体" panose="02010600030101010101" pitchFamily="2" charset="-122"/>
-                <a:cs typeface="宋体" panose="02010600030101010101" pitchFamily="2" charset="-122"/>
-              </a:rPr>
-              <a:t>注入线程上下文，</a:t>
-            </a:r>
-            <a:endParaRPr lang="en-US" altLang="zh-CN" sz="800" dirty="0">
-              <a:latin typeface="宋体" panose="02010600030101010101" pitchFamily="2" charset="-122"/>
-              <a:ea typeface="宋体" panose="02010600030101010101" pitchFamily="2" charset="-122"/>
-              <a:cs typeface="宋体" panose="02010600030101010101" pitchFamily="2" charset="-122"/>
-            </a:endParaRPr>
-          </a:p>
-          <a:p>
-            <a:pPr>
-              <a:lnSpc>
-                <a:spcPts val="1520"/>
-              </a:lnSpc>
-            </a:pPr>
-            <a:r>
               <a:rPr lang="en-US" altLang="zh-CN" sz="800" dirty="0">
                 <a:latin typeface="宋体" panose="02010600030101010101" pitchFamily="2" charset="-122"/>
                 <a:ea typeface="宋体" panose="02010600030101010101" pitchFamily="2" charset="-122"/>
@@ -5968,43 +5569,6 @@
           </a:p>
         </p:txBody>
       </p:sp>
-      <p:cxnSp>
-        <p:nvCxnSpPr>
-          <p:cNvPr id="108" name="直接连接符 107"/>
-          <p:cNvCxnSpPr/>
-          <p:nvPr/>
-        </p:nvCxnSpPr>
-        <p:spPr>
-          <a:xfrm>
-            <a:off x="135263" y="7689332"/>
-            <a:ext cx="6427236" cy="0"/>
-          </a:xfrm>
-          <a:prstGeom prst="line">
-            <a:avLst/>
-          </a:prstGeom>
-          <a:ln w="9525">
-            <a:solidFill>
-              <a:schemeClr val="accent1">
-                <a:lumMod val="50000"/>
-              </a:schemeClr>
-            </a:solidFill>
-          </a:ln>
-        </p:spPr>
-        <p:style>
-          <a:lnRef idx="1">
-            <a:schemeClr val="accent1"/>
-          </a:lnRef>
-          <a:fillRef idx="0">
-            <a:schemeClr val="accent1"/>
-          </a:fillRef>
-          <a:effectRef idx="0">
-            <a:schemeClr val="accent1"/>
-          </a:effectRef>
-          <a:fontRef idx="minor">
-            <a:schemeClr val="tx1"/>
-          </a:fontRef>
-        </p:style>
-      </p:cxnSp>
       <p:pic>
         <p:nvPicPr>
           <p:cNvPr id="3" name="图片 2" descr="IcBaselineWechat"/>
@@ -6069,7 +5633,7 @@
         </p:blipFill>
         <p:spPr>
           <a:xfrm>
-            <a:off x="207010" y="4808855"/>
+            <a:off x="210820" y="6681470"/>
             <a:ext cx="196850" cy="196850"/>
           </a:xfrm>
           <a:prstGeom prst="rect">
@@ -6085,7 +5649,7 @@
         </p:nvSpPr>
         <p:spPr>
           <a:xfrm>
-            <a:off x="407670" y="4808855"/>
+            <a:off x="407670" y="6681470"/>
             <a:ext cx="3650615" cy="196850"/>
           </a:xfrm>
           <a:prstGeom prst="rect">
@@ -6148,7 +5712,7 @@
         </p:nvSpPr>
         <p:spPr>
           <a:xfrm>
-            <a:off x="79375" y="2545715"/>
+            <a:off x="90805" y="2504440"/>
             <a:ext cx="6296025" cy="263525"/>
           </a:xfrm>
           <a:prstGeom prst="rect">
@@ -6170,13 +5734,22 @@
               <a:buFontTx/>
             </a:pPr>
             <a:r>
-              <a:rPr lang="zh-CN" altLang="en-US" sz="800" dirty="0">
+              <a:rPr lang="zh-CN" altLang="en-US" sz="800" b="1" dirty="0">
                 <a:latin typeface="阿里巴巴普惠体 R" panose="00020600040101010101" pitchFamily="18" charset="-122"/>
                 <a:ea typeface="阿里巴巴普惠体 R" panose="00020600040101010101" pitchFamily="18" charset="-122"/>
                 <a:cs typeface="阿里巴巴普惠体 R" panose="00020600040101010101" pitchFamily="18" charset="-122"/>
                 <a:sym typeface="+mn-ea"/>
               </a:rPr>
               <a:t>福州琢木鸟信息科技有限公司</a:t>
+            </a:r>
+            <a:r>
+              <a:rPr lang="en-US" altLang="zh-CN" sz="800" b="1" dirty="0">
+                <a:latin typeface="阿里巴巴普惠体 R" panose="00020600040101010101" pitchFamily="18" charset="-122"/>
+                <a:ea typeface="阿里巴巴普惠体 R" panose="00020600040101010101" pitchFamily="18" charset="-122"/>
+                <a:cs typeface="阿里巴巴普惠体 R" panose="00020600040101010101" pitchFamily="18" charset="-122"/>
+                <a:sym typeface="+mn-ea"/>
+              </a:rPr>
+              <a:t>	</a:t>
             </a:r>
             <a:r>
               <a:rPr lang="en-US" altLang="zh-CN" sz="800" dirty="0">
@@ -6185,21 +5758,76 @@
                 <a:cs typeface="阿里巴巴普惠体 R" panose="00020600040101010101" pitchFamily="18" charset="-122"/>
                 <a:sym typeface="+mn-ea"/>
               </a:rPr>
-              <a:t>			    </a:t>
-            </a:r>
-            <a:r>
-              <a:rPr lang="zh-CN" altLang="en-US" sz="800" dirty="0">
+              <a:t>		</a:t>
+            </a:r>
+            <a:r>
+              <a:rPr lang="en-US" altLang="zh-CN" sz="800" b="1" dirty="0">
                 <a:latin typeface="阿里巴巴普惠体 R" panose="00020600040101010101" pitchFamily="18" charset="-122"/>
                 <a:ea typeface="阿里巴巴普惠体 R" panose="00020600040101010101" pitchFamily="18" charset="-122"/>
                 <a:cs typeface="阿里巴巴普惠体 R" panose="00020600040101010101" pitchFamily="18" charset="-122"/>
                 <a:sym typeface="+mn-ea"/>
               </a:rPr>
-              <a:t>2025/7 – 2025/9				    后端开发</a:t>
-            </a:r>
-            <a:endParaRPr lang="zh-CN" altLang="en-US" sz="1400" dirty="0" smtClean="0">
+              <a:t>    </a:t>
+            </a:r>
+            <a:r>
+              <a:rPr lang="zh-CN" altLang="en-US" sz="800" b="1" dirty="0">
+                <a:latin typeface="阿里巴巴普惠体 R" panose="00020600040101010101" pitchFamily="18" charset="-122"/>
+                <a:ea typeface="阿里巴巴普惠体 R" panose="00020600040101010101" pitchFamily="18" charset="-122"/>
+                <a:cs typeface="阿里巴巴普惠体 R" panose="00020600040101010101" pitchFamily="18" charset="-122"/>
+                <a:sym typeface="+mn-ea"/>
+              </a:rPr>
+              <a:t>2025/</a:t>
+            </a:r>
+            <a:r>
+              <a:rPr lang="en-US" altLang="zh-CN" sz="800" b="1" dirty="0">
+                <a:latin typeface="阿里巴巴普惠体 R" panose="00020600040101010101" pitchFamily="18" charset="-122"/>
+                <a:ea typeface="阿里巴巴普惠体 R" panose="00020600040101010101" pitchFamily="18" charset="-122"/>
+                <a:cs typeface="阿里巴巴普惠体 R" panose="00020600040101010101" pitchFamily="18" charset="-122"/>
+                <a:sym typeface="+mn-ea"/>
+              </a:rPr>
+              <a:t>6</a:t>
+            </a:r>
+            <a:r>
+              <a:rPr lang="zh-CN" altLang="en-US" sz="800" b="1" dirty="0">
+                <a:latin typeface="阿里巴巴普惠体 R" panose="00020600040101010101" pitchFamily="18" charset="-122"/>
+                <a:ea typeface="阿里巴巴普惠体 R" panose="00020600040101010101" pitchFamily="18" charset="-122"/>
+                <a:cs typeface="阿里巴巴普惠体 R" panose="00020600040101010101" pitchFamily="18" charset="-122"/>
+                <a:sym typeface="+mn-ea"/>
+              </a:rPr>
+              <a:t> – 2025/</a:t>
+            </a:r>
+            <a:r>
+              <a:rPr lang="en-US" altLang="zh-CN" sz="800" b="1" dirty="0">
+                <a:latin typeface="阿里巴巴普惠体 R" panose="00020600040101010101" pitchFamily="18" charset="-122"/>
+                <a:ea typeface="阿里巴巴普惠体 R" panose="00020600040101010101" pitchFamily="18" charset="-122"/>
+                <a:cs typeface="阿里巴巴普惠体 R" panose="00020600040101010101" pitchFamily="18" charset="-122"/>
+                <a:sym typeface="+mn-ea"/>
+              </a:rPr>
+              <a:t>8</a:t>
+            </a:r>
+            <a:r>
+              <a:rPr lang="zh-CN" altLang="en-US" sz="800" dirty="0">
+                <a:latin typeface="阿里巴巴普惠体 R" panose="00020600040101010101" pitchFamily="18" charset="-122"/>
+                <a:ea typeface="阿里巴巴普惠体 R" panose="00020600040101010101" pitchFamily="18" charset="-122"/>
+                <a:cs typeface="阿里巴巴普惠体 R" panose="00020600040101010101" pitchFamily="18" charset="-122"/>
+                <a:sym typeface="+mn-ea"/>
+              </a:rPr>
+              <a:t>				    </a:t>
+            </a:r>
+            <a:r>
+              <a:rPr lang="zh-CN" altLang="en-US" sz="800" b="1" dirty="0">
+                <a:latin typeface="阿里巴巴普惠体 R" panose="00020600040101010101" pitchFamily="18" charset="-122"/>
+                <a:ea typeface="阿里巴巴普惠体 R" panose="00020600040101010101" pitchFamily="18" charset="-122"/>
+                <a:cs typeface="阿里巴巴普惠体 R" panose="00020600040101010101" pitchFamily="18" charset="-122"/>
+                <a:sym typeface="+mn-ea"/>
+              </a:rPr>
+              <a:t>后端开发实习生</a:t>
+            </a:r>
+            <a:endParaRPr lang="zh-CN" altLang="en-US" sz="800" b="1" dirty="0">
               <a:latin typeface="阿里巴巴普惠体 R" panose="00020600040101010101" pitchFamily="18" charset="-122"/>
               <a:ea typeface="阿里巴巴普惠体 R" panose="00020600040101010101" pitchFamily="18" charset="-122"/>
               <a:cs typeface="阿里巴巴普惠体 R" panose="00020600040101010101" pitchFamily="18" charset="-122"/>
+              <a:sym typeface="+mn-ea"/>
             </a:endParaRPr>
           </a:p>
         </p:txBody>
@@ -6212,8 +5840,8 @@
         </p:nvSpPr>
         <p:spPr>
           <a:xfrm>
-            <a:off x="79375" y="2799715"/>
-            <a:ext cx="6064250" cy="1374140"/>
+            <a:off x="76200" y="2720340"/>
+            <a:ext cx="6544310" cy="1739900"/>
           </a:xfrm>
           <a:prstGeom prst="rect">
             <a:avLst/>
@@ -6228,16 +5856,400 @@
             <a:pPr algn="l"/>
             <a:r>
               <a:rPr lang="zh-CN" altLang="en-US" sz="800" b="1" dirty="0" smtClean="0">
+                <a:latin typeface="宋体" panose="02010600030101010101" pitchFamily="2" charset="-122"/>
+                <a:ea typeface="宋体" panose="02010600030101010101" pitchFamily="2" charset="-122"/>
+                <a:cs typeface="宋体" panose="02010600030101010101" pitchFamily="2" charset="-122"/>
+              </a:rPr>
+              <a:t>主要职责：负责社会福利院轮候审批流程、床位管理、统计分析等核心业务模块的后端开发与性能优化工作。</a:t>
+            </a:r>
+            <a:endParaRPr lang="zh-CN" altLang="en-US" sz="800" b="1" u="sng" dirty="0" smtClean="0">
+              <a:latin typeface="宋体" panose="02010600030101010101" pitchFamily="2" charset="-122"/>
+              <a:ea typeface="宋体" panose="02010600030101010101" pitchFamily="2" charset="-122"/>
+              <a:cs typeface="宋体" panose="02010600030101010101" pitchFamily="2" charset="-122"/>
+            </a:endParaRPr>
+          </a:p>
+          <a:p>
+            <a:pPr algn="l"/>
+            <a:endParaRPr lang="en-US" altLang="zh-CN" sz="800" b="1" dirty="0" smtClean="0">
+              <a:latin typeface="宋体" panose="02010600030101010101" pitchFamily="2" charset="-122"/>
+              <a:ea typeface="宋体" panose="02010600030101010101" pitchFamily="2" charset="-122"/>
+              <a:cs typeface="宋体" panose="02010600030101010101" pitchFamily="2" charset="-122"/>
+            </a:endParaRPr>
+          </a:p>
+          <a:p>
+            <a:pPr algn="l"/>
+            <a:r>
+              <a:rPr lang="zh-CN" altLang="en-US" sz="800" dirty="0" smtClean="0">
+                <a:latin typeface="宋体" panose="02010600030101010101" pitchFamily="2" charset="-122"/>
+                <a:ea typeface="宋体" panose="02010600030101010101" pitchFamily="2" charset="-122"/>
+                <a:cs typeface="宋体" panose="02010600030101010101" pitchFamily="2" charset="-122"/>
+              </a:rPr>
+              <a:t>针对入住户数据统计接口</a:t>
+            </a:r>
+            <a:r>
+              <a:rPr lang="en-US" altLang="zh-CN" sz="800" dirty="0" smtClean="0">
+                <a:latin typeface="宋体" panose="02010600030101010101" pitchFamily="2" charset="-122"/>
+                <a:ea typeface="宋体" panose="02010600030101010101" pitchFamily="2" charset="-122"/>
+                <a:cs typeface="宋体" panose="02010600030101010101" pitchFamily="2" charset="-122"/>
+              </a:rPr>
+              <a:t> 900ms </a:t>
+            </a:r>
+            <a:r>
+              <a:rPr lang="zh-CN" altLang="en-US" sz="800" dirty="0" smtClean="0">
+                <a:latin typeface="宋体" panose="02010600030101010101" pitchFamily="2" charset="-122"/>
+                <a:ea typeface="宋体" panose="02010600030101010101" pitchFamily="2" charset="-122"/>
+                <a:cs typeface="宋体" panose="02010600030101010101" pitchFamily="2" charset="-122"/>
+              </a:rPr>
+              <a:t>的响应瓶颈，使用窗口函数替代关联子查询、</a:t>
+            </a:r>
+            <a:r>
+              <a:rPr lang="en-US" altLang="zh-CN" sz="800" dirty="0" smtClean="0">
+                <a:latin typeface="宋体" panose="02010600030101010101" pitchFamily="2" charset="-122"/>
+                <a:ea typeface="宋体" panose="02010600030101010101" pitchFamily="2" charset="-122"/>
+                <a:cs typeface="宋体" panose="02010600030101010101" pitchFamily="2" charset="-122"/>
+              </a:rPr>
+              <a:t>UNION ALL</a:t>
+            </a:r>
+            <a:r>
+              <a:rPr lang="zh-CN" altLang="en-US" sz="800" dirty="0" smtClean="0">
+                <a:latin typeface="宋体" panose="02010600030101010101" pitchFamily="2" charset="-122"/>
+                <a:ea typeface="宋体" panose="02010600030101010101" pitchFamily="2" charset="-122"/>
+                <a:cs typeface="宋体" panose="02010600030101010101" pitchFamily="2" charset="-122"/>
+              </a:rPr>
+              <a:t>替换递归</a:t>
+            </a:r>
+            <a:r>
+              <a:rPr lang="en-US" altLang="zh-CN" sz="800" dirty="0" smtClean="0">
+                <a:latin typeface="宋体" panose="02010600030101010101" pitchFamily="2" charset="-122"/>
+                <a:ea typeface="宋体" panose="02010600030101010101" pitchFamily="2" charset="-122"/>
+                <a:cs typeface="宋体" panose="02010600030101010101" pitchFamily="2" charset="-122"/>
+              </a:rPr>
+              <a:t> CTE</a:t>
+            </a:r>
+            <a:r>
+              <a:rPr lang="zh-CN" altLang="en-US" sz="800" dirty="0" smtClean="0">
+                <a:latin typeface="宋体" panose="02010600030101010101" pitchFamily="2" charset="-122"/>
+                <a:ea typeface="宋体" panose="02010600030101010101" pitchFamily="2" charset="-122"/>
+                <a:cs typeface="宋体" panose="02010600030101010101" pitchFamily="2" charset="-122"/>
+              </a:rPr>
+              <a:t>，并基于</a:t>
+            </a:r>
+            <a:r>
+              <a:rPr lang="en-US" altLang="zh-CN" sz="800" dirty="0" smtClean="0">
+                <a:latin typeface="宋体" panose="02010600030101010101" pitchFamily="2" charset="-122"/>
+                <a:ea typeface="宋体" panose="02010600030101010101" pitchFamily="2" charset="-122"/>
+                <a:cs typeface="宋体" panose="02010600030101010101" pitchFamily="2" charset="-122"/>
+              </a:rPr>
+              <a:t>CompletableFuture+ </a:t>
+            </a:r>
+            <a:r>
+              <a:rPr lang="zh-CN" altLang="en-US" sz="800" dirty="0" smtClean="0">
+                <a:latin typeface="宋体" panose="02010600030101010101" pitchFamily="2" charset="-122"/>
+                <a:ea typeface="宋体" panose="02010600030101010101" pitchFamily="2" charset="-122"/>
+                <a:cs typeface="宋体" panose="02010600030101010101" pitchFamily="2" charset="-122"/>
+              </a:rPr>
+              <a:t>自定义线程池实现</a:t>
+            </a:r>
+            <a:r>
+              <a:rPr lang="en-US" altLang="zh-CN" sz="800" dirty="0" smtClean="0">
+                <a:latin typeface="宋体" panose="02010600030101010101" pitchFamily="2" charset="-122"/>
+                <a:ea typeface="宋体" panose="02010600030101010101" pitchFamily="2" charset="-122"/>
+                <a:cs typeface="宋体" panose="02010600030101010101" pitchFamily="2" charset="-122"/>
+              </a:rPr>
+              <a:t> 4 </a:t>
+            </a:r>
+            <a:r>
+              <a:rPr lang="zh-CN" altLang="en-US" sz="800" dirty="0" smtClean="0">
+                <a:latin typeface="宋体" panose="02010600030101010101" pitchFamily="2" charset="-122"/>
+                <a:ea typeface="宋体" panose="02010600030101010101" pitchFamily="2" charset="-122"/>
+                <a:cs typeface="宋体" panose="02010600030101010101" pitchFamily="2" charset="-122"/>
+              </a:rPr>
+              <a:t>个核心查询并行执行，最终接口</a:t>
+            </a:r>
+            <a:r>
+              <a:rPr lang="zh-CN" altLang="en-US" sz="800" b="1" dirty="0" smtClean="0">
+                <a:latin typeface="宋体" panose="02010600030101010101" pitchFamily="2" charset="-122"/>
+                <a:ea typeface="宋体" panose="02010600030101010101" pitchFamily="2" charset="-122"/>
+                <a:cs typeface="宋体" panose="02010600030101010101" pitchFamily="2" charset="-122"/>
+              </a:rPr>
+              <a:t>响应降至</a:t>
+            </a:r>
+            <a:r>
+              <a:rPr lang="en-US" altLang="zh-CN" sz="800" b="1" dirty="0" smtClean="0">
+                <a:latin typeface="宋体" panose="02010600030101010101" pitchFamily="2" charset="-122"/>
+                <a:ea typeface="宋体" panose="02010600030101010101" pitchFamily="2" charset="-122"/>
+                <a:cs typeface="宋体" panose="02010600030101010101" pitchFamily="2" charset="-122"/>
+              </a:rPr>
+              <a:t> 9ms</a:t>
+            </a:r>
+            <a:r>
+              <a:rPr lang="zh-CN" altLang="en-US" sz="800" b="1" dirty="0" smtClean="0">
+                <a:latin typeface="宋体" panose="02010600030101010101" pitchFamily="2" charset="-122"/>
+                <a:ea typeface="宋体" panose="02010600030101010101" pitchFamily="2" charset="-122"/>
+                <a:cs typeface="宋体" panose="02010600030101010101" pitchFamily="2" charset="-122"/>
+              </a:rPr>
+              <a:t>，性能提升超</a:t>
+            </a:r>
+            <a:r>
+              <a:rPr lang="en-US" altLang="zh-CN" sz="800" b="1" dirty="0" smtClean="0">
+                <a:latin typeface="宋体" panose="02010600030101010101" pitchFamily="2" charset="-122"/>
+                <a:ea typeface="宋体" panose="02010600030101010101" pitchFamily="2" charset="-122"/>
+                <a:cs typeface="宋体" panose="02010600030101010101" pitchFamily="2" charset="-122"/>
+              </a:rPr>
+              <a:t> 99%</a:t>
+            </a:r>
+            <a:r>
+              <a:rPr lang="zh-CN" altLang="en-US" sz="800" b="1" dirty="0" smtClean="0">
+                <a:latin typeface="宋体" panose="02010600030101010101" pitchFamily="2" charset="-122"/>
+                <a:ea typeface="宋体" panose="02010600030101010101" pitchFamily="2" charset="-122"/>
+                <a:cs typeface="宋体" panose="02010600030101010101" pitchFamily="2" charset="-122"/>
+              </a:rPr>
+              <a:t>。</a:t>
+            </a:r>
+            <a:endParaRPr lang="zh-CN" altLang="en-US" sz="800" b="1" dirty="0" smtClean="0">
+              <a:latin typeface="宋体" panose="02010600030101010101" pitchFamily="2" charset="-122"/>
+              <a:ea typeface="宋体" panose="02010600030101010101" pitchFamily="2" charset="-122"/>
+              <a:cs typeface="宋体" panose="02010600030101010101" pitchFamily="2" charset="-122"/>
+            </a:endParaRPr>
+          </a:p>
+          <a:p>
+            <a:pPr algn="l"/>
+            <a:endParaRPr lang="en-US" altLang="zh-CN" sz="800" dirty="0" smtClean="0">
+              <a:latin typeface="宋体" panose="02010600030101010101" pitchFamily="2" charset="-122"/>
+              <a:ea typeface="宋体" panose="02010600030101010101" pitchFamily="2" charset="-122"/>
+              <a:cs typeface="宋体" panose="02010600030101010101" pitchFamily="2" charset="-122"/>
+            </a:endParaRPr>
+          </a:p>
+          <a:p>
+            <a:pPr algn="l"/>
+            <a:r>
+              <a:rPr lang="zh-CN" altLang="en-US" sz="800" dirty="0" smtClean="0">
+                <a:latin typeface="宋体" panose="02010600030101010101" pitchFamily="2" charset="-122"/>
+                <a:ea typeface="宋体" panose="02010600030101010101" pitchFamily="2" charset="-122"/>
+                <a:cs typeface="宋体" panose="02010600030101010101" pitchFamily="2" charset="-122"/>
+              </a:rPr>
+              <a:t>针对养老院集中审批期全局锁导致不同老人申请单阻塞、响应超时的问题，自研申请单</a:t>
+            </a:r>
+            <a:r>
+              <a:rPr lang="en-US" altLang="zh-CN" sz="800" dirty="0" smtClean="0">
+                <a:latin typeface="宋体" panose="02010600030101010101" pitchFamily="2" charset="-122"/>
+                <a:ea typeface="宋体" panose="02010600030101010101" pitchFamily="2" charset="-122"/>
+                <a:cs typeface="宋体" panose="02010600030101010101" pitchFamily="2" charset="-122"/>
+              </a:rPr>
+              <a:t> ID </a:t>
+            </a:r>
+            <a:r>
+              <a:rPr lang="zh-CN" altLang="en-US" sz="800" dirty="0" smtClean="0">
+                <a:latin typeface="宋体" panose="02010600030101010101" pitchFamily="2" charset="-122"/>
+                <a:ea typeface="宋体" panose="02010600030101010101" pitchFamily="2" charset="-122"/>
+                <a:cs typeface="宋体" panose="02010600030101010101" pitchFamily="2" charset="-122"/>
+              </a:rPr>
+              <a:t>级读写锁组件，通过</a:t>
+            </a:r>
+            <a:r>
+              <a:rPr lang="en-US" altLang="zh-CN" sz="800" dirty="0" smtClean="0">
+                <a:latin typeface="宋体" panose="02010600030101010101" pitchFamily="2" charset="-122"/>
+                <a:ea typeface="宋体" panose="02010600030101010101" pitchFamily="2" charset="-122"/>
+                <a:cs typeface="宋体" panose="02010600030101010101" pitchFamily="2" charset="-122"/>
+              </a:rPr>
+              <a:t>ConcurrentHashMap</a:t>
+            </a:r>
+            <a:r>
+              <a:rPr lang="zh-CN" altLang="en-US" sz="800" dirty="0" smtClean="0">
+                <a:latin typeface="宋体" panose="02010600030101010101" pitchFamily="2" charset="-122"/>
+                <a:ea typeface="宋体" panose="02010600030101010101" pitchFamily="2" charset="-122"/>
+                <a:cs typeface="宋体" panose="02010600030101010101" pitchFamily="2" charset="-122"/>
+              </a:rPr>
+              <a:t>管理独立锁、</a:t>
+            </a:r>
+            <a:r>
+              <a:rPr lang="en-US" altLang="zh-CN" sz="800" dirty="0" smtClean="0">
+                <a:latin typeface="宋体" panose="02010600030101010101" pitchFamily="2" charset="-122"/>
+                <a:ea typeface="宋体" panose="02010600030101010101" pitchFamily="2" charset="-122"/>
+                <a:cs typeface="宋体" panose="02010600030101010101" pitchFamily="2" charset="-122"/>
+              </a:rPr>
+              <a:t>AtomicInteger</a:t>
+            </a:r>
+            <a:r>
+              <a:rPr lang="zh-CN" altLang="en-US" sz="800" dirty="0" smtClean="0">
+                <a:latin typeface="宋体" panose="02010600030101010101" pitchFamily="2" charset="-122"/>
+                <a:ea typeface="宋体" panose="02010600030101010101" pitchFamily="2" charset="-122"/>
+                <a:cs typeface="宋体" panose="02010600030101010101" pitchFamily="2" charset="-122"/>
+              </a:rPr>
+              <a:t>实现锁动态释放，搭配</a:t>
+            </a:r>
+            <a:r>
+              <a:rPr lang="en-US" altLang="zh-CN" sz="800" dirty="0" smtClean="0">
+                <a:latin typeface="宋体" panose="02010600030101010101" pitchFamily="2" charset="-122"/>
+                <a:ea typeface="宋体" panose="02010600030101010101" pitchFamily="2" charset="-122"/>
+                <a:cs typeface="宋体" panose="02010600030101010101" pitchFamily="2" charset="-122"/>
+              </a:rPr>
+              <a:t>tryLock()</a:t>
+            </a:r>
+            <a:r>
+              <a:rPr lang="zh-CN" altLang="en-US" sz="800" dirty="0" smtClean="0">
+                <a:latin typeface="宋体" panose="02010600030101010101" pitchFamily="2" charset="-122"/>
+                <a:ea typeface="宋体" panose="02010600030101010101" pitchFamily="2" charset="-122"/>
+                <a:cs typeface="宋体" panose="02010600030101010101" pitchFamily="2" charset="-122"/>
+              </a:rPr>
+              <a:t>非阻塞获取锁机制。</a:t>
+            </a:r>
+            <a:endParaRPr lang="zh-CN" altLang="en-US" sz="800" dirty="0" smtClean="0">
+              <a:latin typeface="宋体" panose="02010600030101010101" pitchFamily="2" charset="-122"/>
+              <a:ea typeface="宋体" panose="02010600030101010101" pitchFamily="2" charset="-122"/>
+              <a:cs typeface="宋体" panose="02010600030101010101" pitchFamily="2" charset="-122"/>
+            </a:endParaRPr>
+          </a:p>
+          <a:p>
+            <a:pPr algn="l"/>
+            <a:endParaRPr lang="en-US" altLang="zh-CN" sz="800" dirty="0" smtClean="0">
+              <a:latin typeface="宋体" panose="02010600030101010101" pitchFamily="2" charset="-122"/>
+              <a:ea typeface="宋体" panose="02010600030101010101" pitchFamily="2" charset="-122"/>
+              <a:cs typeface="宋体" panose="02010600030101010101" pitchFamily="2" charset="-122"/>
+            </a:endParaRPr>
+          </a:p>
+          <a:p>
+            <a:pPr algn="l"/>
+            <a:r>
+              <a:rPr lang="zh-CN" altLang="en-US" sz="800" dirty="0" smtClean="0">
+                <a:latin typeface="宋体" panose="02010600030101010101" pitchFamily="2" charset="-122"/>
+                <a:ea typeface="宋体" panose="02010600030101010101" pitchFamily="2" charset="-122"/>
+                <a:cs typeface="宋体" panose="02010600030101010101" pitchFamily="2" charset="-122"/>
+              </a:rPr>
+              <a:t>优化养老院入住审批自研状态机，构建条件校验、业务动作、上下文传递三层架构，适配审批状态回滚、申请撤销、过期自动作废等养老院实</a:t>
+            </a:r>
+            <a:endParaRPr lang="zh-CN" altLang="en-US" sz="800" dirty="0" smtClean="0">
+              <a:latin typeface="宋体" panose="02010600030101010101" pitchFamily="2" charset="-122"/>
+              <a:ea typeface="宋体" panose="02010600030101010101" pitchFamily="2" charset="-122"/>
+              <a:cs typeface="宋体" panose="02010600030101010101" pitchFamily="2" charset="-122"/>
+            </a:endParaRPr>
+          </a:p>
+          <a:p>
+            <a:pPr algn="l"/>
+            <a:r>
+              <a:rPr lang="zh-CN" altLang="en-US" sz="800" dirty="0" smtClean="0">
+                <a:latin typeface="宋体" panose="02010600030101010101" pitchFamily="2" charset="-122"/>
+                <a:ea typeface="宋体" panose="02010600030101010101" pitchFamily="2" charset="-122"/>
+                <a:cs typeface="宋体" panose="02010600030101010101" pitchFamily="2" charset="-122"/>
+              </a:rPr>
+              <a:t>际审批场景，实现审批状态转换规则动态调整（无需重启服务），新增审批节点仅需配置规则即可上线，</a:t>
+            </a:r>
+            <a:r>
+              <a:rPr lang="zh-CN" altLang="en-US" sz="800" b="1" dirty="0" smtClean="0">
+                <a:latin typeface="宋体" panose="02010600030101010101" pitchFamily="2" charset="-122"/>
+                <a:ea typeface="宋体" panose="02010600030101010101" pitchFamily="2" charset="-122"/>
+                <a:cs typeface="宋体" panose="02010600030101010101" pitchFamily="2" charset="-122"/>
+              </a:rPr>
+              <a:t>大幅降低养老院审批流程的维护成本。</a:t>
+            </a:r>
+            <a:endParaRPr lang="zh-CN" altLang="en-US" sz="800" dirty="0" smtClean="0">
+              <a:latin typeface="宋体" panose="02010600030101010101" pitchFamily="2" charset="-122"/>
+              <a:ea typeface="宋体" panose="02010600030101010101" pitchFamily="2" charset="-122"/>
+              <a:cs typeface="宋体" panose="02010600030101010101" pitchFamily="2" charset="-122"/>
+            </a:endParaRPr>
+          </a:p>
+          <a:p>
+            <a:pPr algn="l"/>
+            <a:endParaRPr lang="en-US" altLang="zh-CN" sz="800" dirty="0" smtClean="0">
+              <a:latin typeface="宋体" panose="02010600030101010101" pitchFamily="2" charset="-122"/>
+              <a:ea typeface="宋体" panose="02010600030101010101" pitchFamily="2" charset="-122"/>
+              <a:cs typeface="宋体" panose="02010600030101010101" pitchFamily="2" charset="-122"/>
+            </a:endParaRPr>
+          </a:p>
+          <a:p>
+            <a:pPr algn="l"/>
+            <a:r>
+              <a:rPr lang="zh-CN" altLang="en-US" sz="800" dirty="0" smtClean="0">
+                <a:latin typeface="宋体" panose="02010600030101010101" pitchFamily="2" charset="-122"/>
+                <a:ea typeface="宋体" panose="02010600030101010101" pitchFamily="2" charset="-122"/>
+                <a:cs typeface="宋体" panose="02010600030101010101" pitchFamily="2" charset="-122"/>
+              </a:rPr>
+              <a:t>基于</a:t>
+            </a:r>
+            <a:r>
+              <a:rPr lang="en-US" altLang="zh-CN" sz="800" dirty="0" smtClean="0">
+                <a:latin typeface="宋体" panose="02010600030101010101" pitchFamily="2" charset="-122"/>
+                <a:ea typeface="宋体" panose="02010600030101010101" pitchFamily="2" charset="-122"/>
+                <a:cs typeface="宋体" panose="02010600030101010101" pitchFamily="2" charset="-122"/>
+              </a:rPr>
+              <a:t> RBAC </a:t>
+            </a:r>
+            <a:r>
+              <a:rPr lang="zh-CN" altLang="en-US" sz="800" dirty="0" smtClean="0">
+                <a:latin typeface="宋体" panose="02010600030101010101" pitchFamily="2" charset="-122"/>
+                <a:ea typeface="宋体" panose="02010600030101010101" pitchFamily="2" charset="-122"/>
+                <a:cs typeface="宋体" panose="02010600030101010101" pitchFamily="2" charset="-122"/>
+              </a:rPr>
+              <a:t>模型搭建养老院多角色权限体系，实现接口级权限拦截与通配符路径匹配，通过缓存</a:t>
+            </a:r>
+            <a:r>
+              <a:rPr lang="en-US" altLang="zh-CN" sz="800" dirty="0" smtClean="0">
+                <a:latin typeface="宋体" panose="02010600030101010101" pitchFamily="2" charset="-122"/>
+                <a:ea typeface="宋体" panose="02010600030101010101" pitchFamily="2" charset="-122"/>
+                <a:cs typeface="宋体" panose="02010600030101010101" pitchFamily="2" charset="-122"/>
+              </a:rPr>
+              <a:t> + </a:t>
+            </a:r>
+            <a:r>
+              <a:rPr lang="zh-CN" altLang="en-US" sz="800" dirty="0" smtClean="0">
+                <a:latin typeface="宋体" panose="02010600030101010101" pitchFamily="2" charset="-122"/>
+                <a:ea typeface="宋体" panose="02010600030101010101" pitchFamily="2" charset="-122"/>
+                <a:cs typeface="宋体" panose="02010600030101010101" pitchFamily="2" charset="-122"/>
+              </a:rPr>
+              <a:t>事件监听实现权限热更新并留存操作审计日志，权限配置与代码解耦，</a:t>
+            </a:r>
+            <a:r>
+              <a:rPr lang="zh-CN" altLang="en-US" sz="800" b="1" dirty="0" smtClean="0">
+                <a:latin typeface="宋体" panose="02010600030101010101" pitchFamily="2" charset="-122"/>
+                <a:ea typeface="宋体" panose="02010600030101010101" pitchFamily="2" charset="-122"/>
+                <a:cs typeface="宋体" panose="02010600030101010101" pitchFamily="2" charset="-122"/>
+              </a:rPr>
+              <a:t>新增权限无需重启服务。</a:t>
+            </a:r>
+            <a:endParaRPr lang="zh-CN" altLang="en-US" sz="800" dirty="0" smtClean="0">
+              <a:latin typeface="宋体" panose="02010600030101010101" pitchFamily="2" charset="-122"/>
+              <a:ea typeface="宋体" panose="02010600030101010101" pitchFamily="2" charset="-122"/>
+              <a:cs typeface="宋体" panose="02010600030101010101" pitchFamily="2" charset="-122"/>
+            </a:endParaRPr>
+          </a:p>
+          <a:p>
+            <a:pPr algn="l"/>
+            <a:r>
+              <a:rPr lang="en-US" altLang="zh-CN" sz="800" b="1" dirty="0" smtClean="0">
                 <a:latin typeface="阿里巴巴普惠体 R" panose="00020600040101010101" pitchFamily="18" charset="-122"/>
                 <a:ea typeface="阿里巴巴普惠体 R" panose="00020600040101010101" pitchFamily="18" charset="-122"/>
                 <a:cs typeface="阿里巴巴普惠体 R" panose="00020600040101010101" pitchFamily="18" charset="-122"/>
               </a:rPr>
-              <a:t>主要职责：</a:t>
-            </a:r>
-            <a:endParaRPr lang="zh-CN" altLang="en-US" sz="800" b="1" dirty="0" smtClean="0">
+              <a:t> </a:t>
+            </a:r>
+            <a:endParaRPr lang="en-US" altLang="zh-CN" sz="800" b="1" dirty="0" smtClean="0">
               <a:latin typeface="阿里巴巴普惠体 R" panose="00020600040101010101" pitchFamily="18" charset="-122"/>
               <a:ea typeface="阿里巴巴普惠体 R" panose="00020600040101010101" pitchFamily="18" charset="-122"/>
               <a:cs typeface="阿里巴巴普惠体 R" panose="00020600040101010101" pitchFamily="18" charset="-122"/>
+            </a:endParaRPr>
+          </a:p>
+          <a:p>
+            <a:pPr algn="l">
+              <a:buClrTx/>
+              <a:buSzTx/>
+              <a:buFontTx/>
+            </a:pPr>
+            <a:endParaRPr lang="en-US" altLang="zh-CN" sz="900" dirty="0" smtClean="0">
+              <a:latin typeface="宋体" panose="02010600030101010101" pitchFamily="2" charset="-122"/>
+              <a:ea typeface="宋体" panose="02010600030101010101" pitchFamily="2" charset="-122"/>
+              <a:cs typeface="宋体" panose="02010600030101010101" pitchFamily="2" charset="-122"/>
+            </a:endParaRPr>
+          </a:p>
+          <a:p>
+            <a:pPr marL="0" lvl="1" algn="l">
+              <a:buClrTx/>
+              <a:buSzTx/>
+              <a:buFontTx/>
+            </a:pPr>
+            <a:endParaRPr lang="en-US" altLang="zh-CN" sz="900" dirty="0" smtClean="0">
+              <a:latin typeface="宋体" panose="02010600030101010101" pitchFamily="2" charset="-122"/>
+              <a:ea typeface="宋体" panose="02010600030101010101" pitchFamily="2" charset="-122"/>
+              <a:cs typeface="宋体" panose="02010600030101010101" pitchFamily="2" charset="-122"/>
             </a:endParaRPr>
           </a:p>
           <a:p>
@@ -6250,6 +6262,138 @@
           </a:p>
         </p:txBody>
       </p:sp>
+      <p:sp>
+        <p:nvSpPr>
+          <p:cNvPr id="2" name="文本框 1"/>
+          <p:cNvSpPr txBox="1"/>
+          <p:nvPr/>
+        </p:nvSpPr>
+        <p:spPr>
+          <a:xfrm>
+            <a:off x="116840" y="4509770"/>
+            <a:ext cx="6350635" cy="1637030"/>
+          </a:xfrm>
+          <a:prstGeom prst="rect">
+            <a:avLst/>
+          </a:prstGeom>
+          <a:noFill/>
+        </p:spPr>
+        <p:txBody>
+          <a:bodyPr wrap="square" rtlCol="0">
+            <a:noAutofit/>
+          </a:bodyPr>
+          <a:p>
+            <a:pPr algn="l"/>
+            <a:r>
+              <a:rPr lang="zh-CN" altLang="en-US" sz="800" b="1" dirty="0">
+                <a:latin typeface="阿里巴巴普惠体 R" panose="00020600040101010101" pitchFamily="18" charset="-122"/>
+                <a:ea typeface="阿里巴巴普惠体 R" panose="00020600040101010101" pitchFamily="18" charset="-122"/>
+                <a:cs typeface="阿里巴巴普惠体 R" panose="00020600040101010101" pitchFamily="18" charset="-122"/>
+                <a:sym typeface="+mn-ea"/>
+              </a:rPr>
+              <a:t>福建新大陆软件工程有限公司</a:t>
+            </a:r>
+            <a:r>
+              <a:rPr lang="en-US" altLang="zh-CN" sz="800" b="1" dirty="0">
+                <a:latin typeface="阿里巴巴普惠体 R" panose="00020600040101010101" pitchFamily="18" charset="-122"/>
+                <a:ea typeface="阿里巴巴普惠体 R" panose="00020600040101010101" pitchFamily="18" charset="-122"/>
+                <a:cs typeface="阿里巴巴普惠体 R" panose="00020600040101010101" pitchFamily="18" charset="-122"/>
+                <a:sym typeface="+mn-ea"/>
+              </a:rPr>
+              <a:t>			  2025/9 - 2025/12  			         </a:t>
+            </a:r>
+            <a:r>
+              <a:rPr lang="zh-CN" altLang="en-US" sz="800" b="1" dirty="0">
+                <a:latin typeface="阿里巴巴普惠体 R" panose="00020600040101010101" pitchFamily="18" charset="-122"/>
+                <a:ea typeface="阿里巴巴普惠体 R" panose="00020600040101010101" pitchFamily="18" charset="-122"/>
+                <a:cs typeface="阿里巴巴普惠体 R" panose="00020600040101010101" pitchFamily="18" charset="-122"/>
+                <a:sym typeface="+mn-ea"/>
+              </a:rPr>
+              <a:t>软件初级开发工程师</a:t>
+            </a:r>
+            <a:endParaRPr lang="zh-CN" altLang="en-US" sz="800" b="1" dirty="0">
+              <a:latin typeface="阿里巴巴普惠体 R" panose="00020600040101010101" pitchFamily="18" charset="-122"/>
+              <a:ea typeface="阿里巴巴普惠体 R" panose="00020600040101010101" pitchFamily="18" charset="-122"/>
+              <a:cs typeface="阿里巴巴普惠体 R" panose="00020600040101010101" pitchFamily="18" charset="-122"/>
+              <a:sym typeface="+mn-ea"/>
+            </a:endParaRPr>
+          </a:p>
+          <a:p>
+            <a:pPr algn="l"/>
+            <a:r>
+              <a:rPr lang="en-US" altLang="zh-CN" sz="800" b="1" dirty="0">
+                <a:latin typeface="阿里巴巴普惠体 R" panose="00020600040101010101" pitchFamily="18" charset="-122"/>
+                <a:ea typeface="阿里巴巴普惠体 R" panose="00020600040101010101" pitchFamily="18" charset="-122"/>
+                <a:cs typeface="阿里巴巴普惠体 R" panose="00020600040101010101" pitchFamily="18" charset="-122"/>
+                <a:sym typeface="+mn-ea"/>
+              </a:rPr>
+              <a:t>	</a:t>
+            </a:r>
+            <a:r>
+              <a:rPr lang="en-US" altLang="zh-CN" sz="800" dirty="0">
+                <a:latin typeface="阿里巴巴普惠体 R" panose="00020600040101010101" pitchFamily="18" charset="-122"/>
+                <a:ea typeface="阿里巴巴普惠体 R" panose="00020600040101010101" pitchFamily="18" charset="-122"/>
+                <a:cs typeface="阿里巴巴普惠体 R" panose="00020600040101010101" pitchFamily="18" charset="-122"/>
+                <a:sym typeface="+mn-ea"/>
+              </a:rPr>
+              <a:t>		</a:t>
+            </a:r>
+            <a:r>
+              <a:rPr lang="en-US" altLang="zh-CN" sz="800" b="1" dirty="0">
+                <a:latin typeface="阿里巴巴普惠体 R" panose="00020600040101010101" pitchFamily="18" charset="-122"/>
+                <a:ea typeface="阿里巴巴普惠体 R" panose="00020600040101010101" pitchFamily="18" charset="-122"/>
+                <a:cs typeface="阿里巴巴普惠体 R" panose="00020600040101010101" pitchFamily="18" charset="-122"/>
+                <a:sym typeface="+mn-ea"/>
+              </a:rPr>
+              <a:t>  </a:t>
+            </a:r>
+            <a:r>
+              <a:rPr lang="zh-CN" altLang="en-US" sz="800" dirty="0">
+                <a:latin typeface="阿里巴巴普惠体 R" panose="00020600040101010101" pitchFamily="18" charset="-122"/>
+                <a:ea typeface="阿里巴巴普惠体 R" panose="00020600040101010101" pitchFamily="18" charset="-122"/>
+                <a:cs typeface="阿里巴巴普惠体 R" panose="00020600040101010101" pitchFamily="18" charset="-122"/>
+                <a:sym typeface="+mn-ea"/>
+              </a:rPr>
+              <a:t>				    </a:t>
+            </a:r>
+            <a:endParaRPr lang="en-US" altLang="zh-CN" sz="900" dirty="0" smtClean="0">
+              <a:latin typeface="宋体" panose="02010600030101010101" pitchFamily="2" charset="-122"/>
+              <a:ea typeface="宋体" panose="02010600030101010101" pitchFamily="2" charset="-122"/>
+              <a:cs typeface="宋体" panose="02010600030101010101" pitchFamily="2" charset="-122"/>
+            </a:endParaRPr>
+          </a:p>
+        </p:txBody>
+      </p:sp>
+      <p:cxnSp>
+        <p:nvCxnSpPr>
+          <p:cNvPr id="10" name="直接连接符 9"/>
+          <p:cNvCxnSpPr/>
+          <p:nvPr/>
+        </p:nvCxnSpPr>
+        <p:spPr>
+          <a:xfrm>
+            <a:off x="188595" y="4448810"/>
+            <a:ext cx="6336665" cy="0"/>
+          </a:xfrm>
+          <a:prstGeom prst="line">
+            <a:avLst/>
+          </a:prstGeom>
+        </p:spPr>
+        <p:style>
+          <a:lnRef idx="2">
+            <a:schemeClr val="accent1"/>
+          </a:lnRef>
+          <a:fillRef idx="0">
+            <a:srgbClr val="FFFFFF"/>
+          </a:fillRef>
+          <a:effectRef idx="0">
+            <a:srgbClr val="FFFFFF"/>
+          </a:effectRef>
+          <a:fontRef idx="minor">
+            <a:schemeClr val="tx1"/>
+          </a:fontRef>
+        </p:style>
+      </p:cxnSp>
     </p:spTree>
   </p:cSld>
   <p:clrMapOvr>
@@ -6276,7 +6420,7 @@
         </p:nvSpPr>
         <p:spPr>
           <a:xfrm>
-            <a:off x="149225" y="734060"/>
+            <a:off x="60960" y="2533650"/>
             <a:ext cx="6807200" cy="1386840"/>
           </a:xfrm>
           <a:prstGeom prst="rect">
@@ -7285,7 +7429,7 @@
         </p:nvGrpSpPr>
         <p:grpSpPr>
           <a:xfrm>
-            <a:off x="116840" y="416560"/>
+            <a:off x="28575" y="2216150"/>
             <a:ext cx="6407785" cy="275590"/>
             <a:chOff x="172266" y="5624643"/>
             <a:chExt cx="6425086" cy="273929"/>
@@ -7445,7 +7589,7 @@
         </p:nvGrpSpPr>
         <p:grpSpPr>
           <a:xfrm>
-            <a:off x="180975" y="3332479"/>
+            <a:off x="92710" y="5132069"/>
             <a:ext cx="6375400" cy="259716"/>
             <a:chOff x="204738" y="5630954"/>
             <a:chExt cx="6392614" cy="258150"/>
@@ -7602,8 +7746,8 @@
         </p:nvSpPr>
         <p:spPr>
           <a:xfrm>
-            <a:off x="180975" y="3656965"/>
-            <a:ext cx="5080000" cy="675640"/>
+            <a:off x="92710" y="5456555"/>
+            <a:ext cx="5080000" cy="814705"/>
           </a:xfrm>
           <a:prstGeom prst="rect">
             <a:avLst/>
@@ -7616,6 +7760,140 @@
           <a:p>
             <a:pPr algn="l">
               <a:lnSpc>
+                <a:spcPts val="1880"/>
+              </a:lnSpc>
+              <a:buClrTx/>
+              <a:buSzTx/>
+              <a:buFontTx/>
+              <a:buNone/>
+            </a:pPr>
+            <a:r>
+              <a:rPr lang="zh-CN" altLang="en-US" sz="800" b="1" dirty="0">
+                <a:solidFill>
+                  <a:schemeClr val="tx1"/>
+                </a:solidFill>
+                <a:latin typeface="宋体" panose="02010600030101010101" pitchFamily="2" charset="-122"/>
+                <a:ea typeface="宋体" panose="02010600030101010101" pitchFamily="2" charset="-122"/>
+                <a:cs typeface="宋体" panose="02010600030101010101" pitchFamily="2" charset="-122"/>
+              </a:rPr>
+              <a:t>性格乐观，善于沟通，</a:t>
+            </a:r>
+            <a:r>
+              <a:rPr lang="zh-CN" altLang="en-US" sz="800" dirty="0">
+                <a:latin typeface="宋体" panose="02010600030101010101" pitchFamily="2" charset="-122"/>
+                <a:ea typeface="宋体" panose="02010600030101010101" pitchFamily="2" charset="-122"/>
+                <a:cs typeface="宋体" panose="02010600030101010101" pitchFamily="2" charset="-122"/>
+              </a:rPr>
+              <a:t>英文读写能力良好。对技术保持高度热情，学习能力强，善于快速掌握新知识并应用于实践。</a:t>
+            </a:r>
+            <a:r>
+              <a:rPr lang="zh-CN" altLang="en-US" sz="800" b="1" dirty="0">
+                <a:latin typeface="宋体" panose="02010600030101010101" pitchFamily="2" charset="-122"/>
+                <a:ea typeface="宋体" panose="02010600030101010101" pitchFamily="2" charset="-122"/>
+                <a:cs typeface="宋体" panose="02010600030101010101" pitchFamily="2" charset="-122"/>
+              </a:rPr>
+              <a:t>热衷探索开源项目与利用 AI 提升开发、办公效率，</a:t>
+            </a:r>
+            <a:r>
+              <a:rPr lang="zh-CN" altLang="en-US" sz="800" dirty="0">
+                <a:latin typeface="宋体" panose="02010600030101010101" pitchFamily="2" charset="-122"/>
+                <a:ea typeface="宋体" panose="02010600030101010101" pitchFamily="2" charset="-122"/>
+                <a:cs typeface="宋体" panose="02010600030101010101" pitchFamily="2" charset="-122"/>
+              </a:rPr>
+              <a:t>积极参与开源社区交流分享。业余爱好包括运动、骑行、社交、听音乐与羽毛球，注重身心平衡与持续成长。乐于分享技术经验并与团队共同成长.</a:t>
+            </a:r>
+            <a:endParaRPr lang="zh-CN" altLang="en-US" sz="800" dirty="0">
+              <a:latin typeface="宋体" panose="02010600030101010101" pitchFamily="2" charset="-122"/>
+              <a:ea typeface="宋体" panose="02010600030101010101" pitchFamily="2" charset="-122"/>
+              <a:cs typeface="宋体" panose="02010600030101010101" pitchFamily="2" charset="-122"/>
+            </a:endParaRPr>
+          </a:p>
+        </p:txBody>
+      </p:sp>
+      <p:sp>
+        <p:nvSpPr>
+          <p:cNvPr id="3" name="文本框 2"/>
+          <p:cNvSpPr txBox="1"/>
+          <p:nvPr/>
+        </p:nvSpPr>
+        <p:spPr>
+          <a:xfrm>
+            <a:off x="60960" y="128270"/>
+            <a:ext cx="6591300" cy="2040255"/>
+          </a:xfrm>
+          <a:prstGeom prst="rect">
+            <a:avLst/>
+          </a:prstGeom>
+          <a:noFill/>
+        </p:spPr>
+        <p:txBody>
+          <a:bodyPr wrap="square" rtlCol="0">
+            <a:spAutoFit/>
+          </a:bodyPr>
+          <a:lstStyle/>
+          <a:p>
+            <a:pPr algn="l">
+              <a:lnSpc>
+                <a:spcPts val="1520"/>
+              </a:lnSpc>
+            </a:pPr>
+            <a:r>
+              <a:rPr lang="en-US" altLang="zh-CN" sz="800" dirty="0">
+                <a:latin typeface="阿里巴巴普惠体 R" panose="00020600040101010101" pitchFamily="18" charset="-122"/>
+                <a:ea typeface="阿里巴巴普惠体 R" panose="00020600040101010101" pitchFamily="18" charset="-122"/>
+                <a:cs typeface="阿里巴巴普惠体 R" panose="00020600040101010101" pitchFamily="18" charset="-122"/>
+              </a:rPr>
+              <a:t>2024/9 – 2025/1</a:t>
+            </a:r>
+            <a:endParaRPr lang="en-US" altLang="zh-CN" sz="800" dirty="0">
+              <a:latin typeface="阿里巴巴普惠体 R" panose="00020600040101010101" pitchFamily="18" charset="-122"/>
+              <a:ea typeface="阿里巴巴普惠体 R" panose="00020600040101010101" pitchFamily="18" charset="-122"/>
+              <a:cs typeface="阿里巴巴普惠体 R" panose="00020600040101010101" pitchFamily="18" charset="-122"/>
+            </a:endParaRPr>
+          </a:p>
+          <a:p>
+            <a:pPr>
+              <a:lnSpc>
+                <a:spcPts val="1520"/>
+              </a:lnSpc>
+            </a:pPr>
+            <a:r>
+              <a:rPr lang="en-US" altLang="zh-CN" sz="800" b="1" dirty="0" err="1">
+                <a:ea typeface="阿里巴巴普惠体 M" panose="00020600040101010101"/>
+              </a:rPr>
+              <a:t>ArcLearn</a:t>
+            </a:r>
+            <a:r>
+              <a:rPr lang="en-US" altLang="zh-CN" sz="800" b="1" dirty="0">
+                <a:ea typeface="阿里巴巴普惠体 M" panose="00020600040101010101"/>
+              </a:rPr>
+              <a:t> </a:t>
+            </a:r>
+            <a:r>
+              <a:rPr lang="zh-CN" altLang="en-US" sz="800" b="1" dirty="0">
+                <a:ea typeface="阿里巴巴普惠体 M" panose="00020600040101010101"/>
+              </a:rPr>
+              <a:t>社区</a:t>
+            </a:r>
+            <a:r>
+              <a:rPr lang="en-US" altLang="zh-CN" sz="800" b="1" dirty="0">
+                <a:ea typeface="阿里巴巴普惠体 M" panose="00020600040101010101"/>
+              </a:rPr>
+              <a:t>—</a:t>
+            </a:r>
+            <a:r>
+              <a:rPr lang="zh-CN" altLang="en-US" sz="800" b="1" dirty="0">
+                <a:ea typeface="阿里巴巴普惠体 M" panose="00020600040101010101"/>
+              </a:rPr>
+              <a:t>后端开发</a:t>
+            </a:r>
+            <a:endParaRPr lang="en-US" altLang="zh-CN" sz="800" b="1" dirty="0">
+              <a:ea typeface="阿里巴巴普惠体 M" panose="00020600040101010101"/>
+            </a:endParaRPr>
+          </a:p>
+          <a:p>
+            <a:pPr algn="l">
+              <a:lnSpc>
                 <a:spcPts val="1520"/>
               </a:lnSpc>
               <a:buClrTx/>
@@ -7623,127 +7901,331 @@
               <a:buNone/>
             </a:pPr>
             <a:r>
+              <a:rPr lang="zh-CN" altLang="en-US" sz="800" b="1" dirty="0">
+                <a:latin typeface="宋体" panose="02010600030101010101" pitchFamily="2" charset="-122"/>
+                <a:ea typeface="宋体" panose="02010600030101010101" pitchFamily="2" charset="-122"/>
+                <a:cs typeface="宋体" panose="02010600030101010101" pitchFamily="2" charset="-122"/>
+              </a:rPr>
+              <a:t>项目描述:</a:t>
+            </a:r>
+            <a:r>
+              <a:rPr lang="zh-CN" altLang="en-US" sz="800" dirty="0">
+                <a:latin typeface="宋体" panose="02010600030101010101" pitchFamily="2" charset="-122"/>
+                <a:ea typeface="宋体" panose="02010600030101010101" pitchFamily="2" charset="-122"/>
+                <a:cs typeface="宋体" panose="02010600030101010101" pitchFamily="2" charset="-122"/>
+              </a:rPr>
+              <a:t> 一款面向开发者的技术交流平台，支持Markdown 富文本文章的发布、评论互动、用户签到、行为统计等功能，</a:t>
+            </a:r>
+            <a:endParaRPr lang="zh-CN" altLang="en-US" sz="800" dirty="0">
+              <a:latin typeface="宋体" panose="02010600030101010101" pitchFamily="2" charset="-122"/>
+              <a:ea typeface="宋体" panose="02010600030101010101" pitchFamily="2" charset="-122"/>
+              <a:cs typeface="宋体" panose="02010600030101010101" pitchFamily="2" charset="-122"/>
+            </a:endParaRPr>
+          </a:p>
+          <a:p>
+            <a:pPr algn="l">
+              <a:lnSpc>
+                <a:spcPts val="1520"/>
+              </a:lnSpc>
+              <a:buClrTx/>
+              <a:buSzTx/>
+              <a:buNone/>
+            </a:pPr>
+            <a:r>
+              <a:rPr lang="zh-CN" altLang="en-US" sz="800" b="1" dirty="0">
+                <a:latin typeface="宋体" panose="02010600030101010101" pitchFamily="2" charset="-122"/>
+                <a:ea typeface="宋体" panose="02010600030101010101" pitchFamily="2" charset="-122"/>
+                <a:cs typeface="宋体" panose="02010600030101010101" pitchFamily="2" charset="-122"/>
+              </a:rPr>
+              <a:t>核心技术:</a:t>
+            </a:r>
+            <a:r>
+              <a:rPr lang="zh-CN" altLang="en-US" sz="800" dirty="0">
+                <a:latin typeface="宋体" panose="02010600030101010101" pitchFamily="2" charset="-122"/>
+                <a:ea typeface="宋体" panose="02010600030101010101" pitchFamily="2" charset="-122"/>
+                <a:cs typeface="宋体" panose="02010600030101010101" pitchFamily="2" charset="-122"/>
+              </a:rPr>
+              <a:t> SpringBoot , MyBatis , Redis, RabbitMQ, JWT, Nginx,阿里云Oss, Vue3,ElementUl Plus</a:t>
+            </a:r>
+            <a:endParaRPr lang="zh-CN" altLang="en-US" sz="800" dirty="0">
+              <a:latin typeface="宋体" panose="02010600030101010101" pitchFamily="2" charset="-122"/>
+              <a:ea typeface="宋体" panose="02010600030101010101" pitchFamily="2" charset="-122"/>
+              <a:cs typeface="宋体" panose="02010600030101010101" pitchFamily="2" charset="-122"/>
+            </a:endParaRPr>
+          </a:p>
+          <a:p>
+            <a:pPr algn="l">
+              <a:lnSpc>
+                <a:spcPts val="1520"/>
+              </a:lnSpc>
+              <a:buClrTx/>
+              <a:buSzTx/>
+              <a:buNone/>
+            </a:pPr>
+            <a:r>
+              <a:rPr lang="zh-CN" altLang="en-US" sz="800" b="1" dirty="0">
+                <a:latin typeface="宋体" panose="02010600030101010101" pitchFamily="2" charset="-122"/>
+                <a:ea typeface="宋体" panose="02010600030101010101" pitchFamily="2" charset="-122"/>
+                <a:cs typeface="宋体" panose="02010600030101010101" pitchFamily="2" charset="-122"/>
+              </a:rPr>
+              <a:t>核心职责:</a:t>
+            </a:r>
+            <a:endParaRPr lang="zh-CN" altLang="en-US" sz="800" b="1" dirty="0">
+              <a:latin typeface="宋体" panose="02010600030101010101" pitchFamily="2" charset="-122"/>
+              <a:ea typeface="宋体" panose="02010600030101010101" pitchFamily="2" charset="-122"/>
+              <a:cs typeface="宋体" panose="02010600030101010101" pitchFamily="2" charset="-122"/>
+            </a:endParaRPr>
+          </a:p>
+          <a:p>
+            <a:pPr lvl="1" algn="l">
+              <a:lnSpc>
+                <a:spcPts val="1520"/>
+              </a:lnSpc>
+              <a:buClrTx/>
+              <a:buSzTx/>
+              <a:buNone/>
+            </a:pPr>
+            <a:r>
+              <a:rPr lang="zh-CN" altLang="en-US" sz="800" dirty="0">
+                <a:latin typeface="宋体" panose="02010600030101010101" pitchFamily="2" charset="-122"/>
+                <a:ea typeface="宋体" panose="02010600030101010101" pitchFamily="2" charset="-122"/>
+                <a:cs typeface="宋体" panose="02010600030101010101" pitchFamily="2" charset="-122"/>
+              </a:rPr>
+              <a:t> </a:t>
+            </a:r>
+            <a:r>
+              <a:rPr lang="zh-CN" altLang="en-US" sz="800" b="1" dirty="0">
+                <a:latin typeface="宋体" panose="02010600030101010101" pitchFamily="2" charset="-122"/>
+                <a:ea typeface="宋体" panose="02010600030101010101" pitchFamily="2" charset="-122"/>
+                <a:cs typeface="宋体" panose="02010600030101010101" pitchFamily="2" charset="-122"/>
+              </a:rPr>
+              <a:t>异步解耦：</a:t>
+            </a:r>
+            <a:r>
+              <a:rPr lang="zh-CN" altLang="en-US" sz="800" dirty="0">
+                <a:latin typeface="宋体" panose="02010600030101010101" pitchFamily="2" charset="-122"/>
+                <a:ea typeface="宋体" panose="02010600030101010101" pitchFamily="2" charset="-122"/>
+                <a:cs typeface="宋体" panose="02010600030101010101" pitchFamily="2" charset="-122"/>
+              </a:rPr>
+              <a:t>构建基于</a:t>
+            </a:r>
+            <a:r>
+              <a:rPr lang="zh-CN" altLang="en-US" sz="800" b="1" dirty="0">
+                <a:latin typeface="宋体" panose="02010600030101010101" pitchFamily="2" charset="-122"/>
+                <a:ea typeface="宋体" panose="02010600030101010101" pitchFamily="2" charset="-122"/>
+                <a:cs typeface="宋体" panose="02010600030101010101" pitchFamily="2" charset="-122"/>
+              </a:rPr>
+              <a:t> RabbitMQ 的事件驱动架构</a:t>
+            </a:r>
+            <a:r>
+              <a:rPr lang="zh-CN" altLang="en-US" sz="800" dirty="0">
+                <a:latin typeface="宋体" panose="02010600030101010101" pitchFamily="2" charset="-122"/>
+                <a:ea typeface="宋体" panose="02010600030101010101" pitchFamily="2" charset="-122"/>
+                <a:cs typeface="宋体" panose="02010600030101010101" pitchFamily="2" charset="-122"/>
+              </a:rPr>
+              <a:t>，将文章发布、评论提醒、系统通知等任务异步化，提高系统响应速度与可扩展性。</a:t>
+            </a:r>
+            <a:endParaRPr lang="zh-CN" altLang="en-US" sz="800" dirty="0">
+              <a:latin typeface="宋体" panose="02010600030101010101" pitchFamily="2" charset="-122"/>
+              <a:ea typeface="宋体" panose="02010600030101010101" pitchFamily="2" charset="-122"/>
+              <a:cs typeface="宋体" panose="02010600030101010101" pitchFamily="2" charset="-122"/>
+            </a:endParaRPr>
+          </a:p>
+          <a:p>
+            <a:pPr lvl="1" algn="l">
+              <a:lnSpc>
+                <a:spcPts val="1520"/>
+              </a:lnSpc>
+              <a:buClrTx/>
+              <a:buSzTx/>
+              <a:buNone/>
+            </a:pPr>
+            <a:r>
+              <a:rPr lang="zh-CN" altLang="en-US" sz="800" dirty="0">
+                <a:latin typeface="宋体" panose="02010600030101010101" pitchFamily="2" charset="-122"/>
+                <a:ea typeface="宋体" panose="02010600030101010101" pitchFamily="2" charset="-122"/>
+                <a:cs typeface="宋体" panose="02010600030101010101" pitchFamily="2" charset="-122"/>
+              </a:rPr>
+              <a:t> </a:t>
+            </a:r>
+            <a:r>
+              <a:rPr lang="zh-CN" altLang="en-US" sz="800" b="1" dirty="0">
+                <a:latin typeface="宋体" panose="02010600030101010101" pitchFamily="2" charset="-122"/>
+                <a:ea typeface="宋体" panose="02010600030101010101" pitchFamily="2" charset="-122"/>
+                <a:cs typeface="宋体" panose="02010600030101010101" pitchFamily="2" charset="-122"/>
+              </a:rPr>
+              <a:t>缓存优化：</a:t>
+            </a:r>
+            <a:r>
+              <a:rPr lang="zh-CN" altLang="en-US" sz="800" dirty="0">
+                <a:latin typeface="宋体" panose="02010600030101010101" pitchFamily="2" charset="-122"/>
+                <a:ea typeface="宋体" panose="02010600030101010101" pitchFamily="2" charset="-122"/>
+                <a:cs typeface="宋体" panose="02010600030101010101" pitchFamily="2" charset="-122"/>
+              </a:rPr>
+              <a:t>使用 Redis 缓存热点数据，结合布隆过滤器与互斥锁，有效防止缓存击穿/穿透问题</a:t>
+            </a:r>
+            <a:endParaRPr lang="zh-CN" altLang="en-US" sz="800" dirty="0">
+              <a:latin typeface="宋体" panose="02010600030101010101" pitchFamily="2" charset="-122"/>
+              <a:ea typeface="宋体" panose="02010600030101010101" pitchFamily="2" charset="-122"/>
+              <a:cs typeface="宋体" panose="02010600030101010101" pitchFamily="2" charset="-122"/>
+            </a:endParaRPr>
+          </a:p>
+          <a:p>
+            <a:pPr lvl="1" algn="l">
+              <a:lnSpc>
+                <a:spcPts val="1520"/>
+              </a:lnSpc>
+              <a:buClrTx/>
+              <a:buSzTx/>
+              <a:buNone/>
+            </a:pPr>
+            <a:r>
+              <a:rPr lang="zh-CN" altLang="en-US" sz="800" dirty="0">
+                <a:latin typeface="宋体" panose="02010600030101010101" pitchFamily="2" charset="-122"/>
+                <a:ea typeface="宋体" panose="02010600030101010101" pitchFamily="2" charset="-122"/>
+                <a:cs typeface="宋体" panose="02010600030101010101" pitchFamily="2" charset="-122"/>
+              </a:rPr>
+              <a:t> </a:t>
+            </a:r>
+            <a:r>
+              <a:rPr lang="zh-CN" altLang="en-US" sz="800" b="1" dirty="0">
+                <a:latin typeface="宋体" panose="02010600030101010101" pitchFamily="2" charset="-122"/>
+                <a:ea typeface="宋体" panose="02010600030101010101" pitchFamily="2" charset="-122"/>
+                <a:cs typeface="宋体" panose="02010600030101010101" pitchFamily="2" charset="-122"/>
+              </a:rPr>
+              <a:t>架构设计：</a:t>
+            </a:r>
+            <a:r>
+              <a:rPr lang="zh-CN" altLang="en-US" sz="800" dirty="0">
+                <a:latin typeface="宋体" panose="02010600030101010101" pitchFamily="2" charset="-122"/>
+                <a:ea typeface="宋体" panose="02010600030101010101" pitchFamily="2" charset="-122"/>
+                <a:cs typeface="宋体" panose="02010600030101010101" pitchFamily="2" charset="-122"/>
+              </a:rPr>
+              <a:t>基于SpringBoot+MyBatis实现高效数据持久化，利用AOP 切面编程统一日志采集</a:t>
+            </a:r>
+            <a:endParaRPr lang="zh-CN" altLang="en-US" sz="800" dirty="0">
+              <a:latin typeface="宋体" panose="02010600030101010101" pitchFamily="2" charset="-122"/>
+              <a:ea typeface="宋体" panose="02010600030101010101" pitchFamily="2" charset="-122"/>
+              <a:cs typeface="宋体" panose="02010600030101010101" pitchFamily="2" charset="-122"/>
+            </a:endParaRPr>
+          </a:p>
+          <a:p>
+            <a:pPr lvl="1" algn="l">
+              <a:lnSpc>
+                <a:spcPts val="1520"/>
+              </a:lnSpc>
+              <a:buClrTx/>
+              <a:buSzTx/>
+              <a:buNone/>
+            </a:pPr>
+            <a:r>
+              <a:rPr lang="zh-CN" altLang="en-US" sz="800" dirty="0">
+                <a:latin typeface="宋体" panose="02010600030101010101" pitchFamily="2" charset="-122"/>
+                <a:ea typeface="宋体" panose="02010600030101010101" pitchFamily="2" charset="-122"/>
+                <a:cs typeface="宋体" panose="02010600030101010101" pitchFamily="2" charset="-122"/>
+              </a:rPr>
+              <a:t> </a:t>
+            </a:r>
+            <a:r>
+              <a:rPr lang="zh-CN" altLang="en-US" sz="800" b="1" dirty="0">
+                <a:latin typeface="宋体" panose="02010600030101010101" pitchFamily="2" charset="-122"/>
+                <a:ea typeface="宋体" panose="02010600030101010101" pitchFamily="2" charset="-122"/>
+                <a:cs typeface="宋体" panose="02010600030101010101" pitchFamily="2" charset="-122"/>
+              </a:rPr>
+              <a:t>安全认证:</a:t>
+            </a:r>
+            <a:r>
               <a:rPr lang="en-US" altLang="zh-CN" sz="800" b="1" dirty="0">
-                <a:solidFill>
-                  <a:schemeClr val="tx1"/>
-                </a:solidFill>
-                <a:effectLst>
-                  <a:outerShdw blurRad="38100" dist="19050" dir="2700000" algn="tl" rotWithShape="0">
-                    <a:schemeClr val="dk1">
-                      <a:alpha val="40000"/>
-                    </a:schemeClr>
-                  </a:outerShdw>
-                </a:effectLst>
-                <a:latin typeface="阿里巴巴普惠体 R" panose="00020600040101010101" pitchFamily="18" charset="-122"/>
-                <a:ea typeface="阿里巴巴普惠体 R" panose="00020600040101010101" pitchFamily="18" charset="-122"/>
-                <a:cs typeface="阿里巴巴普惠体 R" panose="00020600040101010101" pitchFamily="18" charset="-122"/>
-              </a:rPr>
-              <a:t>性格乐观，善于沟通，</a:t>
-            </a:r>
-            <a:r>
-              <a:rPr lang="en-US" altLang="zh-CN" sz="800" b="1" dirty="0">
-                <a:latin typeface="阿里巴巴普惠体 R" panose="00020600040101010101" pitchFamily="18" charset="-122"/>
-                <a:ea typeface="阿里巴巴普惠体 R" panose="00020600040101010101" pitchFamily="18" charset="-122"/>
-                <a:cs typeface="阿里巴巴普惠体 R" panose="00020600040101010101" pitchFamily="18" charset="-122"/>
-              </a:rPr>
-              <a:t>英文读写能力良好。</a:t>
-            </a:r>
-            <a:r>
-              <a:rPr lang="en-US" altLang="zh-CN" sz="800" dirty="0">
-                <a:latin typeface="阿里巴巴普惠体 R" panose="00020600040101010101" pitchFamily="18" charset="-122"/>
-                <a:ea typeface="阿里巴巴普惠体 R" panose="00020600040101010101" pitchFamily="18" charset="-122"/>
-                <a:cs typeface="阿里巴巴普惠体 R" panose="00020600040101010101" pitchFamily="18" charset="-122"/>
-              </a:rPr>
-              <a:t>对技术保持高度热情，</a:t>
-            </a:r>
-            <a:r>
-              <a:rPr lang="en-US" altLang="zh-CN" sz="800" b="1" dirty="0">
-                <a:latin typeface="阿里巴巴普惠体 R" panose="00020600040101010101" pitchFamily="18" charset="-122"/>
-                <a:ea typeface="阿里巴巴普惠体 R" panose="00020600040101010101" pitchFamily="18" charset="-122"/>
-                <a:cs typeface="阿里巴巴普惠体 R" panose="00020600040101010101" pitchFamily="18" charset="-122"/>
-              </a:rPr>
-              <a:t>学习能力强，善于快速掌握新知识并应用于实践。</a:t>
-            </a:r>
-            <a:r>
-              <a:rPr lang="en-US" altLang="zh-CN" sz="800" dirty="0">
-                <a:latin typeface="阿里巴巴普惠体 R" panose="00020600040101010101" pitchFamily="18" charset="-122"/>
-                <a:ea typeface="阿里巴巴普惠体 R" panose="00020600040101010101" pitchFamily="18" charset="-122"/>
-                <a:cs typeface="阿里巴巴普惠体 R" panose="00020600040101010101" pitchFamily="18" charset="-122"/>
-              </a:rPr>
-              <a:t>热衷探索开源项目与</a:t>
-            </a:r>
-            <a:r>
-              <a:rPr lang="en-US" altLang="zh-CN" sz="800" b="1" dirty="0">
-                <a:latin typeface="阿里巴巴普惠体 R" panose="00020600040101010101" pitchFamily="18" charset="-122"/>
-                <a:ea typeface="阿里巴巴普惠体 R" panose="00020600040101010101" pitchFamily="18" charset="-122"/>
-                <a:cs typeface="阿里巴巴普惠体 R" panose="00020600040101010101" pitchFamily="18" charset="-122"/>
-              </a:rPr>
-              <a:t>利用 AI 提升开发</a:t>
-            </a:r>
+                <a:latin typeface="宋体" panose="02010600030101010101" pitchFamily="2" charset="-122"/>
+                <a:ea typeface="宋体" panose="02010600030101010101" pitchFamily="2" charset="-122"/>
+                <a:cs typeface="宋体" panose="02010600030101010101" pitchFamily="2" charset="-122"/>
+              </a:rPr>
+              <a:t> </a:t>
+            </a:r>
+            <a:r>
+              <a:rPr lang="zh-CN" altLang="en-US" sz="800" dirty="0">
+                <a:latin typeface="宋体" panose="02010600030101010101" pitchFamily="2" charset="-122"/>
+                <a:ea typeface="宋体" panose="02010600030101010101" pitchFamily="2" charset="-122"/>
+                <a:cs typeface="宋体" panose="02010600030101010101" pitchFamily="2" charset="-122"/>
+              </a:rPr>
+              <a:t>JWT无状态令牌实现鉴权,优化用户体验并保障接口安全。</a:t>
+            </a:r>
+            <a:endParaRPr lang="zh-CN" altLang="en-US" sz="800" dirty="0">
+              <a:latin typeface="宋体" panose="02010600030101010101" pitchFamily="2" charset="-122"/>
+              <a:ea typeface="宋体" panose="02010600030101010101" pitchFamily="2" charset="-122"/>
+              <a:cs typeface="宋体" panose="02010600030101010101" pitchFamily="2" charset="-122"/>
+            </a:endParaRPr>
+          </a:p>
+          <a:p>
+            <a:pPr lvl="1" algn="l">
+              <a:lnSpc>
+                <a:spcPts val="1520"/>
+              </a:lnSpc>
+              <a:buClrTx/>
+              <a:buSzTx/>
+              <a:buNone/>
+            </a:pPr>
             <a:r>
               <a:rPr lang="zh-CN" altLang="en-US" sz="800" b="1" dirty="0">
-                <a:latin typeface="阿里巴巴普惠体 R" panose="00020600040101010101" pitchFamily="18" charset="-122"/>
-                <a:ea typeface="阿里巴巴普惠体 R" panose="00020600040101010101" pitchFamily="18" charset="-122"/>
-                <a:cs typeface="阿里巴巴普惠体 R" panose="00020600040101010101" pitchFamily="18" charset="-122"/>
-              </a:rPr>
-              <a:t>、办公</a:t>
-            </a:r>
-            <a:r>
-              <a:rPr lang="en-US" altLang="zh-CN" sz="800" b="1" dirty="0">
-                <a:latin typeface="阿里巴巴普惠体 R" panose="00020600040101010101" pitchFamily="18" charset="-122"/>
-                <a:ea typeface="阿里巴巴普惠体 R" panose="00020600040101010101" pitchFamily="18" charset="-122"/>
-                <a:cs typeface="阿里巴巴普惠体 R" panose="00020600040101010101" pitchFamily="18" charset="-122"/>
-              </a:rPr>
-              <a:t>效率</a:t>
-            </a:r>
-            <a:r>
-              <a:rPr lang="en-US" altLang="zh-CN" sz="800" dirty="0">
-                <a:latin typeface="阿里巴巴普惠体 R" panose="00020600040101010101" pitchFamily="18" charset="-122"/>
-                <a:ea typeface="阿里巴巴普惠体 R" panose="00020600040101010101" pitchFamily="18" charset="-122"/>
-                <a:cs typeface="阿里巴巴普惠体 R" panose="00020600040101010101" pitchFamily="18" charset="-122"/>
-              </a:rPr>
-              <a:t>，</a:t>
-            </a:r>
-            <a:r>
-              <a:rPr lang="en-US" altLang="zh-CN" sz="800" b="1" dirty="0">
-                <a:latin typeface="阿里巴巴普惠体 R" panose="00020600040101010101" pitchFamily="18" charset="-122"/>
-                <a:ea typeface="阿里巴巴普惠体 R" panose="00020600040101010101" pitchFamily="18" charset="-122"/>
-                <a:cs typeface="阿里巴巴普惠体 R" panose="00020600040101010101" pitchFamily="18" charset="-122"/>
-              </a:rPr>
-              <a:t>积极</a:t>
-            </a:r>
-            <a:r>
-              <a:rPr lang="en-US" altLang="zh-CN" sz="800" dirty="0">
-                <a:latin typeface="阿里巴巴普惠体 R" panose="00020600040101010101" pitchFamily="18" charset="-122"/>
-                <a:ea typeface="阿里巴巴普惠体 R" panose="00020600040101010101" pitchFamily="18" charset="-122"/>
-                <a:cs typeface="阿里巴巴普惠体 R" panose="00020600040101010101" pitchFamily="18" charset="-122"/>
-              </a:rPr>
-              <a:t>参与开源社区交流分享。业余爱好包括运动、骑行、社交、听音乐与羽毛球，</a:t>
-            </a:r>
-            <a:r>
-              <a:rPr lang="en-US" altLang="zh-CN" sz="800" b="1" dirty="0">
-                <a:latin typeface="阿里巴巴普惠体 R" panose="00020600040101010101" pitchFamily="18" charset="-122"/>
-                <a:ea typeface="阿里巴巴普惠体 R" panose="00020600040101010101" pitchFamily="18" charset="-122"/>
-                <a:cs typeface="阿里巴巴普惠体 R" panose="00020600040101010101" pitchFamily="18" charset="-122"/>
-              </a:rPr>
-              <a:t>注重身心平衡与持续成长。乐于分享技术经验并与团队共同成长</a:t>
-            </a:r>
-            <a:r>
-              <a:rPr lang="en-US" altLang="zh-CN" sz="800" dirty="0">
-                <a:latin typeface="阿里巴巴普惠体 R" panose="00020600040101010101" pitchFamily="18" charset="-122"/>
-                <a:ea typeface="阿里巴巴普惠体 R" panose="00020600040101010101" pitchFamily="18" charset="-122"/>
-                <a:cs typeface="阿里巴巴普惠体 R" panose="00020600040101010101" pitchFamily="18" charset="-122"/>
-              </a:rPr>
-              <a:t>.</a:t>
-            </a:r>
-            <a:endParaRPr lang="en-US" altLang="zh-CN" sz="800" dirty="0">
-              <a:latin typeface="阿里巴巴普惠体 R" panose="00020600040101010101" pitchFamily="18" charset="-122"/>
-              <a:ea typeface="阿里巴巴普惠体 R" panose="00020600040101010101" pitchFamily="18" charset="-122"/>
-              <a:cs typeface="阿里巴巴普惠体 R" panose="00020600040101010101" pitchFamily="18" charset="-122"/>
+                <a:latin typeface="宋体" panose="02010600030101010101" pitchFamily="2" charset="-122"/>
+                <a:ea typeface="宋体" panose="02010600030101010101" pitchFamily="2" charset="-122"/>
+                <a:cs typeface="宋体" panose="02010600030101010101" pitchFamily="2" charset="-122"/>
+              </a:rPr>
+              <a:t> 用户统计：</a:t>
+            </a:r>
+            <a:r>
+              <a:rPr lang="zh-CN" altLang="en-US" sz="800" dirty="0">
+                <a:latin typeface="宋体" panose="02010600030101010101" pitchFamily="2" charset="-122"/>
+                <a:ea typeface="宋体" panose="02010600030101010101" pitchFamily="2" charset="-122"/>
+                <a:cs typeface="宋体" panose="02010600030101010101" pitchFamily="2" charset="-122"/>
+              </a:rPr>
+              <a:t>利用 HyperLogLog 统计独立访客（UV），结合Bitmap 记录用户签到行为，实现社区活跃度分析与数据可视化。</a:t>
+            </a:r>
+            <a:endParaRPr lang="zh-CN" altLang="en-US" sz="800" dirty="0">
+              <a:latin typeface="宋体" panose="02010600030101010101" pitchFamily="2" charset="-122"/>
+              <a:ea typeface="宋体" panose="02010600030101010101" pitchFamily="2" charset="-122"/>
+              <a:cs typeface="宋体" panose="02010600030101010101" pitchFamily="2" charset="-122"/>
             </a:endParaRPr>
           </a:p>
         </p:txBody>
       </p:sp>
+      <p:cxnSp>
+        <p:nvCxnSpPr>
+          <p:cNvPr id="4" name="直接连接符 3"/>
+          <p:cNvCxnSpPr/>
+          <p:nvPr/>
+        </p:nvCxnSpPr>
+        <p:spPr>
+          <a:xfrm>
+            <a:off x="116848" y="200142"/>
+            <a:ext cx="6427236" cy="0"/>
+          </a:xfrm>
+          <a:prstGeom prst="line">
+            <a:avLst/>
+          </a:prstGeom>
+          <a:ln w="9525">
+            <a:solidFill>
+              <a:schemeClr val="accent1">
+                <a:lumMod val="50000"/>
+              </a:schemeClr>
+            </a:solidFill>
+          </a:ln>
+        </p:spPr>
+        <p:style>
+          <a:lnRef idx="1">
+            <a:schemeClr val="accent1"/>
+          </a:lnRef>
+          <a:fillRef idx="0">
+            <a:schemeClr val="accent1"/>
+          </a:fillRef>
+          <a:effectRef idx="0">
+            <a:schemeClr val="accent1"/>
+          </a:effectRef>
+          <a:fontRef idx="minor">
+            <a:schemeClr val="tx1"/>
+          </a:fontRef>
+        </p:style>
+      </p:cxnSp>
     </p:spTree>
   </p:cSld>
   <p:clrMapOvr>

</xml_diff>